<commit_message>
Rebrand the sector brief decks to Middle Market and correct their grammar
The four Q4 2026 decks referred to the team as Benchmark Capital Markets
(BCM). They now use the site's Middle Market naming, the five focus areas
are called sectors, and the "Head of Benchmark Capital Markets" line under
Jordan Houtz is removed so his title matches the site. A proofreading pass
fixed grammar, punctuation, quotation marks, em dashes and serial commas in
the decks themselves; the PDFs and pages are rebuilt from them.

Co-Authored-By: Claude Opus 5.5 <noreply@anthropic.com>
Claude-Session: https://claude.ai/code/session_01BhK2XsdqdQc3W1sm6otL2z
</commit_message>
<xml_diff>
--- a/mid-market-practice/_build/reports/industrial-q4-2026/brief.pptx
+++ b/mid-market-practice/_build/reports/industrial-q4-2026/brief.pptx
@@ -10608,7 +10608,7 @@
                   <a:srgbClr val="D3AE84"/>
                 </a:solidFill>
               </a:rPr>
-              <a:t>BENCHMARK CAPITAL MARKETS</a:t>
+              <a:t>MIDDLE MARKET</a:t>
             </a:r>
             <a:endParaRPr lang="en-US" sz="750" dirty="0"/>
           </a:p>
@@ -10748,7 +10748,7 @@
                 </a:solidFill>
                 <a:latin typeface="+mj-lt" pitchFamily="34" charset="0"/>
               </a:rPr>
-              <a:t>Order books are full, the deal market has become more selective, and buyers are paying the most for power, data center, aerospace and service revenue.</a:t>
+              <a:t>Order books are full, the deal market has become more selective and buyers are paying the most for power, data center, aerospace and service revenue.</a:t>
             </a:r>
             <a:endParaRPr lang="en-US" sz="1500" dirty="0"/>
           </a:p>
@@ -11605,7 +11605,7 @@
                   <a:srgbClr val="D9D2C8"/>
                 </a:solidFill>
               </a:rPr>
-              <a:t>The Benchmark Capital Markets industrial team</a:t>
+              <a:t>The Middle Market industrial team</a:t>
             </a:r>
             <a:endParaRPr lang="en-US" sz="825" dirty="0"/>
           </a:p>
@@ -16853,7 +16853,7 @@
                   <a:srgbClr val="6F6A66"/>
                 </a:solidFill>
               </a:rPr>
-              <a:t>Shares rose at 7 of 7 manufacturing, 8 of 8 distribution, 4 of 8 building, 3 of 8 energy, 7 of 7 transport companies</a:t>
+              <a:t>Shares rose at 7 of 7 manufacturing, 8 of 8 distribution, 4 of 8 building, 3 of 8 energy and 7 of 7 transport companies</a:t>
             </a:r>
             <a:endParaRPr lang="en-US" sz="720" dirty="0"/>
           </a:p>
@@ -17164,7 +17164,7 @@
                   <a:srgbClr val="6F6A66"/>
                 </a:solidFill>
               </a:rPr>
-              <a:t>Capital goods orders are 14% above a year ago, diesel is up 68%, and the 10-year Treasury yield averaged 4.99% in September.</a:t>
+              <a:t>Capital goods orders are 14% above a year ago, diesel is up 68% and the 10-year Treasury yield averaged 4.99% in September.</a:t>
             </a:r>
             <a:endParaRPr lang="en-US" sz="938" dirty="0"/>
           </a:p>
@@ -20224,7 +20224,7 @@
                   <a:srgbClr val="E8E2DA"/>
                 </a:solidFill>
               </a:rPr>
-              <a:t>Benchmark Capital Markets represents owners of privately held companies with $50 million to $500 million of total enterprise value in sales, recapitalizations and growth partnerships. The first step is a confidential conversation about your goals, your company and your options, with no pressure and no commitment.</a:t>
+              <a:t>Benchmark International's Middle Market team represents owners of privately held companies with $50 million to $500 million of total enterprise value in sales, recapitalizations and growth partnerships. The first step is a confidential conversation about your goals, your company and your options, with no pressure and no commitment.</a:t>
             </a:r>
             <a:endParaRPr lang="en-US" sz="1013" dirty="0"/>
           </a:p>
@@ -20731,7 +20731,7 @@
                   <a:srgbClr val="6F6A66"/>
                 </a:solidFill>
               </a:rPr>
-              <a:t>. Team as listed on the Benchmark Capital Markets site in October 2026.</a:t>
+              <a:t>. Team as listed on the Middle Market site in October 2026.</a:t>
             </a:r>
             <a:endParaRPr lang="en-US" sz="675" dirty="0"/>
           </a:p>
@@ -20843,7 +20843,7 @@
                   <a:srgbClr val="333231"/>
                 </a:solidFill>
               </a:rPr>
-              <a:t>Owners considering a sale, a recapitalization or a growth partnership in any of the five industrial segments, and the accountants, attorneys and wealth advisors who work with them, are welcome to call or write. Every engagement is led by the Benchmark Capital Markets team and backed by Benchmark International’s global network of strategic acquirers, private equity groups, family offices and independent sponsors.</a:t>
+              <a:t>Owners considering a sale, a recapitalization or a growth partnership in any of the five industrial segments, and the accountants, attorneys and wealth advisors who work with them, are welcome to call or write. Every engagement is led by the Middle Market team and backed by Benchmark International’s global network of strategic acquirers, private equity groups, family offices and independent sponsors.</a:t>
             </a:r>
             <a:endParaRPr lang="en-US" sz="938" dirty="0"/>
           </a:p>
@@ -21254,7 +21254,7 @@
                   <a:srgbClr val="6F6A66"/>
                 </a:solidFill>
               </a:rPr>
-              <a:t>Head of Benchmark Capital Markets</a:t>
+              <a:t/>
             </a:r>
             <a:endParaRPr lang="en-US" sz="810" dirty="0"/>
           </a:p>
@@ -22241,7 +22241,7 @@
                   <a:srgbClr val="8C6239"/>
                 </a:solidFill>
               </a:rPr>
-              <a:t>BENCHMARK CAPITAL MARKETS</a:t>
+              <a:t>MIDDLE MARKET</a:t>
             </a:r>
             <a:endParaRPr lang="en-US" sz="675" dirty="0"/>
           </a:p>
@@ -23193,7 +23193,7 @@
                   <a:srgbClr val="6F6A66"/>
                 </a:solidFill>
               </a:rPr>
-              <a:t>These disclosures apply to this brief and to the Benchmark Capital Markets sector reports.</a:t>
+              <a:t>These disclosures apply to this brief and to the Middle Market sector reports.</a:t>
             </a:r>
             <a:endParaRPr lang="en-US" sz="938" dirty="0"/>
           </a:p>
@@ -23275,7 +23275,7 @@
                   <a:srgbClr val="333231"/>
                 </a:solidFill>
               </a:rPr>
-              <a:t>“Benchmark International” refers to the Benchmark International group of companies, which provide merger and acquisition advisory services to business owners through offices around the world. Benchmark Capital Markets (BCM) is part of Benchmark International. Any reference to Benchmark International in this material includes its affiliated companies, as the context requires.</a:t>
+              <a:t>“Benchmark International” refers to the Benchmark International group of companies, which provide merger and acquisition advisory services to business owners through offices around the world. The Middle Market team is part of Benchmark International. Any reference to Benchmark International in this material includes its affiliated companies, as the context requires.</a:t>
             </a:r>
             <a:endParaRPr lang="en-US" sz="855" dirty="0"/>
           </a:p>
@@ -25583,7 +25583,7 @@
                   </a:extLst>
                 </a:hlinkClick>
               </a:rPr>
-              <a:t>Benchmark Capital Markets: Industrial M&amp;A Report, Q4 2026</a:t>
+              <a:t>Middle Market: Industrial Q4 2026 M&amp;A Sector Report</a:t>
             </a:r>
             <a:r>
               <a:rPr lang="en-US" sz="720" dirty="0">
@@ -26825,7 +26825,7 @@
                   <a:srgbClr val="6F6A66"/>
                 </a:solidFill>
               </a:rPr>
-              <a:t>Demand is broad, buyers are organized around platforms, and financing became more expensive in September.</a:t>
+              <a:t>Demand is broad, buyers are organized around platforms and financing became more expensive in September.</a:t>
             </a:r>
             <a:endParaRPr lang="en-US" sz="938" dirty="0"/>
           </a:p>
@@ -27821,7 +27821,7 @@
                   <a:srgbClr val="333231"/>
                 </a:solidFill>
               </a:rPr>
-              <a:t>Quanta Services ended June with backlog of $53.4 billion against $35.8 billion a year earlier (</a:t>
+              <a:t>Quanta Services ended June with a backlog of $53.4 billion against $35.8 billion a year earlier (</a:t>
             </a:r>
             <a:r>
               <a:rPr lang="en-US" sz="900" dirty="0">
@@ -28165,7 +28165,7 @@
                   <a:srgbClr val="333231"/>
                 </a:solidFill>
               </a:rPr>
-              <a:t>). Buyers pay for service, repair, inspection and aftermarket parts revenue when an owner reports it separately from project and product sales, with the renewal history behind it.</a:t>
+              <a:t>). Buyers pay more for service, repair, inspection and aftermarket parts revenue when an owner reports it separately from project and product sales, with the renewal history behind it.</a:t>
             </a:r>
             <a:endParaRPr lang="en-US" sz="810" dirty="0"/>
           </a:p>
@@ -28752,7 +28752,7 @@
                   <a:srgbClr val="6F6A66"/>
                 </a:solidFill>
               </a:rPr>
-              <a:t>Electricity demand is growing about 2% a year, the equipment to meet it is sold out years ahead, and acquirers are buying existing capacity.</a:t>
+              <a:t>Electricity demand is growing about 2% a year, the equipment to meet it is sold out years ahead and acquirers are buying existing capacity.</a:t>
             </a:r>
             <a:endParaRPr lang="en-US" sz="938" dirty="0"/>
           </a:p>
@@ -29087,7 +29087,7 @@
           <a:p>
             <a:r>
               <a:rPr lang="en-US" sz="800" i="1" dirty="0"/>
-              <a:t>“So, it’s interesting as they continue to announce all the data centers and data center sites. I’ve sort of always had a strong view that energy would be the constraint” — Greg Abel, CEO, Berkshire Hathaway (</a:t>
+              <a:t>“So, it’s interesting as they continue to announce all the data centers and data center sites. I’ve sort of always had a strong view that energy would be the constraint.” Greg Abel, CEO, Berkshire Hathaway (</a:t>
             </a:r>
             <a:r>
               <a:rPr lang="en-US" sz="800" u="sng" dirty="0">
@@ -29120,17 +29120,17 @@
           <a:p>
             <a:r>
               <a:rPr lang="en-US" sz="800" i="1" dirty="0"/>
-              <a:t>“Well, I don't think it's going to come down to chips or the models that people create or the apps that we develop. I think the consistent theme you hear here is can we get the power generation to power these massive data centers.”  - Toby Rice, CEO, EQT  (</a:t>
+              <a:t>“Well, I don’t think it's going to come down to chips or the models that people create or the apps that we develop. I think the consistent theme you hear here is can we get the power generation to power these massive data centers.” Toby Rice, CEO, EQT (EQT Corporation)</a:t>
             </a:r>
             <a:r>
               <a:rPr lang="en-US" sz="800" u="sng" dirty="0">
                 <a:hlinkClick r:id="rId10"/>
               </a:rPr>
-              <a:t>EQT Corporation</a:t>
+              <a:t/>
             </a:r>
             <a:r>
               <a:rPr lang="en-US" sz="800" u="sng" dirty="0"/>
-              <a:t>)</a:t>
+              <a:t/>
             </a:r>
             <a:endParaRPr lang="en-US" sz="800" dirty="0"/>
           </a:p>
@@ -29145,7 +29145,7 @@
           <a:p>
             <a:r>
               <a:rPr lang="en-US" sz="800" i="1" dirty="0"/>
-              <a:t>“quite frankly, the biggest issue we are now having is not a compute glut, but it's a power and it's sort of the ability to get the builds done fast enough close to power. So, if you can't do that, you may actually have a bunch of chips sitting in inventory that I can't plug in.” — Satya Nadella, CEO, Microsoft (</a:t>
+              <a:t>“quite frankly, the biggest issue we are now having is not a compute glut, but it’s a power and it's sort of the ability to get the builds done fast enough close to power. So, if you can't do that, you may actually have a bunch of chips sitting in inventory that I can’t plug in.” Satya Nadella, CEO, Microsoft (</a:t>
             </a:r>
             <a:r>
               <a:rPr lang="en-US" sz="800" u="sng" dirty="0">
@@ -29355,7 +29355,7 @@
                   <a:srgbClr val="333231"/>
                 </a:solidFill>
               </a:rPr>
-              <a:t>nVent agreed to buy Maverick Power, a Texas maker of switchgear and modular power for data centers, for $1.75 billion plus up to $550 million, which it put at 11.5 times anticipated 2026 adjusted EBITDA on the upfront payment (</a:t>
+              <a:t>nVent agreed to buy Maverick Power, a Texas maker of switchgear and modular power for data centers, for $1.75 billion plus up to $550 million, and put the upfront payment at 11.5 times anticipated 2026 adjusted EBITDA (</a:t>
             </a:r>
             <a:r>
               <a:rPr lang="en-US" sz="795" u="sng" dirty="0">
@@ -32771,7 +32771,7 @@
                   <a:srgbClr val="6F6A66"/>
                 </a:solidFill>
               </a:rPr>
-              <a:t>Head of Benchmark Capital Markets</a:t>
+              <a:t/>
             </a:r>
             <a:endParaRPr lang="en-US" sz="750" dirty="0"/>
           </a:p>
@@ -34970,7 +34970,7 @@
                             <a:srgbClr val="333231"/>
                           </a:solidFill>
                         </a:rPr>
-                        <a:t>Meritus announced at least five acquisitions in 2026, four of them since July, and nearly every product line now has a specialist acquirer of this kind.</a:t>
+                        <a:t>Meritus has announced at least five acquisitions in 2026, four of them since July, and nearly every product line now has a specialist acquirer of this kind.</a:t>
                       </a:r>
                       <a:endParaRPr lang="en-US" sz="1200" dirty="0"/>
                     </a:p>
@@ -35160,7 +35160,7 @@
                             <a:srgbClr val="333231"/>
                           </a:solidFill>
                         </a:rPr>
-                        <a:t>Limbach acquired 1901 Inc., a mechanical, electrical and plumbing contractor in Madison, Wisconsin that it expects to contribute about $140 million of revenue, for $63 million plus an earn-out of up to $6 million (</a:t>
+                        <a:t>Limbach acquired 1901 Inc., a mechanical, electrical and plumbing contractor in Madison, Wisconsin, that it expects to contribute about $140 million of revenue, for $63 million plus an earn-out of up to $6 million (</a:t>
                       </a:r>
                       <a:r>
                         <a:rPr lang="en-US" sz="810" u="sng" dirty="0">
@@ -35832,7 +35832,7 @@
                             <a:srgbClr val="333231"/>
                           </a:solidFill>
                         </a:rPr>
-                        <a:t>Bay Crane acquired Clark Rigging &amp; Rental, a crane rental, rigging and heavy haul company in upstate New York that had been family-owned since 1954 (</a:t>
+                        <a:t>Bay Crane acquired Clark Rigging &amp; Rental, a crane rental, rigging and heavy-haul company in upstate New York that had been family-owned since 1954 (</a:t>
                       </a:r>
                       <a:r>
                         <a:rPr lang="en-US" sz="810" u="sng" dirty="0">
@@ -36160,7 +36160,7 @@
                             <a:srgbClr val="333231"/>
                           </a:solidFill>
                         </a:rPr>
-                        <a:t>The agreement followed Clean Harbors’ $305 million agreement for ES&amp;H, which it described as 8.7 times EBITDA after synergies (</a:t>
+                        <a:t>The agreement followed Clean Harbors’ $305 million deal for ES&amp;H, which it described as 8.7 times EBITDA after synergies (</a:t>
                       </a:r>
                       <a:r>
                         <a:rPr lang="en-US" sz="780" u="sng" dirty="0">
@@ -36919,7 +36919,7 @@
                             <a:srgbClr val="333231"/>
                           </a:solidFill>
                         </a:rPr>
-                        <a:t>Redwood Logistics acquired EELCO, a Laredo, Texas customs brokerage with a foreign-trade-zone warehouse that had been founder-owned since 1991 (</a:t>
+                        <a:t>Redwood Logistics acquired EELCO, a Laredo, Texas, customs brokerage with a foreign-trade-zone warehouse that had been founder-owned since 1991 (</a:t>
                       </a:r>
                       <a:r>
                         <a:rPr lang="en-US" sz="810" u="sng" dirty="0">

</xml_diff>

<commit_message>
Team pages: Middle Market naming, full contact details, Sector Report labels
Co-Authored-By: Claude Sonnet 5.5 <noreply@anthropic.com>
Claude-Session: https://claude.ai/code/session_01Ah1p8V1uKFw8TkFADAuHkz
</commit_message>
<xml_diff>
--- a/mid-market-practice/_build/reports/industrial-q4-2026/brief.pptx
+++ b/mid-market-practice/_build/reports/industrial-q4-2026/brief.pptx
@@ -9605,7 +9605,7 @@
                   <a:srgbClr val="8C6239"/>
                 </a:solidFill>
               </a:rPr>
-              <a:t>INDUSTRIAL  |  QUARTERLY SECTOR BRIEF</a:t>
+              <a:t>INDUSTRIAL  |  SECTOR REPORT</a:t>
             </a:r>
             <a:endParaRPr lang="en-US" sz="675" dirty="0"/>
           </a:p>
@@ -10013,7 +10013,7 @@
                   <a:srgbClr val="D3AE84"/>
                 </a:solidFill>
               </a:rPr>
-              <a:t>BENCHMARK CAPITAL MARKETS</a:t>
+              <a:t>MIDDLE MARKET</a:t>
             </a:r>
             <a:endParaRPr lang="en-US" sz="638" dirty="0"/>
           </a:p>
@@ -10049,7 +10049,7 @@
                   <a:srgbClr val="D3AE84"/>
                 </a:solidFill>
               </a:rPr>
-              <a:t>INDUSTRIAL  |  QUARTERLY SECTOR BRIEF  |  Q4 2026</a:t>
+              <a:t>INDUSTRIAL  |  SECTOR REPORT  |  Q4 2026</a:t>
             </a:r>
             <a:endParaRPr lang="en-US" sz="675" dirty="0"/>
           </a:p>
@@ -10608,7 +10608,7 @@
                   <a:srgbClr val="D3AE84"/>
                 </a:solidFill>
               </a:rPr>
-              <a:t>BENCHMARK CAPITAL MARKETS</a:t>
+              <a:t>MIDDLE MARKET</a:t>
             </a:r>
             <a:endParaRPr lang="en-US" sz="750" dirty="0"/>
           </a:p>
@@ -10644,7 +10644,7 @@
                   <a:srgbClr val="D3AE84"/>
                 </a:solidFill>
               </a:rPr>
-              <a:t>QUARTERLY SECTOR BRIEF  |  Q4 2026</a:t>
+              <a:t>SECTOR REPORT  |  Q4 2026</a:t>
             </a:r>
             <a:endParaRPr lang="en-US" sz="825" dirty="0"/>
           </a:p>
@@ -11605,7 +11605,7 @@
                   <a:srgbClr val="D9D2C8"/>
                 </a:solidFill>
               </a:rPr>
-              <a:t>The Benchmark Capital Markets industrial team</a:t>
+              <a:t>The Middle Market industrial team</a:t>
             </a:r>
             <a:endParaRPr lang="en-US" sz="825" dirty="0"/>
           </a:p>
@@ -20224,7 +20224,7 @@
                   <a:srgbClr val="E8E2DA"/>
                 </a:solidFill>
               </a:rPr>
-              <a:t>Benchmark Capital Markets represents owners of privately held companies with $50 million to $500 million of total enterprise value in sales, recapitalizations and growth partnerships. The first step is a confidential conversation about your goals, your company and your options, with no pressure and no commitment.</a:t>
+              <a:t>Middle Market represents owners of privately held companies with $50 million to $500 million of total enterprise value in sales, recapitalizations and growth partnerships. The first step is a confidential conversation about your goals, your company and your options, with no pressure and no commitment.</a:t>
             </a:r>
             <a:endParaRPr lang="en-US" sz="1013" dirty="0"/>
           </a:p>
@@ -20731,7 +20731,7 @@
                   <a:srgbClr val="6F6A66"/>
                 </a:solidFill>
               </a:rPr>
-              <a:t>. Team as listed on the Benchmark Capital Markets site in October 2026.</a:t>
+              <a:t>. Team as listed on the Middle Market site in October 2026.</a:t>
             </a:r>
             <a:endParaRPr lang="en-US" sz="675" dirty="0"/>
           </a:p>
@@ -20843,7 +20843,7 @@
                   <a:srgbClr val="333231"/>
                 </a:solidFill>
               </a:rPr>
-              <a:t>Owners considering a sale, a recapitalization or a growth partnership in any of the five industrial segments, and the accountants, attorneys and wealth advisors who work with them, are welcome to call or write. Every engagement is led by the Benchmark Capital Markets team and backed by Benchmark International’s global network of strategic acquirers, private equity groups, family offices and independent sponsors.</a:t>
+              <a:t>Owners considering a sale, a recapitalization or a growth partnership in any of the five industrial segments, and the accountants, attorneys and wealth advisors who work with them, are welcome to call or write. Every engagement is led by the Middle Market team and backed by Benchmark International’s global network of strategic acquirers, private equity groups, family offices and independent sponsors.</a:t>
             </a:r>
             <a:endParaRPr lang="en-US" sz="938" dirty="0"/>
           </a:p>
@@ -21002,76 +21002,6 @@
       </p:sp>
       <p:sp>
         <p:nvSpPr>
-          <p:cNvPr id="13" name="Text 10"/>
-          <p:cNvSpPr txBox="1"/>
-          <p:nvPr/>
-        </p:nvSpPr>
-        <p:spPr>
-          <a:xfrm>
-            <a:off x="1504950" y="3581400"/>
-            <a:ext cx="1790700" cy="381000"/>
-          </a:xfrm>
-          <a:prstGeom prst="rect">
-            <a:avLst/>
-          </a:prstGeom>
-          <a:noFill/>
-          <a:ln/>
-        </p:spPr>
-        <p:txBody>
-          <a:bodyPr wrap="square" lIns="0" tIns="0" rIns="0" bIns="0" rtlCol="0" anchor="t"/>
-          <a:lstStyle/>
-          <a:p>
-            <a:pPr marL="0" indent="0">
-              <a:lnSpc>
-                <a:spcPts val="1125"/>
-              </a:lnSpc>
-              <a:buNone/>
-            </a:pPr>
-            <a:r>
-              <a:rPr lang="en-US" sz="810" u="sng" dirty="0">
-                <a:solidFill>
-                  <a:srgbClr val="8C6239"/>
-                </a:solidFill>
-                <a:hlinkClick r:id="rId5">
-                  <a:extLst>
-                    <a:ext uri="{A12FA001-AC4F-418D-AE19-62706E023703}">
-                      <ahyp:hlinkClr xmlns:ahyp="http://schemas.microsoft.com/office/drawing/2018/hyperlinkcolor" val="tx"/>
-                    </a:ext>
-                  </a:extLst>
-                </a:hlinkClick>
-              </a:rPr>
-              <a:t>813-771-6675</a:t>
-            </a:r>
-            <a:endParaRPr lang="en-US" sz="810" dirty="0"/>
-          </a:p>
-          <a:p>
-            <a:pPr marL="0" indent="0">
-              <a:lnSpc>
-                <a:spcPts val="1125"/>
-              </a:lnSpc>
-              <a:buNone/>
-            </a:pPr>
-            <a:r>
-              <a:rPr lang="en-US" sz="810" u="sng" dirty="0">
-                <a:solidFill>
-                  <a:srgbClr val="8C6239"/>
-                </a:solidFill>
-                <a:hlinkClick r:id="rId6">
-                  <a:extLst>
-                    <a:ext uri="{A12FA001-AC4F-418D-AE19-62706E023703}">
-                      <ahyp:hlinkClr xmlns:ahyp="http://schemas.microsoft.com/office/drawing/2018/hyperlinkcolor" val="tx"/>
-                    </a:ext>
-                  </a:extLst>
-                </a:hlinkClick>
-              </a:rPr>
-              <a:t>j.hardin@benchmarkintl.com</a:t>
-            </a:r>
-            <a:endParaRPr lang="en-US" sz="810" dirty="0"/>
-          </a:p>
-        </p:txBody>
-      </p:sp>
-      <p:sp>
-        <p:nvSpPr>
           <p:cNvPr id="14" name="Jordan Houtz card"/>
           <p:cNvSpPr/>
           <p:nvPr/>
@@ -21223,45 +21153,6 @@
       </p:sp>
       <p:sp>
         <p:nvSpPr>
-          <p:cNvPr id="19" name="Text 15"/>
-          <p:cNvSpPr txBox="1"/>
-          <p:nvPr/>
-        </p:nvSpPr>
-        <p:spPr>
-          <a:xfrm>
-            <a:off x="4591050" y="3581400"/>
-            <a:ext cx="1790700" cy="381000"/>
-          </a:xfrm>
-          <a:prstGeom prst="rect">
-            <a:avLst/>
-          </a:prstGeom>
-          <a:noFill/>
-          <a:ln/>
-        </p:spPr>
-        <p:txBody>
-          <a:bodyPr wrap="square" lIns="0" tIns="0" rIns="0" bIns="0" rtlCol="0" anchor="t"/>
-          <a:lstStyle/>
-          <a:p>
-            <a:pPr marL="0" indent="0">
-              <a:lnSpc>
-                <a:spcPts val="1125"/>
-              </a:lnSpc>
-              <a:buNone/>
-            </a:pPr>
-            <a:r>
-              <a:rPr lang="en-US" sz="810" dirty="0">
-                <a:solidFill>
-                  <a:srgbClr val="6F6A66"/>
-                </a:solidFill>
-              </a:rPr>
-              <a:t>Head of Benchmark Capital Markets</a:t>
-            </a:r>
-            <a:endParaRPr lang="en-US" sz="810" dirty="0"/>
-          </a:p>
-        </p:txBody>
-      </p:sp>
-      <p:sp>
-        <p:nvSpPr>
           <p:cNvPr id="20" name="Alex Zykov card"/>
           <p:cNvSpPr/>
           <p:nvPr/>
@@ -21413,45 +21304,6 @@
       </p:sp>
       <p:sp>
         <p:nvSpPr>
-          <p:cNvPr id="25" name="Text 20"/>
-          <p:cNvSpPr txBox="1"/>
-          <p:nvPr/>
-        </p:nvSpPr>
-        <p:spPr>
-          <a:xfrm>
-            <a:off x="1504950" y="4743450"/>
-            <a:ext cx="1790700" cy="381000"/>
-          </a:xfrm>
-          <a:prstGeom prst="rect">
-            <a:avLst/>
-          </a:prstGeom>
-          <a:noFill/>
-          <a:ln/>
-        </p:spPr>
-        <p:txBody>
-          <a:bodyPr wrap="square" lIns="0" tIns="0" rIns="0" bIns="0" rtlCol="0" anchor="t"/>
-          <a:lstStyle/>
-          <a:p>
-            <a:pPr marL="0" indent="0">
-              <a:lnSpc>
-                <a:spcPts val="1125"/>
-              </a:lnSpc>
-              <a:buNone/>
-            </a:pPr>
-            <a:r>
-              <a:rPr lang="en-US" sz="810" dirty="0">
-                <a:solidFill>
-                  <a:srgbClr val="6F6A66"/>
-                </a:solidFill>
-              </a:rPr>
-              <a:t>Leads execution from onboarding through signing and closing</a:t>
-            </a:r>
-            <a:endParaRPr lang="en-US" sz="810" dirty="0"/>
-          </a:p>
-        </p:txBody>
-      </p:sp>
-      <p:sp>
-        <p:nvSpPr>
           <p:cNvPr id="26" name="Shannon Hess card"/>
           <p:cNvSpPr/>
           <p:nvPr/>
@@ -21598,45 +21450,6 @@
               <a:t>CLIENT ENGAGEMENT DIRECTOR</a:t>
             </a:r>
             <a:endParaRPr lang="en-US" sz="638" dirty="0"/>
-          </a:p>
-        </p:txBody>
-      </p:sp>
-      <p:sp>
-        <p:nvSpPr>
-          <p:cNvPr id="31" name="Text 25"/>
-          <p:cNvSpPr txBox="1"/>
-          <p:nvPr/>
-        </p:nvSpPr>
-        <p:spPr>
-          <a:xfrm>
-            <a:off x="4591050" y="4743450"/>
-            <a:ext cx="1790700" cy="381000"/>
-          </a:xfrm>
-          <a:prstGeom prst="rect">
-            <a:avLst/>
-          </a:prstGeom>
-          <a:noFill/>
-          <a:ln/>
-        </p:spPr>
-        <p:txBody>
-          <a:bodyPr wrap="square" lIns="0" tIns="0" rIns="0" bIns="0" rtlCol="0" anchor="t"/>
-          <a:lstStyle/>
-          <a:p>
-            <a:pPr marL="0" indent="0">
-              <a:lnSpc>
-                <a:spcPts val="1125"/>
-              </a:lnSpc>
-              <a:buNone/>
-            </a:pPr>
-            <a:r>
-              <a:rPr lang="en-US" sz="810" dirty="0">
-                <a:solidFill>
-                  <a:srgbClr val="6F6A66"/>
-                </a:solidFill>
-              </a:rPr>
-              <a:t>An additional point of contact for owners considering an engagement</a:t>
-            </a:r>
-            <a:endParaRPr lang="en-US" sz="810" dirty="0"/>
           </a:p>
         </p:txBody>
       </p:sp>
@@ -22241,7 +22054,7 @@
                   <a:srgbClr val="8C6239"/>
                 </a:solidFill>
               </a:rPr>
-              <a:t>BENCHMARK CAPITAL MARKETS</a:t>
+              <a:t>MIDDLE MARKET</a:t>
             </a:r>
             <a:endParaRPr lang="en-US" sz="675" dirty="0"/>
           </a:p>
@@ -23091,6 +22904,403 @@
               <a:t>15</a:t>
             </a:fld>
             <a:endParaRPr lang="en-US"/>
+          </a:p>
+        </p:txBody>
+      </p:sp>
+      <p:sp>
+        <p:nvSpPr>
+          <p:cNvPr id="72" name="Contact Jared Hardin"/>
+          <p:cNvSpPr txBox="1"/>
+          <p:nvPr/>
+        </p:nvSpPr>
+        <p:spPr>
+          <a:xfrm>
+            <a:off x="1508760" y="3593592"/>
+            <a:ext cx="1792224" cy="370332"/>
+          </a:xfrm>
+          <a:prstGeom prst="rect">
+            <a:avLst/>
+          </a:prstGeom>
+          <a:noFill/>
+        </p:spPr>
+        <p:txBody>
+          <a:bodyPr wrap="square" lIns="0" tIns="0" rIns="0" bIns="0" anchor="t">
+            <a:spAutoFit/>
+          </a:bodyPr>
+          <a:lstStyle/>
+          <a:p>
+            <a:pPr algn="l" indent="0" marL="0">
+              <a:lnSpc>
+                <a:spcPts val="972"/>
+              </a:lnSpc>
+              <a:buNone/>
+            </a:pPr>
+            <a:r>
+              <a:rPr lang="en-US" sz="750" dirty="0" u="sng">
+                <a:solidFill>
+                  <a:srgbClr val="8C6239"/>
+                </a:solidFill>
+                <a:latin typeface="+mn-lt" pitchFamily="34" charset="0"/>
+                <a:hlinkClick r:id="rId5">
+                  <a:extLst>
+                    <a:ext uri="{A12FA001-AC4F-418D-AE19-62706E023703}">
+                      <ahyp:hlinkClr xmlns:ahyp="http://schemas.microsoft.com/office/drawing/2018/hyperlinkcolor" val="tx"/>
+                    </a:ext>
+                  </a:extLst>
+                </a:hlinkClick>
+              </a:rPr>
+              <a:t>813-771-6675</a:t>
+            </a:r>
+          </a:p>
+          <a:p>
+            <a:pPr algn="l" indent="0" marL="0">
+              <a:lnSpc>
+                <a:spcPts val="972"/>
+              </a:lnSpc>
+              <a:buNone/>
+            </a:pPr>
+            <a:r>
+              <a:rPr lang="en-US" sz="750" dirty="0" u="sng">
+                <a:solidFill>
+                  <a:srgbClr val="8C6239"/>
+                </a:solidFill>
+                <a:latin typeface="+mn-lt" pitchFamily="34" charset="0"/>
+                <a:hlinkClick r:id="rId6">
+                  <a:extLst>
+                    <a:ext uri="{A12FA001-AC4F-418D-AE19-62706E023703}">
+                      <ahyp:hlinkClr xmlns:ahyp="http://schemas.microsoft.com/office/drawing/2018/hyperlinkcolor" val="tx"/>
+                    </a:ext>
+                  </a:extLst>
+                </a:hlinkClick>
+              </a:rPr>
+              <a:t>j.hardin@benchmarkintl.com</a:t>
+            </a:r>
+          </a:p>
+          <a:p>
+            <a:pPr algn="l" indent="0" marL="0">
+              <a:lnSpc>
+                <a:spcPts val="972"/>
+              </a:lnSpc>
+              <a:buNone/>
+            </a:pPr>
+            <a:r>
+              <a:rPr lang="en-US" sz="750" dirty="0" u="sng">
+                <a:solidFill>
+                  <a:srgbClr val="8C6239"/>
+                </a:solidFill>
+                <a:latin typeface="+mn-lt" pitchFamily="34" charset="0"/>
+                <a:hlinkClick r:id="rId17">
+                  <a:extLst>
+                    <a:ext uri="{A12FA001-AC4F-418D-AE19-62706E023703}">
+                      <ahyp:hlinkClr xmlns:ahyp="http://schemas.microsoft.com/office/drawing/2018/hyperlinkcolor" val="tx"/>
+                    </a:ext>
+                  </a:extLst>
+                </a:hlinkClick>
+              </a:rPr>
+              <a:t>LinkedIn</a:t>
+            </a:r>
+          </a:p>
+        </p:txBody>
+      </p:sp>
+      <p:sp>
+        <p:nvSpPr>
+          <p:cNvPr id="73" name="Contact Jordan Houtz"/>
+          <p:cNvSpPr txBox="1"/>
+          <p:nvPr/>
+        </p:nvSpPr>
+        <p:spPr>
+          <a:xfrm>
+            <a:off x="4590288" y="3593592"/>
+            <a:ext cx="1792224" cy="493776"/>
+          </a:xfrm>
+          <a:prstGeom prst="rect">
+            <a:avLst/>
+          </a:prstGeom>
+          <a:noFill/>
+        </p:spPr>
+        <p:txBody>
+          <a:bodyPr wrap="square" lIns="0" tIns="0" rIns="0" bIns="0" anchor="t">
+            <a:spAutoFit/>
+          </a:bodyPr>
+          <a:lstStyle/>
+          <a:p>
+            <a:pPr algn="l" indent="0" marL="0">
+              <a:lnSpc>
+                <a:spcPts val="972"/>
+              </a:lnSpc>
+              <a:buNone/>
+            </a:pPr>
+            <a:r>
+              <a:rPr lang="en-US" sz="750" dirty="0">
+                <a:solidFill>
+                  <a:srgbClr val="6F6A66"/>
+                </a:solidFill>
+                <a:latin typeface="+mn-lt" pitchFamily="34" charset="0"/>
+              </a:rPr>
+              <a:t>Head of Middle Market</a:t>
+            </a:r>
+          </a:p>
+          <a:p>
+            <a:pPr algn="l" indent="0" marL="0">
+              <a:lnSpc>
+                <a:spcPts val="972"/>
+              </a:lnSpc>
+              <a:buNone/>
+            </a:pPr>
+            <a:r>
+              <a:rPr lang="en-US" sz="750" dirty="0" u="sng">
+                <a:solidFill>
+                  <a:srgbClr val="8C6239"/>
+                </a:solidFill>
+                <a:latin typeface="+mn-lt" pitchFamily="34" charset="0"/>
+                <a:hlinkClick r:id="rId5">
+                  <a:extLst>
+                    <a:ext uri="{A12FA001-AC4F-418D-AE19-62706E023703}">
+                      <ahyp:hlinkClr xmlns:ahyp="http://schemas.microsoft.com/office/drawing/2018/hyperlinkcolor" val="tx"/>
+                    </a:ext>
+                  </a:extLst>
+                </a:hlinkClick>
+              </a:rPr>
+              <a:t>813-771-6675 (team line)</a:t>
+            </a:r>
+          </a:p>
+          <a:p>
+            <a:pPr algn="l" indent="0" marL="0">
+              <a:lnSpc>
+                <a:spcPts val="972"/>
+              </a:lnSpc>
+              <a:buNone/>
+            </a:pPr>
+            <a:r>
+              <a:rPr lang="en-US" sz="750" dirty="0" u="sng">
+                <a:solidFill>
+                  <a:srgbClr val="8C6239"/>
+                </a:solidFill>
+                <a:latin typeface="+mn-lt" pitchFamily="34" charset="0"/>
+                <a:hlinkClick r:id="rId18">
+                  <a:extLst>
+                    <a:ext uri="{A12FA001-AC4F-418D-AE19-62706E023703}">
+                      <ahyp:hlinkClr xmlns:ahyp="http://schemas.microsoft.com/office/drawing/2018/hyperlinkcolor" val="tx"/>
+                    </a:ext>
+                  </a:extLst>
+                </a:hlinkClick>
+              </a:rPr>
+              <a:t>jhoutz@benchmarkintl.com</a:t>
+            </a:r>
+          </a:p>
+          <a:p>
+            <a:pPr algn="l" indent="0" marL="0">
+              <a:lnSpc>
+                <a:spcPts val="972"/>
+              </a:lnSpc>
+              <a:buNone/>
+            </a:pPr>
+            <a:r>
+              <a:rPr lang="en-US" sz="750" dirty="0" u="sng">
+                <a:solidFill>
+                  <a:srgbClr val="8C6239"/>
+                </a:solidFill>
+                <a:latin typeface="+mn-lt" pitchFamily="34" charset="0"/>
+                <a:hlinkClick r:id="rId19">
+                  <a:extLst>
+                    <a:ext uri="{A12FA001-AC4F-418D-AE19-62706E023703}">
+                      <ahyp:hlinkClr xmlns:ahyp="http://schemas.microsoft.com/office/drawing/2018/hyperlinkcolor" val="tx"/>
+                    </a:ext>
+                  </a:extLst>
+                </a:hlinkClick>
+              </a:rPr>
+              <a:t>LinkedIn</a:t>
+            </a:r>
+          </a:p>
+        </p:txBody>
+      </p:sp>
+      <p:sp>
+        <p:nvSpPr>
+          <p:cNvPr id="74" name="Contact Alex Zykov"/>
+          <p:cNvSpPr txBox="1"/>
+          <p:nvPr/>
+        </p:nvSpPr>
+        <p:spPr>
+          <a:xfrm>
+            <a:off x="1508760" y="4754880"/>
+            <a:ext cx="1792224" cy="370332"/>
+          </a:xfrm>
+          <a:prstGeom prst="rect">
+            <a:avLst/>
+          </a:prstGeom>
+          <a:noFill/>
+        </p:spPr>
+        <p:txBody>
+          <a:bodyPr wrap="square" lIns="0" tIns="0" rIns="0" bIns="0" anchor="t">
+            <a:spAutoFit/>
+          </a:bodyPr>
+          <a:lstStyle/>
+          <a:p>
+            <a:pPr algn="l" indent="0" marL="0">
+              <a:lnSpc>
+                <a:spcPts val="972"/>
+              </a:lnSpc>
+              <a:buNone/>
+            </a:pPr>
+            <a:r>
+              <a:rPr lang="en-US" sz="750" dirty="0" u="sng">
+                <a:solidFill>
+                  <a:srgbClr val="8C6239"/>
+                </a:solidFill>
+                <a:latin typeface="+mn-lt" pitchFamily="34" charset="0"/>
+                <a:hlinkClick r:id="rId20">
+                  <a:extLst>
+                    <a:ext uri="{A12FA001-AC4F-418D-AE19-62706E023703}">
+                      <ahyp:hlinkClr xmlns:ahyp="http://schemas.microsoft.com/office/drawing/2018/hyperlinkcolor" val="tx"/>
+                    </a:ext>
+                  </a:extLst>
+                </a:hlinkClick>
+              </a:rPr>
+              <a:t>813-898-2372</a:t>
+            </a:r>
+          </a:p>
+          <a:p>
+            <a:pPr algn="l" indent="0" marL="0">
+              <a:lnSpc>
+                <a:spcPts val="972"/>
+              </a:lnSpc>
+              <a:buNone/>
+            </a:pPr>
+            <a:r>
+              <a:rPr lang="en-US" sz="750" dirty="0" u="sng">
+                <a:solidFill>
+                  <a:srgbClr val="8C6239"/>
+                </a:solidFill>
+                <a:latin typeface="+mn-lt" pitchFamily="34" charset="0"/>
+                <a:hlinkClick r:id="rId21">
+                  <a:extLst>
+                    <a:ext uri="{A12FA001-AC4F-418D-AE19-62706E023703}">
+                      <ahyp:hlinkClr xmlns:ahyp="http://schemas.microsoft.com/office/drawing/2018/hyperlinkcolor" val="tx"/>
+                    </a:ext>
+                  </a:extLst>
+                </a:hlinkClick>
+              </a:rPr>
+              <a:t>azykov@benchmarkintl.com</a:t>
+            </a:r>
+          </a:p>
+          <a:p>
+            <a:pPr algn="l" indent="0" marL="0">
+              <a:lnSpc>
+                <a:spcPts val="972"/>
+              </a:lnSpc>
+              <a:buNone/>
+            </a:pPr>
+            <a:r>
+              <a:rPr lang="en-US" sz="750" dirty="0" u="sng">
+                <a:solidFill>
+                  <a:srgbClr val="8C6239"/>
+                </a:solidFill>
+                <a:latin typeface="+mn-lt" pitchFamily="34" charset="0"/>
+                <a:hlinkClick r:id="rId22">
+                  <a:extLst>
+                    <a:ext uri="{A12FA001-AC4F-418D-AE19-62706E023703}">
+                      <ahyp:hlinkClr xmlns:ahyp="http://schemas.microsoft.com/office/drawing/2018/hyperlinkcolor" val="tx"/>
+                    </a:ext>
+                  </a:extLst>
+                </a:hlinkClick>
+              </a:rPr>
+              <a:t>LinkedIn</a:t>
+            </a:r>
+          </a:p>
+        </p:txBody>
+      </p:sp>
+      <p:sp>
+        <p:nvSpPr>
+          <p:cNvPr id="75" name="Contact Shannon Hess"/>
+          <p:cNvSpPr txBox="1"/>
+          <p:nvPr/>
+        </p:nvSpPr>
+        <p:spPr>
+          <a:xfrm>
+            <a:off x="4590288" y="4754880"/>
+            <a:ext cx="1792224" cy="370332"/>
+          </a:xfrm>
+          <a:prstGeom prst="rect">
+            <a:avLst/>
+          </a:prstGeom>
+          <a:noFill/>
+        </p:spPr>
+        <p:txBody>
+          <a:bodyPr wrap="square" lIns="0" tIns="0" rIns="0" bIns="0" anchor="t">
+            <a:spAutoFit/>
+          </a:bodyPr>
+          <a:lstStyle/>
+          <a:p>
+            <a:pPr algn="l" indent="0" marL="0">
+              <a:lnSpc>
+                <a:spcPts val="972"/>
+              </a:lnSpc>
+              <a:buNone/>
+            </a:pPr>
+            <a:r>
+              <a:rPr lang="en-US" sz="750" dirty="0" u="sng">
+                <a:solidFill>
+                  <a:srgbClr val="8C6239"/>
+                </a:solidFill>
+                <a:latin typeface="+mn-lt" pitchFamily="34" charset="0"/>
+                <a:hlinkClick r:id="rId23">
+                  <a:extLst>
+                    <a:ext uri="{A12FA001-AC4F-418D-AE19-62706E023703}">
+                      <ahyp:hlinkClr xmlns:ahyp="http://schemas.microsoft.com/office/drawing/2018/hyperlinkcolor" val="tx"/>
+                    </a:ext>
+                  </a:extLst>
+                </a:hlinkClick>
+              </a:rPr>
+              <a:t>813-898-2397</a:t>
+            </a:r>
+          </a:p>
+          <a:p>
+            <a:pPr algn="l" indent="0" marL="0">
+              <a:lnSpc>
+                <a:spcPts val="972"/>
+              </a:lnSpc>
+              <a:buNone/>
+            </a:pPr>
+            <a:r>
+              <a:rPr lang="en-US" sz="750" dirty="0" u="sng">
+                <a:solidFill>
+                  <a:srgbClr val="8C6239"/>
+                </a:solidFill>
+                <a:latin typeface="+mn-lt" pitchFamily="34" charset="0"/>
+                <a:hlinkClick r:id="rId24">
+                  <a:extLst>
+                    <a:ext uri="{A12FA001-AC4F-418D-AE19-62706E023703}">
+                      <ahyp:hlinkClr xmlns:ahyp="http://schemas.microsoft.com/office/drawing/2018/hyperlinkcolor" val="tx"/>
+                    </a:ext>
+                  </a:extLst>
+                </a:hlinkClick>
+              </a:rPr>
+              <a:t>hess@benchmarkintl.com</a:t>
+            </a:r>
+          </a:p>
+          <a:p>
+            <a:pPr algn="l" indent="0" marL="0">
+              <a:lnSpc>
+                <a:spcPts val="972"/>
+              </a:lnSpc>
+              <a:buNone/>
+            </a:pPr>
+            <a:r>
+              <a:rPr lang="en-US" sz="750" dirty="0" u="sng">
+                <a:solidFill>
+                  <a:srgbClr val="8C6239"/>
+                </a:solidFill>
+                <a:latin typeface="+mn-lt" pitchFamily="34" charset="0"/>
+                <a:hlinkClick r:id="rId25">
+                  <a:extLst>
+                    <a:ext uri="{A12FA001-AC4F-418D-AE19-62706E023703}">
+                      <ahyp:hlinkClr xmlns:ahyp="http://schemas.microsoft.com/office/drawing/2018/hyperlinkcolor" val="tx"/>
+                    </a:ext>
+                  </a:extLst>
+                </a:hlinkClick>
+              </a:rPr>
+              <a:t>LinkedIn</a:t>
+            </a:r>
           </a:p>
         </p:txBody>
       </p:sp>
@@ -23193,7 +23403,7 @@
                   <a:srgbClr val="6F6A66"/>
                 </a:solidFill>
               </a:rPr>
-              <a:t>These disclosures apply to this brief and to the Benchmark Capital Markets sector reports.</a:t>
+              <a:t>These disclosures apply to this report and to the Middle Market sector reports.</a:t>
             </a:r>
             <a:endParaRPr lang="en-US" sz="938" dirty="0"/>
           </a:p>
@@ -23233,7 +23443,7 @@
                   <a:srgbClr val="6F6A66"/>
                 </a:solidFill>
               </a:rPr>
-              <a:t>Information in this brief is as of October 7, 2026 unless stated otherwise.</a:t>
+              <a:t>Information in this report is as of October 7, 2026 unless stated otherwise.</a:t>
             </a:r>
             <a:endParaRPr lang="en-US" sz="675" dirty="0"/>
           </a:p>
@@ -23275,7 +23485,7 @@
                   <a:srgbClr val="333231"/>
                 </a:solidFill>
               </a:rPr>
-              <a:t>“Benchmark International” refers to the Benchmark International group of companies, which provide merger and acquisition advisory services to business owners through offices around the world. Benchmark Capital Markets (BCM) is part of Benchmark International. Any reference to Benchmark International in this material includes its affiliated companies, as the context requires.</a:t>
+              <a:t>“Benchmark International” refers to the Benchmark International group of companies, which provide merger and acquisition advisory services to business owners through offices around the world. Middle Market is part of Benchmark International. Any reference to Benchmark International in this material includes its affiliated companies, as the context requires.</a:t>
             </a:r>
             <a:endParaRPr lang="en-US" sz="855" dirty="0"/>
           </a:p>
@@ -23547,7 +23757,7 @@
                   <a:srgbClr val="6F6A66"/>
                 </a:solidFill>
               </a:rPr>
-              <a:t>Every figure in this brief links to the page it came from, and the same links are collected here by section.</a:t>
+              <a:t>Every figure in this report links to the page it came from, and the same links are collected here by section.</a:t>
             </a:r>
             <a:endParaRPr lang="en-US" sz="938" dirty="0"/>
           </a:p>
@@ -25583,7 +25793,7 @@
                   </a:extLst>
                 </a:hlinkClick>
               </a:rPr>
-              <a:t>Benchmark Capital Markets: Industrial M&amp;A Report, Q4 2026</a:t>
+              <a:t>Middle Market: Industrial M&amp;A Report, Q4 2026</a:t>
             </a:r>
             <a:r>
               <a:rPr lang="en-US" sz="720" dirty="0">
@@ -32771,7 +32981,7 @@
                   <a:srgbClr val="6F6A66"/>
                 </a:solidFill>
               </a:rPr>
-              <a:t>Head of Benchmark Capital Markets</a:t>
+              <a:t>Head of Middle Market</a:t>
             </a:r>
             <a:endParaRPr lang="en-US" sz="750" dirty="0"/>
           </a:p>

</xml_diff>

<commit_message>
Drop "full report" references from the sector briefs and finish cover sentences
The briefs are now the reports, so the decks no longer point readers to a
separate full report: the Connect page buttons read "Read the report online"
and the notes and source lists that mentioned the full report are trimmed.
The Healthcare and Business Services cover sentences end with a period. The
PDFs, pages, Markdown copies and Insights summaries are rebuilt from the decks.

Co-Authored-By: Claude Opus 5.5 <noreply@anthropic.com>
Claude-Session: https://claude.ai/code/session_01BhK2XsdqdQc3W1sm6otL2z
</commit_message>
<xml_diff>
--- a/mid-market-practice/_build/reports/industrial-q4-2026/brief.pptx
+++ b/mid-market-practice/_build/reports/industrial-q4-2026/brief.pptx
@@ -22154,7 +22154,7 @@
                   </a:extLst>
                 </a:hlinkClick>
               </a:rPr>
-              <a:t>READ THE FULL Q4 2026 INDUSTRIAL REPORT</a:t>
+              <a:t>READ THE REPORT ONLINE</a:t>
             </a:r>
             <a:endParaRPr lang="en-US" sz="713" dirty="0"/>
           </a:p>
@@ -23587,7 +23587,7 @@
                   <a:srgbClr val="6F6A66"/>
                 </a:solidFill>
               </a:rPr>
-              <a:t>Figures were gathered from these sources between October 2 and October 7, 2026. The full Q4 2026 Industrial report carries the longer source list behind the five segment chapters.</a:t>
+              <a:t>Figures were gathered from these sources between October 2 and October 7, 2026.</a:t>
             </a:r>
             <a:endParaRPr lang="en-US" sz="675" dirty="0"/>
           </a:p>

</xml_diff>

<commit_message>
Add every team member's contact details to the sector briefs
Healthcare and Business Services: phone and email under each of the four
leaders and each of the six associates on the team page, and the "upcoming
event" placeholder panel removed from the Connect page. Industrial: contact
lines on all four leader cards and a new Our Team page (page 16) with the
whole team and their details; the Connect With Us list and page numbers
follow. Jared Hardin's title reads Managing Director everywhere, and the
Industrial divider footer now says Middle Market. Contacts and titles come
from the site's team data. PDFs, pages and Markdown copies are rebuilt.

Co-Authored-By: Claude Opus 5.5 <noreply@anthropic.com>
Claude-Session: https://claude.ai/code/session_01BhK2XsdqdQc3W1sm6otL2z
</commit_message>
<xml_diff>
--- a/mid-market-practice/_build/reports/industrial-q4-2026/brief.pptx
+++ b/mid-market-practice/_build/reports/industrial-q4-2026/brief.pptx
@@ -23,6 +23,7 @@
     <p:sldId id="268" r:id="rId14"/>
     <p:sldId id="269" r:id="rId15"/>
     <p:sldId id="270" r:id="rId16"/>
+    <p:sldId id="273" r:id="rId24"/>
     <p:sldId id="271" r:id="rId17"/>
     <p:sldId id="272" r:id="rId18"/>
   </p:sldIdLst>
@@ -10013,7 +10014,7 @@
                   <a:srgbClr val="D3AE84"/>
                 </a:solidFill>
               </a:rPr>
-              <a:t>BENCHMARK CAPITAL MARKETS</a:t>
+              <a:t>MIDDLE MARKET</a:t>
             </a:r>
             <a:endParaRPr lang="en-US" sz="638" dirty="0"/>
           </a:p>
@@ -20430,7 +20431,7 @@
                   <a:srgbClr val="F4EFE8"/>
                 </a:solidFill>
               </a:rPr>
-              <a:t>Important disclosures</a:t>
+              <a:t>Our team</a:t>
             </a:r>
             <a:endParaRPr lang="en-US" sz="975" dirty="0"/>
           </a:p>
@@ -20533,6 +20534,109 @@
                   <a:srgbClr val="F4EFE8"/>
                 </a:solidFill>
               </a:rPr>
+              <a:t>Important disclosures</a:t>
+            </a:r>
+            <a:endParaRPr lang="en-US" sz="975" dirty="0"/>
+          </a:p>
+        </p:txBody>
+      </p:sp>
+      <p:sp>
+        <p:nvSpPr>
+          <p:cNvPr id="18" name="Shape 15"/>
+          <p:cNvSpPr/>
+          <p:nvPr/>
+        </p:nvSpPr>
+        <p:spPr>
+          <a:xfrm>
+            <a:off x="609600" y="6353175"/>
+            <a:ext cx="4476750" cy="0"/>
+          </a:xfrm>
+          <a:prstGeom prst="line">
+            <a:avLst/>
+          </a:prstGeom>
+          <a:noFill/>
+          <a:ln w="9525">
+            <a:solidFill>
+              <a:srgbClr val="5B4E40"/>
+            </a:solidFill>
+            <a:prstDash val="solid"/>
+          </a:ln>
+        </p:spPr>
+        <p:txBody>
+          <a:bodyPr/>
+          <a:lstStyle/>
+          <a:p>
+            <a:endParaRPr lang="en-US"/>
+          </a:p>
+        </p:txBody>
+      </p:sp>
+      <p:sp>
+        <p:nvSpPr>
+          <p:cNvPr id="19" name="Text 13"/>
+          <p:cNvSpPr txBox="1"/>
+          <p:nvPr/>
+        </p:nvSpPr>
+        <p:spPr>
+          <a:xfrm>
+            <a:off x="609600" y="6448425"/>
+            <a:ext cx="285750" cy="171450"/>
+          </a:xfrm>
+          <a:prstGeom prst="rect">
+            <a:avLst/>
+          </a:prstGeom>
+          <a:noFill/>
+          <a:ln/>
+        </p:spPr>
+        <p:txBody>
+          <a:bodyPr wrap="square" lIns="0" tIns="0" rIns="0" bIns="0" rtlCol="0" anchor="t"/>
+          <a:lstStyle/>
+          <a:p>
+            <a:pPr marL="0" indent="0">
+              <a:buNone/>
+            </a:pPr>
+            <a:r>
+              <a:rPr lang="en-US" sz="825" dirty="0">
+                <a:solidFill>
+                  <a:srgbClr val="D3AE84"/>
+                </a:solidFill>
+                <a:latin typeface="+mj-lt" pitchFamily="34" charset="0"/>
+              </a:rPr>
+              <a:t>18</a:t>
+            </a:r>
+            <a:endParaRPr lang="en-US" sz="825" dirty="0"/>
+          </a:p>
+        </p:txBody>
+      </p:sp>
+      <p:sp>
+        <p:nvSpPr>
+          <p:cNvPr id="20" name="Text 14"/>
+          <p:cNvSpPr txBox="1"/>
+          <p:nvPr/>
+        </p:nvSpPr>
+        <p:spPr>
+          <a:xfrm>
+            <a:off x="971550" y="6429375"/>
+            <a:ext cx="4095750" cy="209550"/>
+          </a:xfrm>
+          <a:prstGeom prst="rect">
+            <a:avLst/>
+          </a:prstGeom>
+          <a:noFill/>
+          <a:ln/>
+        </p:spPr>
+        <p:txBody>
+          <a:bodyPr wrap="square" lIns="0" tIns="0" rIns="0" bIns="0" rtlCol="0" anchor="t"/>
+          <a:lstStyle/>
+          <a:p>
+            <a:pPr marL="0" indent="0">
+              <a:buNone/>
+            </a:pPr>
+            <a:r>
+              <a:rPr lang="en-US" sz="975" dirty="0">
+                <a:solidFill>
+                  <a:srgbClr val="F4EFE8"/>
+                </a:solidFill>
+              </a:rPr>
               <a:t>Sources</a:t>
             </a:r>
             <a:endParaRPr lang="en-US" sz="975" dirty="0"/>
@@ -20541,7 +20645,7 @@
       </p:sp>
       <p:sp>
         <p:nvSpPr>
-          <p:cNvPr id="18" name="Shape 15"/>
+          <p:cNvPr id="21" name="Shape 12"/>
           <p:cNvSpPr/>
           <p:nvPr/>
         </p:nvSpPr>
@@ -21223,45 +21327,6 @@
       </p:sp>
       <p:sp>
         <p:nvSpPr>
-          <p:cNvPr id="19" name="Text 15"/>
-          <p:cNvSpPr txBox="1"/>
-          <p:nvPr/>
-        </p:nvSpPr>
-        <p:spPr>
-          <a:xfrm>
-            <a:off x="4591050" y="3581400"/>
-            <a:ext cx="1790700" cy="381000"/>
-          </a:xfrm>
-          <a:prstGeom prst="rect">
-            <a:avLst/>
-          </a:prstGeom>
-          <a:noFill/>
-          <a:ln/>
-        </p:spPr>
-        <p:txBody>
-          <a:bodyPr wrap="square" lIns="0" tIns="0" rIns="0" bIns="0" rtlCol="0" anchor="t"/>
-          <a:lstStyle/>
-          <a:p>
-            <a:pPr marL="0" indent="0">
-              <a:lnSpc>
-                <a:spcPts val="1125"/>
-              </a:lnSpc>
-              <a:buNone/>
-            </a:pPr>
-            <a:r>
-              <a:rPr lang="en-US" sz="810" dirty="0">
-                <a:solidFill>
-                  <a:srgbClr val="6F6A66"/>
-                </a:solidFill>
-              </a:rPr>
-              <a:t/>
-            </a:r>
-            <a:endParaRPr lang="en-US" sz="810" dirty="0"/>
-          </a:p>
-        </p:txBody>
-      </p:sp>
-      <p:sp>
-        <p:nvSpPr>
           <p:cNvPr id="20" name="Alex Zykov card"/>
           <p:cNvSpPr/>
           <p:nvPr/>
@@ -21413,45 +21478,6 @@
       </p:sp>
       <p:sp>
         <p:nvSpPr>
-          <p:cNvPr id="25" name="Text 20"/>
-          <p:cNvSpPr txBox="1"/>
-          <p:nvPr/>
-        </p:nvSpPr>
-        <p:spPr>
-          <a:xfrm>
-            <a:off x="1504950" y="4743450"/>
-            <a:ext cx="1790700" cy="381000"/>
-          </a:xfrm>
-          <a:prstGeom prst="rect">
-            <a:avLst/>
-          </a:prstGeom>
-          <a:noFill/>
-          <a:ln/>
-        </p:spPr>
-        <p:txBody>
-          <a:bodyPr wrap="square" lIns="0" tIns="0" rIns="0" bIns="0" rtlCol="0" anchor="t"/>
-          <a:lstStyle/>
-          <a:p>
-            <a:pPr marL="0" indent="0">
-              <a:lnSpc>
-                <a:spcPts val="1125"/>
-              </a:lnSpc>
-              <a:buNone/>
-            </a:pPr>
-            <a:r>
-              <a:rPr lang="en-US" sz="810" dirty="0">
-                <a:solidFill>
-                  <a:srgbClr val="6F6A66"/>
-                </a:solidFill>
-              </a:rPr>
-              <a:t>Leads execution from onboarding through signing and closing</a:t>
-            </a:r>
-            <a:endParaRPr lang="en-US" sz="810" dirty="0"/>
-          </a:p>
-        </p:txBody>
-      </p:sp>
-      <p:sp>
-        <p:nvSpPr>
           <p:cNvPr id="26" name="Shannon Hess card"/>
           <p:cNvSpPr/>
           <p:nvPr/>
@@ -21598,45 +21624,6 @@
               <a:t>CLIENT ENGAGEMENT DIRECTOR</a:t>
             </a:r>
             <a:endParaRPr lang="en-US" sz="638" dirty="0"/>
-          </a:p>
-        </p:txBody>
-      </p:sp>
-      <p:sp>
-        <p:nvSpPr>
-          <p:cNvPr id="31" name="Text 25"/>
-          <p:cNvSpPr txBox="1"/>
-          <p:nvPr/>
-        </p:nvSpPr>
-        <p:spPr>
-          <a:xfrm>
-            <a:off x="4591050" y="4743450"/>
-            <a:ext cx="1790700" cy="381000"/>
-          </a:xfrm>
-          <a:prstGeom prst="rect">
-            <a:avLst/>
-          </a:prstGeom>
-          <a:noFill/>
-          <a:ln/>
-        </p:spPr>
-        <p:txBody>
-          <a:bodyPr wrap="square" lIns="0" tIns="0" rIns="0" bIns="0" rtlCol="0" anchor="t"/>
-          <a:lstStyle/>
-          <a:p>
-            <a:pPr marL="0" indent="0">
-              <a:lnSpc>
-                <a:spcPts val="1125"/>
-              </a:lnSpc>
-              <a:buNone/>
-            </a:pPr>
-            <a:r>
-              <a:rPr lang="en-US" sz="810" dirty="0">
-                <a:solidFill>
-                  <a:srgbClr val="6F6A66"/>
-                </a:solidFill>
-              </a:rPr>
-              <a:t>An additional point of contact for owners considering an engagement</a:t>
-            </a:r>
-            <a:endParaRPr lang="en-US" sz="810" dirty="0"/>
           </a:p>
         </p:txBody>
       </p:sp>
@@ -23091,6 +23078,216 @@
               <a:t>15</a:t>
             </a:fld>
             <a:endParaRPr lang="en-US"/>
+          </a:p>
+        </p:txBody>
+      </p:sp>
+      <p:sp>
+        <p:nvSpPr>
+          <p:cNvPr id="72" name="Text: jhoutz@benchmarkintl.com"/>
+          <p:cNvSpPr txBox="1"/>
+          <p:nvPr/>
+        </p:nvSpPr>
+        <p:spPr>
+          <a:xfrm>
+            <a:off x="4591050" y="3581400"/>
+            <a:ext cx="1790700" cy="381000"/>
+          </a:xfrm>
+          <a:prstGeom prst="rect">
+            <a:avLst/>
+          </a:prstGeom>
+          <a:noFill/>
+          <a:ln/>
+        </p:spPr>
+        <p:txBody>
+          <a:bodyPr wrap="square" lIns="0" tIns="0" rIns="0" bIns="0" rtlCol="0" anchor="t"/>
+          <a:lstStyle/>
+          <a:p>
+            <a:pPr marL="0" indent="0">
+              <a:lnSpc>
+                <a:spcPts val="1125"/>
+              </a:lnSpc>
+              <a:buNone/>
+            </a:pPr>
+            <a:r>
+              <a:rPr lang="en-US" sz="810" u="sng" dirty="0">
+                <a:solidFill>
+                  <a:srgbClr val="8C6239"/>
+                </a:solidFill>
+                <a:hlinkClick r:id="rId5">
+                  <a:extLst>
+                    <a:ext uri="{A12FA001-AC4F-418D-AE19-62706E023703}">
+                      <ahyp:hlinkClr xmlns:ahyp="http://schemas.microsoft.com/office/drawing/2018/hyperlinkcolor" val="tx"/>
+                    </a:ext>
+                  </a:extLst>
+                </a:hlinkClick>
+              </a:rPr>
+              <a:t>813-771-6675</a:t>
+            </a:r>
+            <a:endParaRPr lang="en-US" sz="810" dirty="0"/>
+          </a:p>
+          <a:p>
+            <a:pPr marL="0" indent="0">
+              <a:lnSpc>
+                <a:spcPts val="1125"/>
+              </a:lnSpc>
+              <a:buNone/>
+            </a:pPr>
+            <a:r>
+              <a:rPr lang="en-US" sz="810" u="sng" dirty="0">
+                <a:solidFill>
+                  <a:srgbClr val="8C6239"/>
+                </a:solidFill>
+                <a:hlinkClick r:id="rId17">
+                  <a:extLst>
+                    <a:ext uri="{A12FA001-AC4F-418D-AE19-62706E023703}">
+                      <ahyp:hlinkClr xmlns:ahyp="http://schemas.microsoft.com/office/drawing/2018/hyperlinkcolor" val="tx"/>
+                    </a:ext>
+                  </a:extLst>
+                </a:hlinkClick>
+              </a:rPr>
+              <a:t>jhoutz@benchmarkintl.com</a:t>
+            </a:r>
+            <a:endParaRPr lang="en-US" sz="810" dirty="0"/>
+          </a:p>
+        </p:txBody>
+      </p:sp>
+      <p:sp>
+        <p:nvSpPr>
+          <p:cNvPr id="73" name="Text: azykov@benchmarkintl.com"/>
+          <p:cNvSpPr txBox="1"/>
+          <p:nvPr/>
+        </p:nvSpPr>
+        <p:spPr>
+          <a:xfrm>
+            <a:off x="1504950" y="4743450"/>
+            <a:ext cx="1790700" cy="381000"/>
+          </a:xfrm>
+          <a:prstGeom prst="rect">
+            <a:avLst/>
+          </a:prstGeom>
+          <a:noFill/>
+          <a:ln/>
+        </p:spPr>
+        <p:txBody>
+          <a:bodyPr wrap="square" lIns="0" tIns="0" rIns="0" bIns="0" rtlCol="0" anchor="t"/>
+          <a:lstStyle/>
+          <a:p>
+            <a:pPr marL="0" indent="0">
+              <a:lnSpc>
+                <a:spcPts val="1125"/>
+              </a:lnSpc>
+              <a:buNone/>
+            </a:pPr>
+            <a:r>
+              <a:rPr lang="en-US" sz="810" u="sng" dirty="0">
+                <a:solidFill>
+                  <a:srgbClr val="8C6239"/>
+                </a:solidFill>
+                <a:hlinkClick r:id="rId18">
+                  <a:extLst>
+                    <a:ext uri="{A12FA001-AC4F-418D-AE19-62706E023703}">
+                      <ahyp:hlinkClr xmlns:ahyp="http://schemas.microsoft.com/office/drawing/2018/hyperlinkcolor" val="tx"/>
+                    </a:ext>
+                  </a:extLst>
+                </a:hlinkClick>
+              </a:rPr>
+              <a:t>813-898-2372</a:t>
+            </a:r>
+            <a:endParaRPr lang="en-US" sz="810" dirty="0"/>
+          </a:p>
+          <a:p>
+            <a:pPr marL="0" indent="0">
+              <a:lnSpc>
+                <a:spcPts val="1125"/>
+              </a:lnSpc>
+              <a:buNone/>
+            </a:pPr>
+            <a:r>
+              <a:rPr lang="en-US" sz="810" u="sng" dirty="0">
+                <a:solidFill>
+                  <a:srgbClr val="8C6239"/>
+                </a:solidFill>
+                <a:hlinkClick r:id="rId19">
+                  <a:extLst>
+                    <a:ext uri="{A12FA001-AC4F-418D-AE19-62706E023703}">
+                      <ahyp:hlinkClr xmlns:ahyp="http://schemas.microsoft.com/office/drawing/2018/hyperlinkcolor" val="tx"/>
+                    </a:ext>
+                  </a:extLst>
+                </a:hlinkClick>
+              </a:rPr>
+              <a:t>azykov@benchmarkintl.com</a:t>
+            </a:r>
+            <a:endParaRPr lang="en-US" sz="810" dirty="0"/>
+          </a:p>
+        </p:txBody>
+      </p:sp>
+      <p:sp>
+        <p:nvSpPr>
+          <p:cNvPr id="74" name="Text: hess@benchmarkintl.com"/>
+          <p:cNvSpPr txBox="1"/>
+          <p:nvPr/>
+        </p:nvSpPr>
+        <p:spPr>
+          <a:xfrm>
+            <a:off x="4591050" y="4743450"/>
+            <a:ext cx="1790700" cy="381000"/>
+          </a:xfrm>
+          <a:prstGeom prst="rect">
+            <a:avLst/>
+          </a:prstGeom>
+          <a:noFill/>
+          <a:ln/>
+        </p:spPr>
+        <p:txBody>
+          <a:bodyPr wrap="square" lIns="0" tIns="0" rIns="0" bIns="0" rtlCol="0" anchor="t"/>
+          <a:lstStyle/>
+          <a:p>
+            <a:pPr marL="0" indent="0">
+              <a:lnSpc>
+                <a:spcPts val="1125"/>
+              </a:lnSpc>
+              <a:buNone/>
+            </a:pPr>
+            <a:r>
+              <a:rPr lang="en-US" sz="810" u="sng" dirty="0">
+                <a:solidFill>
+                  <a:srgbClr val="8C6239"/>
+                </a:solidFill>
+                <a:hlinkClick r:id="rId20">
+                  <a:extLst>
+                    <a:ext uri="{A12FA001-AC4F-418D-AE19-62706E023703}">
+                      <ahyp:hlinkClr xmlns:ahyp="http://schemas.microsoft.com/office/drawing/2018/hyperlinkcolor" val="tx"/>
+                    </a:ext>
+                  </a:extLst>
+                </a:hlinkClick>
+              </a:rPr>
+              <a:t>813-898-2397</a:t>
+            </a:r>
+            <a:endParaRPr lang="en-US" sz="810" dirty="0"/>
+          </a:p>
+          <a:p>
+            <a:pPr marL="0" indent="0">
+              <a:lnSpc>
+                <a:spcPts val="1125"/>
+              </a:lnSpc>
+              <a:buNone/>
+            </a:pPr>
+            <a:r>
+              <a:rPr lang="en-US" sz="810" u="sng" dirty="0">
+                <a:solidFill>
+                  <a:srgbClr val="8C6239"/>
+                </a:solidFill>
+                <a:hlinkClick r:id="rId21">
+                  <a:extLst>
+                    <a:ext uri="{A12FA001-AC4F-418D-AE19-62706E023703}">
+                      <ahyp:hlinkClr xmlns:ahyp="http://schemas.microsoft.com/office/drawing/2018/hyperlinkcolor" val="tx"/>
+                    </a:ext>
+                  </a:extLst>
+                </a:hlinkClick>
+              </a:rPr>
+              <a:t>hess@benchmarkintl.com</a:t>
+            </a:r>
+            <a:endParaRPr lang="en-US" sz="810" dirty="0"/>
           </a:p>
         </p:txBody>
       </p:sp>
@@ -26137,6 +26334,4061 @@
               <a:t>17</a:t>
             </a:fld>
             <a:endParaRPr lang="en-US"/>
+          </a:p>
+        </p:txBody>
+      </p:sp>
+    </p:spTree>
+  </p:cSld>
+  <p:clrMapOvr>
+    <a:masterClrMapping/>
+  </p:clrMapOvr>
+</p:sld>
+</file>
+
+<file path=ppt/slides/slide18.xml><?xml version="1.0" encoding="utf-8"?>
+<p:sld xmlns:a="http://schemas.openxmlformats.org/drawingml/2006/main" xmlns:p="http://schemas.openxmlformats.org/presentationml/2006/main" xmlns:r="http://schemas.openxmlformats.org/officeDocument/2006/relationships">
+  <p:cSld>
+    <p:spTree>
+      <p:nvGrpSpPr>
+        <p:cNvPr id="1" name=""/>
+        <p:cNvGrpSpPr/>
+        <p:nvPr/>
+      </p:nvGrpSpPr>
+      <p:grpSpPr/>
+      <p:sp>
+        <p:nvSpPr>
+          <p:cNvPr id="2" name="Rectangle 1"/>
+          <p:cNvSpPr/>
+          <p:nvPr/>
+        </p:nvSpPr>
+        <p:spPr>
+          <a:xfrm>
+            <a:off x="0" y="0"/>
+            <a:ext cx="57150" cy="7772400"/>
+          </a:xfrm>
+          <a:prstGeom prst="rect">
+            <a:avLst/>
+          </a:prstGeom>
+          <a:solidFill>
+            <a:srgbClr val="B68757"/>
+          </a:solidFill>
+          <a:ln>
+            <a:noFill/>
+          </a:ln>
+          <a:effectLst/>
+        </p:spPr>
+        <p:txBody>
+          <a:bodyPr rtlCol="0" anchor="ctr"/>
+          <a:lstStyle/>
+          <a:p>
+            <a:pPr algn="ctr"/>
+            <a:endParaRPr/>
+          </a:p>
+        </p:txBody>
+      </p:sp>
+      <p:sp>
+        <p:nvSpPr>
+          <p:cNvPr id="3" name="Text: HEALTHCARE | QUARTERLY SECTOR BRIE"/>
+          <p:cNvSpPr txBox="1"/>
+          <p:nvPr/>
+        </p:nvSpPr>
+        <p:spPr>
+          <a:xfrm>
+            <a:off x="419100" y="381000"/>
+            <a:ext cx="2439591" cy="133350"/>
+          </a:xfrm>
+          <a:prstGeom prst="rect">
+            <a:avLst/>
+          </a:prstGeom>
+          <a:noFill/>
+        </p:spPr>
+        <p:txBody>
+          <a:bodyPr wrap="square" lIns="0" tIns="0" rIns="0" bIns="0" anchor="t">
+            <a:spAutoFit/>
+          </a:bodyPr>
+          <a:lstStyle/>
+          <a:p>
+            <a:pPr algn="l">
+              <a:lnSpc>
+                <a:spcPts val="1050"/>
+              </a:lnSpc>
+            </a:pPr>
+            <a:r>
+              <a:rPr sz="675" b="1" i="0" spc="195">
+                <a:solidFill>
+                  <a:srgbClr val="8C6239"/>
+                </a:solidFill>
+                <a:latin typeface="Calibri"/>
+              </a:rPr>
+              <a:t>INDUSTRIAL | QUARTERLY SECTOR BRIEF</a:t>
+            </a:r>
+          </a:p>
+        </p:txBody>
+      </p:sp>
+      <p:sp>
+        <p:nvSpPr>
+          <p:cNvPr id="4" name="Text: Q4 2026"/>
+          <p:cNvSpPr txBox="1"/>
+          <p:nvPr/>
+        </p:nvSpPr>
+        <p:spPr>
+          <a:xfrm>
+            <a:off x="9188648" y="361950"/>
+            <a:ext cx="464939" cy="171450"/>
+          </a:xfrm>
+          <a:prstGeom prst="rect">
+            <a:avLst/>
+          </a:prstGeom>
+          <a:noFill/>
+        </p:spPr>
+        <p:txBody>
+          <a:bodyPr wrap="square" lIns="0" tIns="0" rIns="0" bIns="0" anchor="t">
+            <a:spAutoFit/>
+          </a:bodyPr>
+          <a:lstStyle/>
+          <a:p>
+            <a:pPr algn="l">
+              <a:lnSpc>
+                <a:spcPts val="1350"/>
+              </a:lnSpc>
+            </a:pPr>
+            <a:r>
+              <a:rPr sz="900" b="0" i="0" spc="90">
+                <a:solidFill>
+                  <a:srgbClr val="6F6A66"/>
+                </a:solidFill>
+                <a:latin typeface="Cambria"/>
+              </a:rPr>
+              <a:t>Q4 2026</a:t>
+            </a:r>
+          </a:p>
+        </p:txBody>
+      </p:sp>
+      <p:sp>
+        <p:nvSpPr>
+          <p:cNvPr id="5" name="Text: Our Team"/>
+          <p:cNvSpPr txBox="1"/>
+          <p:nvPr/>
+        </p:nvSpPr>
+        <p:spPr>
+          <a:xfrm>
+            <a:off x="419100" y="523875"/>
+            <a:ext cx="9234488" cy="323850"/>
+          </a:xfrm>
+          <a:prstGeom prst="rect">
+            <a:avLst/>
+          </a:prstGeom>
+          <a:noFill/>
+        </p:spPr>
+        <p:txBody>
+          <a:bodyPr wrap="square" lIns="0" tIns="0" rIns="0" bIns="0" anchor="t">
+            <a:spAutoFit/>
+          </a:bodyPr>
+          <a:lstStyle/>
+          <a:p>
+            <a:pPr algn="l">
+              <a:lnSpc>
+                <a:spcPts val="2550"/>
+              </a:lnSpc>
+            </a:pPr>
+            <a:r>
+              <a:rPr sz="2025" b="1" i="0">
+                <a:solidFill>
+                  <a:srgbClr val="1B1A1A"/>
+                </a:solidFill>
+                <a:latin typeface="Cambria"/>
+              </a:rPr>
+              <a:t>Our Team</a:t>
+            </a:r>
+          </a:p>
+        </p:txBody>
+      </p:sp>
+      <p:sp>
+        <p:nvSpPr>
+          <p:cNvPr id="6" name="Text: The BCM team leads each engagement"/>
+          <p:cNvSpPr txBox="1"/>
+          <p:nvPr/>
+        </p:nvSpPr>
+        <p:spPr>
+          <a:xfrm>
+            <a:off x="419100" y="885825"/>
+            <a:ext cx="10215086" cy="180975"/>
+          </a:xfrm>
+          <a:prstGeom prst="rect">
+            <a:avLst/>
+          </a:prstGeom>
+          <a:noFill/>
+        </p:spPr>
+        <p:txBody>
+          <a:bodyPr wrap="square" lIns="0" tIns="0" rIns="0" bIns="0" anchor="t">
+            <a:spAutoFit/>
+          </a:bodyPr>
+          <a:lstStyle/>
+          <a:p>
+            <a:pPr algn="l">
+              <a:lnSpc>
+                <a:spcPts val="1388"/>
+              </a:lnSpc>
+            </a:pPr>
+            <a:r>
+              <a:rPr sz="938" b="0" i="0" spc="15">
+                <a:solidFill>
+                  <a:srgbClr val="6F6A66"/>
+                </a:solidFill>
+                <a:latin typeface="Calibri"/>
+              </a:rPr>
+              <a:t>The Middle Market team leads each engagement from the first conversation through signing and closing.</a:t>
+            </a:r>
+          </a:p>
+        </p:txBody>
+      </p:sp>
+      <p:sp>
+        <p:nvSpPr>
+          <p:cNvPr id="7" name="Rectangle 6"/>
+          <p:cNvSpPr/>
+          <p:nvPr/>
+        </p:nvSpPr>
+        <p:spPr>
+          <a:xfrm>
+            <a:off x="419100" y="1143000"/>
+            <a:ext cx="9220200" cy="9525"/>
+          </a:xfrm>
+          <a:prstGeom prst="rect">
+            <a:avLst/>
+          </a:prstGeom>
+          <a:solidFill>
+            <a:srgbClr val="E3DCD3"/>
+          </a:solidFill>
+          <a:ln>
+            <a:noFill/>
+          </a:ln>
+          <a:effectLst/>
+        </p:spPr>
+        <p:txBody>
+          <a:bodyPr rtlCol="0" anchor="ctr"/>
+          <a:lstStyle/>
+          <a:p>
+            <a:pPr algn="ctr"/>
+            <a:endParaRPr/>
+          </a:p>
+        </p:txBody>
+      </p:sp>
+      <p:sp>
+        <p:nvSpPr>
+          <p:cNvPr id="8" name="Rectangle 7"/>
+          <p:cNvSpPr/>
+          <p:nvPr/>
+        </p:nvSpPr>
+        <p:spPr>
+          <a:xfrm>
+            <a:off x="419100" y="1238250"/>
+            <a:ext cx="2038350" cy="5695950"/>
+          </a:xfrm>
+          <a:prstGeom prst="rect">
+            <a:avLst/>
+          </a:prstGeom>
+          <a:solidFill>
+            <a:srgbClr val="1B1A1A"/>
+          </a:solidFill>
+          <a:ln>
+            <a:noFill/>
+          </a:ln>
+          <a:effectLst/>
+        </p:spPr>
+        <p:txBody>
+          <a:bodyPr rtlCol="0" anchor="ctr"/>
+          <a:lstStyle/>
+          <a:p>
+            <a:pPr algn="ctr"/>
+            <a:endParaRPr/>
+          </a:p>
+        </p:txBody>
+      </p:sp>
+      <p:pic>
+        <p:nvPicPr>
+          <p:cNvPr id="9" name="Picture 8" descr="knot-dark.jpg"/>
+          <p:cNvPicPr>
+            <a:picLocks noChangeAspect="1"/>
+          </p:cNvPicPr>
+          <p:nvPr/>
+        </p:nvPicPr>
+        <p:blipFill>
+          <a:blip r:embed="rId2">
+            <a:alphaModFix amt="50000"/>
+          </a:blip>
+          <a:srcRect l="30109" t="1500" r="50365" b="1500"/>
+          <a:stretch>
+            <a:fillRect/>
+          </a:stretch>
+        </p:blipFill>
+        <p:spPr>
+          <a:xfrm>
+            <a:off x="419100" y="1238250"/>
+            <a:ext cx="2038350" cy="5695950"/>
+          </a:xfrm>
+          <a:prstGeom prst="rect">
+            <a:avLst/>
+          </a:prstGeom>
+        </p:spPr>
+      </p:pic>
+      <p:sp>
+        <p:nvSpPr>
+          <p:cNvPr id="10" name="Text: Benchmark Capital Markets"/>
+          <p:cNvSpPr txBox="1"/>
+          <p:nvPr/>
+        </p:nvSpPr>
+        <p:spPr>
+          <a:xfrm>
+            <a:off x="609600" y="1485900"/>
+            <a:ext cx="1671638" cy="533400"/>
+          </a:xfrm>
+          <a:prstGeom prst="rect">
+            <a:avLst/>
+          </a:prstGeom>
+          <a:noFill/>
+        </p:spPr>
+        <p:txBody>
+          <a:bodyPr wrap="square" lIns="0" tIns="0" rIns="0" bIns="0" anchor="t">
+            <a:spAutoFit/>
+          </a:bodyPr>
+          <a:lstStyle/>
+          <a:p>
+            <a:pPr algn="l">
+              <a:lnSpc>
+                <a:spcPts val="2100"/>
+              </a:lnSpc>
+            </a:pPr>
+            <a:r>
+              <a:rPr sz="1725" b="1" i="0">
+                <a:solidFill>
+                  <a:srgbClr val="FFFFFF"/>
+                </a:solidFill>
+                <a:latin typeface="Cambria"/>
+              </a:rPr>
+              <a:t>Middle Market</a:t>
+            </a:r>
+          </a:p>
+        </p:txBody>
+      </p:sp>
+      <p:sp>
+        <p:nvSpPr>
+          <p:cNvPr id="11" name="Rectangle 10"/>
+          <p:cNvSpPr/>
+          <p:nvPr/>
+        </p:nvSpPr>
+        <p:spPr>
+          <a:xfrm>
+            <a:off x="609600" y="2171700"/>
+            <a:ext cx="533400" cy="19050"/>
+          </a:xfrm>
+          <a:prstGeom prst="rect">
+            <a:avLst/>
+          </a:prstGeom>
+          <a:solidFill>
+            <a:srgbClr val="B68757"/>
+          </a:solidFill>
+          <a:ln>
+            <a:noFill/>
+          </a:ln>
+          <a:effectLst/>
+        </p:spPr>
+        <p:txBody>
+          <a:bodyPr rtlCol="0" anchor="ctr"/>
+          <a:lstStyle/>
+          <a:p>
+            <a:pPr algn="ctr"/>
+            <a:endParaRPr/>
+          </a:p>
+        </p:txBody>
+      </p:sp>
+      <p:sp>
+        <p:nvSpPr>
+          <p:cNvPr id="12" name="Text: Benchmark Capital Markets (BCM) re"/>
+          <p:cNvSpPr txBox="1"/>
+          <p:nvPr/>
+        </p:nvSpPr>
+        <p:spPr>
+          <a:xfrm>
+            <a:off x="609600" y="2343150"/>
+            <a:ext cx="1671638" cy="1085850"/>
+          </a:xfrm>
+          <a:prstGeom prst="rect">
+            <a:avLst/>
+          </a:prstGeom>
+          <a:noFill/>
+        </p:spPr>
+        <p:txBody>
+          <a:bodyPr wrap="square" lIns="0" tIns="0" rIns="0" bIns="0" anchor="t">
+            <a:spAutoFit/>
+          </a:bodyPr>
+          <a:lstStyle/>
+          <a:p>
+            <a:pPr algn="l">
+              <a:lnSpc>
+                <a:spcPts val="1425"/>
+              </a:lnSpc>
+            </a:pPr>
+            <a:r>
+              <a:rPr sz="900" b="0" i="0" spc="15">
+                <a:solidFill>
+                  <a:srgbClr val="E8E2DA"/>
+                </a:solidFill>
+                <a:latin typeface="Calibri"/>
+              </a:rPr>
+              <a:t>Benchmark International's Middle Market team represents owners of privately held companies with $50 million to $500 million of total enterprise value in sales, recapitalizations and growth partnerships.</a:t>
+            </a:r>
+          </a:p>
+        </p:txBody>
+      </p:sp>
+      <p:sp>
+        <p:nvSpPr>
+          <p:cNvPr id="13" name="Text: HEADQUARTERS"/>
+          <p:cNvSpPr txBox="1"/>
+          <p:nvPr/>
+        </p:nvSpPr>
+        <p:spPr>
+          <a:xfrm>
+            <a:off x="609600" y="3900488"/>
+            <a:ext cx="1671638" cy="123825"/>
+          </a:xfrm>
+          <a:prstGeom prst="rect">
+            <a:avLst/>
+          </a:prstGeom>
+          <a:noFill/>
+        </p:spPr>
+        <p:txBody>
+          <a:bodyPr wrap="square" lIns="0" tIns="0" rIns="0" bIns="0" anchor="t">
+            <a:spAutoFit/>
+          </a:bodyPr>
+          <a:lstStyle/>
+          <a:p>
+            <a:pPr algn="l">
+              <a:lnSpc>
+                <a:spcPts val="975"/>
+              </a:lnSpc>
+            </a:pPr>
+            <a:r>
+              <a:rPr sz="675" b="1" i="0" spc="150">
+                <a:solidFill>
+                  <a:srgbClr val="D3AE84"/>
+                </a:solidFill>
+                <a:latin typeface="Calibri"/>
+              </a:rPr>
+              <a:t>HEADQUARTERS</a:t>
+            </a:r>
+          </a:p>
+        </p:txBody>
+      </p:sp>
+      <p:sp>
+        <p:nvSpPr>
+          <p:cNvPr id="14" name="Rectangle 13"/>
+          <p:cNvSpPr/>
+          <p:nvPr/>
+        </p:nvSpPr>
+        <p:spPr>
+          <a:xfrm>
+            <a:off x="609600" y="4100512"/>
+            <a:ext cx="1657350" cy="9525"/>
+          </a:xfrm>
+          <a:prstGeom prst="rect">
+            <a:avLst/>
+          </a:prstGeom>
+          <a:solidFill>
+            <a:srgbClr val="FFFFFF">
+              <a:alpha val="16000"/>
+            </a:srgbClr>
+          </a:solidFill>
+          <a:ln>
+            <a:noFill/>
+          </a:ln>
+          <a:effectLst/>
+        </p:spPr>
+        <p:txBody>
+          <a:bodyPr rtlCol="0" anchor="ctr"/>
+          <a:lstStyle/>
+          <a:p>
+            <a:pPr algn="ctr"/>
+            <a:endParaRPr/>
+          </a:p>
+        </p:txBody>
+      </p:sp>
+      <p:sp>
+        <p:nvSpPr>
+          <p:cNvPr id="15" name="Text: AMERICAS"/>
+          <p:cNvSpPr txBox="1"/>
+          <p:nvPr/>
+        </p:nvSpPr>
+        <p:spPr>
+          <a:xfrm>
+            <a:off x="609600" y="4214812"/>
+            <a:ext cx="1671638" cy="171450"/>
+          </a:xfrm>
+          <a:prstGeom prst="rect">
+            <a:avLst/>
+          </a:prstGeom>
+          <a:noFill/>
+        </p:spPr>
+        <p:txBody>
+          <a:bodyPr wrap="square" lIns="0" tIns="0" rIns="0" bIns="0" anchor="t">
+            <a:spAutoFit/>
+          </a:bodyPr>
+          <a:lstStyle/>
+          <a:p>
+            <a:pPr algn="l">
+              <a:lnSpc>
+                <a:spcPts val="1350"/>
+              </a:lnSpc>
+            </a:pPr>
+            <a:r>
+              <a:rPr sz="975" b="0" i="0" spc="225">
+                <a:solidFill>
+                  <a:srgbClr val="D3AE84"/>
+                </a:solidFill>
+                <a:latin typeface="Cambria"/>
+              </a:rPr>
+              <a:t>AMERICAS</a:t>
+            </a:r>
+          </a:p>
+        </p:txBody>
+      </p:sp>
+      <p:sp>
+        <p:nvSpPr>
+          <p:cNvPr id="16" name="Text: 4030 West Boy Scout Blvd."/>
+          <p:cNvSpPr txBox="1"/>
+          <p:nvPr/>
+        </p:nvSpPr>
+        <p:spPr>
+          <a:xfrm>
+            <a:off x="609600" y="4414838"/>
+            <a:ext cx="1671638" cy="442912"/>
+          </a:xfrm>
+          <a:prstGeom prst="rect">
+            <a:avLst/>
+          </a:prstGeom>
+          <a:noFill/>
+        </p:spPr>
+        <p:txBody>
+          <a:bodyPr wrap="square" lIns="0" tIns="0" rIns="0" bIns="0" anchor="t">
+            <a:spAutoFit/>
+          </a:bodyPr>
+          <a:lstStyle/>
+          <a:p>
+            <a:pPr algn="l">
+              <a:lnSpc>
+                <a:spcPts val="1162"/>
+              </a:lnSpc>
+            </a:pPr>
+            <a:r>
+              <a:rPr sz="788" b="0" i="0" spc="15">
+                <a:solidFill>
+                  <a:srgbClr val="E8E2DA"/>
+                </a:solidFill>
+                <a:latin typeface="Calibri"/>
+              </a:rPr>
+              <a:t>4030 West Boy Scout Blvd.</a:t>
+            </a:r>
+            <a:br/>
+            <a:r>
+              <a:rPr sz="788" b="0" i="0" spc="15">
+                <a:solidFill>
+                  <a:srgbClr val="E8E2DA"/>
+                </a:solidFill>
+                <a:latin typeface="Calibri"/>
+              </a:rPr>
+              <a:t>Suite 500, Tampa, FL 33607</a:t>
+            </a:r>
+            <a:br/>
+            <a:r>
+              <a:rPr sz="788" b="0" i="0" spc="15">
+                <a:solidFill>
+                  <a:srgbClr val="E8E2DA"/>
+                </a:solidFill>
+                <a:latin typeface="Calibri"/>
+              </a:rPr>
+              <a:t>+1 813 898 2350</a:t>
+            </a:r>
+          </a:p>
+        </p:txBody>
+      </p:sp>
+      <p:sp>
+        <p:nvSpPr>
+          <p:cNvPr id="17" name="Rectangle 16"/>
+          <p:cNvSpPr/>
+          <p:nvPr/>
+        </p:nvSpPr>
+        <p:spPr>
+          <a:xfrm>
+            <a:off x="609600" y="4962525"/>
+            <a:ext cx="1657350" cy="9525"/>
+          </a:xfrm>
+          <a:prstGeom prst="rect">
+            <a:avLst/>
+          </a:prstGeom>
+          <a:solidFill>
+            <a:srgbClr val="FFFFFF">
+              <a:alpha val="16000"/>
+            </a:srgbClr>
+          </a:solidFill>
+          <a:ln>
+            <a:noFill/>
+          </a:ln>
+          <a:effectLst/>
+        </p:spPr>
+        <p:txBody>
+          <a:bodyPr rtlCol="0" anchor="ctr"/>
+          <a:lstStyle/>
+          <a:p>
+            <a:pPr algn="ctr"/>
+            <a:endParaRPr/>
+          </a:p>
+        </p:txBody>
+      </p:sp>
+      <p:sp>
+        <p:nvSpPr>
+          <p:cNvPr id="18" name="Text: EUROPE"/>
+          <p:cNvSpPr txBox="1"/>
+          <p:nvPr/>
+        </p:nvSpPr>
+        <p:spPr>
+          <a:xfrm>
+            <a:off x="609600" y="5076825"/>
+            <a:ext cx="1671638" cy="171450"/>
+          </a:xfrm>
+          <a:prstGeom prst="rect">
+            <a:avLst/>
+          </a:prstGeom>
+          <a:noFill/>
+        </p:spPr>
+        <p:txBody>
+          <a:bodyPr wrap="square" lIns="0" tIns="0" rIns="0" bIns="0" anchor="t">
+            <a:spAutoFit/>
+          </a:bodyPr>
+          <a:lstStyle/>
+          <a:p>
+            <a:pPr algn="l">
+              <a:lnSpc>
+                <a:spcPts val="1350"/>
+              </a:lnSpc>
+            </a:pPr>
+            <a:r>
+              <a:rPr sz="975" b="0" i="0" spc="225">
+                <a:solidFill>
+                  <a:srgbClr val="D3AE84"/>
+                </a:solidFill>
+                <a:latin typeface="Cambria"/>
+              </a:rPr>
+              <a:t>EUROPE</a:t>
+            </a:r>
+          </a:p>
+        </p:txBody>
+      </p:sp>
+      <p:sp>
+        <p:nvSpPr>
+          <p:cNvPr id="19" name="Text: One New Bailey, 4 Stanley St."/>
+          <p:cNvSpPr txBox="1"/>
+          <p:nvPr/>
+        </p:nvSpPr>
+        <p:spPr>
+          <a:xfrm>
+            <a:off x="609600" y="5276850"/>
+            <a:ext cx="1671638" cy="442912"/>
+          </a:xfrm>
+          <a:prstGeom prst="rect">
+            <a:avLst/>
+          </a:prstGeom>
+          <a:noFill/>
+        </p:spPr>
+        <p:txBody>
+          <a:bodyPr wrap="square" lIns="0" tIns="0" rIns="0" bIns="0" anchor="t">
+            <a:spAutoFit/>
+          </a:bodyPr>
+          <a:lstStyle/>
+          <a:p>
+            <a:pPr algn="l">
+              <a:lnSpc>
+                <a:spcPts val="1162"/>
+              </a:lnSpc>
+            </a:pPr>
+            <a:r>
+              <a:rPr sz="788" b="0" i="0" spc="15">
+                <a:solidFill>
+                  <a:srgbClr val="E8E2DA"/>
+                </a:solidFill>
+                <a:latin typeface="Calibri"/>
+              </a:rPr>
+              <a:t>One New Bailey, 4 Stanley St.</a:t>
+            </a:r>
+            <a:br/>
+            <a:r>
+              <a:rPr sz="788" b="0" i="0" spc="15">
+                <a:solidFill>
+                  <a:srgbClr val="E8E2DA"/>
+                </a:solidFill>
+                <a:latin typeface="Calibri"/>
+              </a:rPr>
+              <a:t>Manchester, M3 5JL</a:t>
+            </a:r>
+            <a:br/>
+            <a:r>
+              <a:rPr sz="788" b="0" i="0" spc="15">
+                <a:solidFill>
+                  <a:srgbClr val="E8E2DA"/>
+                </a:solidFill>
+                <a:latin typeface="Calibri"/>
+              </a:rPr>
+              <a:t>+44 (0) 161 359 4400</a:t>
+            </a:r>
+          </a:p>
+        </p:txBody>
+      </p:sp>
+      <p:sp>
+        <p:nvSpPr>
+          <p:cNvPr id="20" name="Rectangle 19"/>
+          <p:cNvSpPr/>
+          <p:nvPr/>
+        </p:nvSpPr>
+        <p:spPr>
+          <a:xfrm>
+            <a:off x="609600" y="5824538"/>
+            <a:ext cx="1657350" cy="9525"/>
+          </a:xfrm>
+          <a:prstGeom prst="rect">
+            <a:avLst/>
+          </a:prstGeom>
+          <a:solidFill>
+            <a:srgbClr val="FFFFFF">
+              <a:alpha val="16000"/>
+            </a:srgbClr>
+          </a:solidFill>
+          <a:ln>
+            <a:noFill/>
+          </a:ln>
+          <a:effectLst/>
+        </p:spPr>
+        <p:txBody>
+          <a:bodyPr rtlCol="0" anchor="ctr"/>
+          <a:lstStyle/>
+          <a:p>
+            <a:pPr algn="ctr"/>
+            <a:endParaRPr/>
+          </a:p>
+        </p:txBody>
+      </p:sp>
+      <p:sp>
+        <p:nvSpPr>
+          <p:cNvPr id="21" name="Text: AFRICA"/>
+          <p:cNvSpPr txBox="1"/>
+          <p:nvPr/>
+        </p:nvSpPr>
+        <p:spPr>
+          <a:xfrm>
+            <a:off x="609600" y="5938838"/>
+            <a:ext cx="1671638" cy="171450"/>
+          </a:xfrm>
+          <a:prstGeom prst="rect">
+            <a:avLst/>
+          </a:prstGeom>
+          <a:noFill/>
+        </p:spPr>
+        <p:txBody>
+          <a:bodyPr wrap="square" lIns="0" tIns="0" rIns="0" bIns="0" anchor="t">
+            <a:spAutoFit/>
+          </a:bodyPr>
+          <a:lstStyle/>
+          <a:p>
+            <a:pPr algn="l">
+              <a:lnSpc>
+                <a:spcPts val="1350"/>
+              </a:lnSpc>
+            </a:pPr>
+            <a:r>
+              <a:rPr sz="975" b="0" i="0" spc="225">
+                <a:solidFill>
+                  <a:srgbClr val="D3AE84"/>
+                </a:solidFill>
+                <a:latin typeface="Cambria"/>
+              </a:rPr>
+              <a:t>AFRICA</a:t>
+            </a:r>
+          </a:p>
+        </p:txBody>
+      </p:sp>
+      <p:sp>
+        <p:nvSpPr>
+          <p:cNvPr id="22" name="Text: Airport Office Park, Freight Rd."/>
+          <p:cNvSpPr txBox="1"/>
+          <p:nvPr/>
+        </p:nvSpPr>
+        <p:spPr>
+          <a:xfrm>
+            <a:off x="609600" y="6138862"/>
+            <a:ext cx="1671638" cy="442912"/>
+          </a:xfrm>
+          <a:prstGeom prst="rect">
+            <a:avLst/>
+          </a:prstGeom>
+          <a:noFill/>
+        </p:spPr>
+        <p:txBody>
+          <a:bodyPr wrap="square" lIns="0" tIns="0" rIns="0" bIns="0" anchor="t">
+            <a:spAutoFit/>
+          </a:bodyPr>
+          <a:lstStyle/>
+          <a:p>
+            <a:pPr algn="l">
+              <a:lnSpc>
+                <a:spcPts val="1162"/>
+              </a:lnSpc>
+            </a:pPr>
+            <a:r>
+              <a:rPr sz="788" b="0" i="0" spc="15">
+                <a:solidFill>
+                  <a:srgbClr val="E8E2DA"/>
+                </a:solidFill>
+                <a:latin typeface="Calibri"/>
+              </a:rPr>
+              <a:t>Airport Office Park, Freight Rd.</a:t>
+            </a:r>
+            <a:br/>
+            <a:r>
+              <a:rPr sz="788" b="0" i="0" spc="15">
+                <a:solidFill>
+                  <a:srgbClr val="E8E2DA"/>
+                </a:solidFill>
+                <a:latin typeface="Calibri"/>
+              </a:rPr>
+              <a:t>Cape Town Airport, 7525</a:t>
+            </a:r>
+            <a:br/>
+            <a:r>
+              <a:rPr sz="788" b="0" i="0" spc="15">
+                <a:solidFill>
+                  <a:srgbClr val="E8E2DA"/>
+                </a:solidFill>
+                <a:latin typeface="Calibri"/>
+              </a:rPr>
+              <a:t>+27 (0) 21 300 2055</a:t>
+            </a:r>
+          </a:p>
+        </p:txBody>
+      </p:sp>
+      <p:sp>
+        <p:nvSpPr>
+          <p:cNvPr id="23" name="Rectangle 22"/>
+          <p:cNvSpPr/>
+          <p:nvPr/>
+        </p:nvSpPr>
+        <p:spPr>
+          <a:xfrm>
+            <a:off x="2628900" y="1238250"/>
+            <a:ext cx="1652588" cy="2628900"/>
+          </a:xfrm>
+          <a:prstGeom prst="rect">
+            <a:avLst/>
+          </a:prstGeom>
+          <a:solidFill>
+            <a:srgbClr val="FAF7F3"/>
+          </a:solidFill>
+          <a:ln>
+            <a:noFill/>
+          </a:ln>
+          <a:effectLst/>
+        </p:spPr>
+        <p:txBody>
+          <a:bodyPr rtlCol="0" anchor="ctr"/>
+          <a:lstStyle/>
+          <a:p>
+            <a:pPr algn="ctr"/>
+            <a:endParaRPr/>
+          </a:p>
+        </p:txBody>
+      </p:sp>
+      <p:sp>
+        <p:nvSpPr>
+          <p:cNvPr id="24" name="Rectangle 23"/>
+          <p:cNvSpPr/>
+          <p:nvPr/>
+        </p:nvSpPr>
+        <p:spPr>
+          <a:xfrm>
+            <a:off x="2628900" y="1238250"/>
+            <a:ext cx="1652588" cy="28575"/>
+          </a:xfrm>
+          <a:prstGeom prst="rect">
+            <a:avLst/>
+          </a:prstGeom>
+          <a:solidFill>
+            <a:srgbClr val="B68757"/>
+          </a:solidFill>
+          <a:ln>
+            <a:noFill/>
+          </a:ln>
+          <a:effectLst/>
+        </p:spPr>
+        <p:txBody>
+          <a:bodyPr rtlCol="0" anchor="ctr"/>
+          <a:lstStyle/>
+          <a:p>
+            <a:pPr algn="ctr"/>
+            <a:endParaRPr/>
+          </a:p>
+        </p:txBody>
+      </p:sp>
+      <p:pic>
+        <p:nvPicPr>
+          <p:cNvPr id="25" name="Picture 24" descr="Jordan Houtz"/>
+          <p:cNvPicPr>
+            <a:picLocks noChangeAspect="1"/>
+          </p:cNvPicPr>
+          <p:nvPr/>
+        </p:nvPicPr>
+        <p:blipFill>
+          <a:blip r:embed="rId3"/>
+          <a:srcRect/>
+          <a:stretch>
+            <a:fillRect/>
+          </a:stretch>
+        </p:blipFill>
+        <p:spPr>
+          <a:xfrm>
+            <a:off x="2883694" y="1438275"/>
+            <a:ext cx="1143000" cy="1143000"/>
+          </a:xfrm>
+          <a:prstGeom prst="ellipse">
+            <a:avLst/>
+          </a:prstGeom>
+        </p:spPr>
+      </p:pic>
+      <p:sp>
+        <p:nvSpPr>
+          <p:cNvPr id="26" name="Text: Jordan Houtz"/>
+          <p:cNvSpPr txBox="1"/>
+          <p:nvPr/>
+        </p:nvSpPr>
+        <p:spPr>
+          <a:xfrm>
+            <a:off x="2919859" y="2714625"/>
+            <a:ext cx="1084808" cy="228600"/>
+          </a:xfrm>
+          <a:prstGeom prst="rect">
+            <a:avLst/>
+          </a:prstGeom>
+          <a:noFill/>
+        </p:spPr>
+        <p:txBody>
+          <a:bodyPr wrap="square" lIns="0" tIns="0" rIns="0" bIns="0" anchor="t">
+            <a:spAutoFit/>
+          </a:bodyPr>
+          <a:lstStyle/>
+          <a:p>
+            <a:pPr algn="ctr">
+              <a:lnSpc>
+                <a:spcPts val="1800"/>
+              </a:lnSpc>
+            </a:pPr>
+            <a:r>
+              <a:rPr sz="1425" b="1" i="0">
+                <a:solidFill>
+                  <a:srgbClr val="1B1A1A"/>
+                </a:solidFill>
+                <a:latin typeface="Cambria"/>
+              </a:rPr>
+              <a:t>Jordan Houtz</a:t>
+            </a:r>
+          </a:p>
+        </p:txBody>
+      </p:sp>
+      <p:sp>
+        <p:nvSpPr>
+          <p:cNvPr id="27" name="Text: MANAGING DIRECTOR"/>
+          <p:cNvSpPr txBox="1"/>
+          <p:nvPr/>
+        </p:nvSpPr>
+        <p:spPr>
+          <a:xfrm>
+            <a:off x="2963912" y="2971800"/>
+            <a:ext cx="996702" cy="123825"/>
+          </a:xfrm>
+          <a:prstGeom prst="rect">
+            <a:avLst/>
+          </a:prstGeom>
+          <a:noFill/>
+        </p:spPr>
+        <p:txBody>
+          <a:bodyPr wrap="square" lIns="0" tIns="0" rIns="0" bIns="0" anchor="t">
+            <a:spAutoFit/>
+          </a:bodyPr>
+          <a:lstStyle/>
+          <a:p>
+            <a:pPr algn="ctr">
+              <a:lnSpc>
+                <a:spcPts val="975"/>
+              </a:lnSpc>
+            </a:pPr>
+            <a:r>
+              <a:rPr sz="638" b="1" i="0" spc="105">
+                <a:solidFill>
+                  <a:srgbClr val="8C6239"/>
+                </a:solidFill>
+                <a:latin typeface="Calibri"/>
+              </a:rPr>
+              <a:t>MANAGING DIRECTOR</a:t>
+            </a:r>
+          </a:p>
+        </p:txBody>
+      </p:sp>
+      <p:sp>
+        <p:nvSpPr>
+          <p:cNvPr id="28" name="Rectangle 27"/>
+          <p:cNvSpPr/>
+          <p:nvPr/>
+        </p:nvSpPr>
+        <p:spPr>
+          <a:xfrm>
+            <a:off x="4414838" y="1238250"/>
+            <a:ext cx="1652588" cy="2628900"/>
+          </a:xfrm>
+          <a:prstGeom prst="rect">
+            <a:avLst/>
+          </a:prstGeom>
+          <a:solidFill>
+            <a:srgbClr val="FAF7F3"/>
+          </a:solidFill>
+          <a:ln>
+            <a:noFill/>
+          </a:ln>
+          <a:effectLst/>
+        </p:spPr>
+        <p:txBody>
+          <a:bodyPr rtlCol="0" anchor="ctr"/>
+          <a:lstStyle/>
+          <a:p>
+            <a:pPr algn="ctr"/>
+            <a:endParaRPr/>
+          </a:p>
+        </p:txBody>
+      </p:sp>
+      <p:sp>
+        <p:nvSpPr>
+          <p:cNvPr id="29" name="Rectangle 28"/>
+          <p:cNvSpPr/>
+          <p:nvPr/>
+        </p:nvSpPr>
+        <p:spPr>
+          <a:xfrm>
+            <a:off x="4414838" y="1238250"/>
+            <a:ext cx="1652588" cy="28575"/>
+          </a:xfrm>
+          <a:prstGeom prst="rect">
+            <a:avLst/>
+          </a:prstGeom>
+          <a:solidFill>
+            <a:srgbClr val="B68757"/>
+          </a:solidFill>
+          <a:ln>
+            <a:noFill/>
+          </a:ln>
+          <a:effectLst/>
+        </p:spPr>
+        <p:txBody>
+          <a:bodyPr rtlCol="0" anchor="ctr"/>
+          <a:lstStyle/>
+          <a:p>
+            <a:pPr algn="ctr"/>
+            <a:endParaRPr/>
+          </a:p>
+        </p:txBody>
+      </p:sp>
+      <p:pic>
+        <p:nvPicPr>
+          <p:cNvPr id="30" name="Picture 29" descr="Jared Hardin"/>
+          <p:cNvPicPr>
+            <a:picLocks noChangeAspect="1"/>
+          </p:cNvPicPr>
+          <p:nvPr/>
+        </p:nvPicPr>
+        <p:blipFill>
+          <a:blip r:embed="rId4"/>
+          <a:srcRect/>
+          <a:stretch>
+            <a:fillRect/>
+          </a:stretch>
+        </p:blipFill>
+        <p:spPr>
+          <a:xfrm>
+            <a:off x="4669631" y="1438275"/>
+            <a:ext cx="1143000" cy="1143000"/>
+          </a:xfrm>
+          <a:prstGeom prst="ellipse">
+            <a:avLst/>
+          </a:prstGeom>
+        </p:spPr>
+      </p:pic>
+      <p:sp>
+        <p:nvSpPr>
+          <p:cNvPr id="31" name="Text: Jared Hardin"/>
+          <p:cNvSpPr txBox="1"/>
+          <p:nvPr/>
+        </p:nvSpPr>
+        <p:spPr>
+          <a:xfrm>
+            <a:off x="4718745" y="2714625"/>
+            <a:ext cx="1058912" cy="228600"/>
+          </a:xfrm>
+          <a:prstGeom prst="rect">
+            <a:avLst/>
+          </a:prstGeom>
+          <a:noFill/>
+        </p:spPr>
+        <p:txBody>
+          <a:bodyPr wrap="square" lIns="0" tIns="0" rIns="0" bIns="0" anchor="t">
+            <a:spAutoFit/>
+          </a:bodyPr>
+          <a:lstStyle/>
+          <a:p>
+            <a:pPr algn="ctr">
+              <a:lnSpc>
+                <a:spcPts val="1800"/>
+              </a:lnSpc>
+            </a:pPr>
+            <a:r>
+              <a:rPr sz="1425" b="1" i="0">
+                <a:solidFill>
+                  <a:srgbClr val="1B1A1A"/>
+                </a:solidFill>
+                <a:latin typeface="Cambria"/>
+              </a:rPr>
+              <a:t>Jared Hardin</a:t>
+            </a:r>
+          </a:p>
+        </p:txBody>
+      </p:sp>
+      <p:sp>
+        <p:nvSpPr>
+          <p:cNvPr id="32" name="Text: MANAGING DIRECTOR"/>
+          <p:cNvSpPr txBox="1"/>
+          <p:nvPr/>
+        </p:nvSpPr>
+        <p:spPr>
+          <a:xfrm>
+            <a:off x="4749850" y="2971800"/>
+            <a:ext cx="996702" cy="123825"/>
+          </a:xfrm>
+          <a:prstGeom prst="rect">
+            <a:avLst/>
+          </a:prstGeom>
+          <a:noFill/>
+        </p:spPr>
+        <p:txBody>
+          <a:bodyPr wrap="square" lIns="0" tIns="0" rIns="0" bIns="0" anchor="t">
+            <a:spAutoFit/>
+          </a:bodyPr>
+          <a:lstStyle/>
+          <a:p>
+            <a:pPr algn="ctr">
+              <a:lnSpc>
+                <a:spcPts val="975"/>
+              </a:lnSpc>
+            </a:pPr>
+            <a:r>
+              <a:rPr sz="638" b="1" i="0" spc="105">
+                <a:solidFill>
+                  <a:srgbClr val="8C6239"/>
+                </a:solidFill>
+                <a:latin typeface="Calibri"/>
+              </a:rPr>
+              <a:t>MANAGING DIRECTOR</a:t>
+            </a:r>
+          </a:p>
+        </p:txBody>
+      </p:sp>
+      <p:sp>
+        <p:nvSpPr>
+          <p:cNvPr id="33" name="Text: 813-771-6675"/>
+          <p:cNvSpPr txBox="1"/>
+          <p:nvPr/>
+        </p:nvSpPr>
+        <p:spPr>
+          <a:xfrm>
+            <a:off x="4621857" y="3162300"/>
+            <a:ext cx="1252686" cy="304800"/>
+          </a:xfrm>
+          <a:prstGeom prst="rect">
+            <a:avLst/>
+          </a:prstGeom>
+          <a:noFill/>
+        </p:spPr>
+        <p:txBody>
+          <a:bodyPr wrap="square" lIns="0" tIns="0" rIns="0" bIns="0" anchor="t">
+            <a:spAutoFit/>
+          </a:bodyPr>
+          <a:lstStyle/>
+          <a:p>
+            <a:pPr algn="ctr">
+              <a:lnSpc>
+                <a:spcPts val="1200"/>
+              </a:lnSpc>
+            </a:pPr>
+            <a:r>
+              <a:rPr sz="788" b="0" i="0" spc="15">
+                <a:solidFill>
+                  <a:srgbClr val="8C6239"/>
+                </a:solidFill>
+                <a:latin typeface="Calibri"/>
+                <a:hlinkClick r:id="rId5">
+                  <a:extLst>
+                    <a:ext uri="{A12FA001-AC4F-418D-AE19-62706E023703}">
+                      <ahyp:hlinkClr xmlns:ahyp="http://schemas.microsoft.com/office/drawing/2018/hyperlinkcolor" val="tx"/>
+                    </a:ext>
+                  </a:extLst>
+                </a:hlinkClick>
+              </a:rPr>
+              <a:t>813-771-6675</a:t>
+            </a:r>
+            <a:br/>
+            <a:r>
+              <a:rPr sz="788" b="0" i="0" spc="15">
+                <a:solidFill>
+                  <a:srgbClr val="8C6239"/>
+                </a:solidFill>
+                <a:latin typeface="Calibri"/>
+                <a:hlinkClick r:id="rId6">
+                  <a:extLst>
+                    <a:ext uri="{A12FA001-AC4F-418D-AE19-62706E023703}">
+                      <ahyp:hlinkClr xmlns:ahyp="http://schemas.microsoft.com/office/drawing/2018/hyperlinkcolor" val="tx"/>
+                    </a:ext>
+                  </a:extLst>
+                </a:hlinkClick>
+              </a:rPr>
+              <a:t>j.hardin@benchmarkintl.com</a:t>
+            </a:r>
+          </a:p>
+        </p:txBody>
+      </p:sp>
+      <p:sp>
+        <p:nvSpPr>
+          <p:cNvPr id="34" name="Rectangle 33"/>
+          <p:cNvSpPr/>
+          <p:nvPr/>
+        </p:nvSpPr>
+        <p:spPr>
+          <a:xfrm>
+            <a:off x="6200775" y="1238250"/>
+            <a:ext cx="1652588" cy="2628900"/>
+          </a:xfrm>
+          <a:prstGeom prst="rect">
+            <a:avLst/>
+          </a:prstGeom>
+          <a:solidFill>
+            <a:srgbClr val="FAF7F3"/>
+          </a:solidFill>
+          <a:ln>
+            <a:noFill/>
+          </a:ln>
+          <a:effectLst/>
+        </p:spPr>
+        <p:txBody>
+          <a:bodyPr rtlCol="0" anchor="ctr"/>
+          <a:lstStyle/>
+          <a:p>
+            <a:pPr algn="ctr"/>
+            <a:endParaRPr/>
+          </a:p>
+        </p:txBody>
+      </p:sp>
+      <p:sp>
+        <p:nvSpPr>
+          <p:cNvPr id="35" name="Rectangle 34"/>
+          <p:cNvSpPr/>
+          <p:nvPr/>
+        </p:nvSpPr>
+        <p:spPr>
+          <a:xfrm>
+            <a:off x="6200775" y="1238250"/>
+            <a:ext cx="1652588" cy="28575"/>
+          </a:xfrm>
+          <a:prstGeom prst="rect">
+            <a:avLst/>
+          </a:prstGeom>
+          <a:solidFill>
+            <a:srgbClr val="B68757"/>
+          </a:solidFill>
+          <a:ln>
+            <a:noFill/>
+          </a:ln>
+          <a:effectLst/>
+        </p:spPr>
+        <p:txBody>
+          <a:bodyPr rtlCol="0" anchor="ctr"/>
+          <a:lstStyle/>
+          <a:p>
+            <a:pPr algn="ctr"/>
+            <a:endParaRPr/>
+          </a:p>
+        </p:txBody>
+      </p:sp>
+      <p:pic>
+        <p:nvPicPr>
+          <p:cNvPr id="36" name="Picture 35" descr="Alex Zykov"/>
+          <p:cNvPicPr>
+            <a:picLocks noChangeAspect="1"/>
+          </p:cNvPicPr>
+          <p:nvPr/>
+        </p:nvPicPr>
+        <p:blipFill>
+          <a:blip r:embed="rId7"/>
+          <a:srcRect/>
+          <a:stretch>
+            <a:fillRect/>
+          </a:stretch>
+        </p:blipFill>
+        <p:spPr>
+          <a:xfrm>
+            <a:off x="6455569" y="1438275"/>
+            <a:ext cx="1143000" cy="1143000"/>
+          </a:xfrm>
+          <a:prstGeom prst="ellipse">
+            <a:avLst/>
+          </a:prstGeom>
+        </p:spPr>
+      </p:pic>
+      <p:sp>
+        <p:nvSpPr>
+          <p:cNvPr id="37" name="Text: Alex Zykov"/>
+          <p:cNvSpPr txBox="1"/>
+          <p:nvPr/>
+        </p:nvSpPr>
+        <p:spPr>
+          <a:xfrm>
+            <a:off x="6588621" y="2714625"/>
+            <a:ext cx="891183" cy="228600"/>
+          </a:xfrm>
+          <a:prstGeom prst="rect">
+            <a:avLst/>
+          </a:prstGeom>
+          <a:noFill/>
+        </p:spPr>
+        <p:txBody>
+          <a:bodyPr wrap="square" lIns="0" tIns="0" rIns="0" bIns="0" anchor="t">
+            <a:spAutoFit/>
+          </a:bodyPr>
+          <a:lstStyle/>
+          <a:p>
+            <a:pPr algn="ctr">
+              <a:lnSpc>
+                <a:spcPts val="1800"/>
+              </a:lnSpc>
+            </a:pPr>
+            <a:r>
+              <a:rPr sz="1425" b="1" i="0">
+                <a:solidFill>
+                  <a:srgbClr val="1B1A1A"/>
+                </a:solidFill>
+                <a:latin typeface="Cambria"/>
+              </a:rPr>
+              <a:t>Alex Zykov</a:t>
+            </a:r>
+          </a:p>
+        </p:txBody>
+      </p:sp>
+      <p:sp>
+        <p:nvSpPr>
+          <p:cNvPr id="38" name="Text: TRANSACTION DIRECTOR"/>
+          <p:cNvSpPr txBox="1"/>
+          <p:nvPr/>
+        </p:nvSpPr>
+        <p:spPr>
+          <a:xfrm>
+            <a:off x="6472238" y="2971800"/>
+            <a:ext cx="1123801" cy="123825"/>
+          </a:xfrm>
+          <a:prstGeom prst="rect">
+            <a:avLst/>
+          </a:prstGeom>
+          <a:noFill/>
+        </p:spPr>
+        <p:txBody>
+          <a:bodyPr wrap="square" lIns="0" tIns="0" rIns="0" bIns="0" anchor="t">
+            <a:spAutoFit/>
+          </a:bodyPr>
+          <a:lstStyle/>
+          <a:p>
+            <a:pPr algn="ctr">
+              <a:lnSpc>
+                <a:spcPts val="975"/>
+              </a:lnSpc>
+            </a:pPr>
+            <a:r>
+              <a:rPr sz="638" b="1" i="0" spc="105">
+                <a:solidFill>
+                  <a:srgbClr val="8C6239"/>
+                </a:solidFill>
+                <a:latin typeface="Calibri"/>
+              </a:rPr>
+              <a:t>TRANSACTION DIRECTOR</a:t>
+            </a:r>
+          </a:p>
+        </p:txBody>
+      </p:sp>
+      <p:sp>
+        <p:nvSpPr>
+          <p:cNvPr id="39" name="Rectangle 38"/>
+          <p:cNvSpPr/>
+          <p:nvPr/>
+        </p:nvSpPr>
+        <p:spPr>
+          <a:xfrm>
+            <a:off x="7986712" y="1238250"/>
+            <a:ext cx="1652588" cy="2628900"/>
+          </a:xfrm>
+          <a:prstGeom prst="rect">
+            <a:avLst/>
+          </a:prstGeom>
+          <a:solidFill>
+            <a:srgbClr val="FAF7F3"/>
+          </a:solidFill>
+          <a:ln>
+            <a:noFill/>
+          </a:ln>
+          <a:effectLst/>
+        </p:spPr>
+        <p:txBody>
+          <a:bodyPr rtlCol="0" anchor="ctr"/>
+          <a:lstStyle/>
+          <a:p>
+            <a:pPr algn="ctr"/>
+            <a:endParaRPr/>
+          </a:p>
+        </p:txBody>
+      </p:sp>
+      <p:sp>
+        <p:nvSpPr>
+          <p:cNvPr id="40" name="Rectangle 39"/>
+          <p:cNvSpPr/>
+          <p:nvPr/>
+        </p:nvSpPr>
+        <p:spPr>
+          <a:xfrm>
+            <a:off x="7986712" y="1238250"/>
+            <a:ext cx="1652588" cy="28575"/>
+          </a:xfrm>
+          <a:prstGeom prst="rect">
+            <a:avLst/>
+          </a:prstGeom>
+          <a:solidFill>
+            <a:srgbClr val="B68757"/>
+          </a:solidFill>
+          <a:ln>
+            <a:noFill/>
+          </a:ln>
+          <a:effectLst/>
+        </p:spPr>
+        <p:txBody>
+          <a:bodyPr rtlCol="0" anchor="ctr"/>
+          <a:lstStyle/>
+          <a:p>
+            <a:pPr algn="ctr"/>
+            <a:endParaRPr/>
+          </a:p>
+        </p:txBody>
+      </p:sp>
+      <p:pic>
+        <p:nvPicPr>
+          <p:cNvPr id="41" name="Picture 40" descr="Shannon Hess"/>
+          <p:cNvPicPr>
+            <a:picLocks noChangeAspect="1"/>
+          </p:cNvPicPr>
+          <p:nvPr/>
+        </p:nvPicPr>
+        <p:blipFill>
+          <a:blip r:embed="rId8"/>
+          <a:srcRect/>
+          <a:stretch>
+            <a:fillRect/>
+          </a:stretch>
+        </p:blipFill>
+        <p:spPr>
+          <a:xfrm>
+            <a:off x="8241506" y="1438275"/>
+            <a:ext cx="1143000" cy="1143000"/>
+          </a:xfrm>
+          <a:prstGeom prst="ellipse">
+            <a:avLst/>
+          </a:prstGeom>
+        </p:spPr>
+      </p:pic>
+      <p:sp>
+        <p:nvSpPr>
+          <p:cNvPr id="42" name="Text: Shannon Hess"/>
+          <p:cNvSpPr txBox="1"/>
+          <p:nvPr/>
+        </p:nvSpPr>
+        <p:spPr>
+          <a:xfrm>
+            <a:off x="8244632" y="2714625"/>
+            <a:ext cx="1150888" cy="228600"/>
+          </a:xfrm>
+          <a:prstGeom prst="rect">
+            <a:avLst/>
+          </a:prstGeom>
+          <a:noFill/>
+        </p:spPr>
+        <p:txBody>
+          <a:bodyPr wrap="square" lIns="0" tIns="0" rIns="0" bIns="0" anchor="t">
+            <a:spAutoFit/>
+          </a:bodyPr>
+          <a:lstStyle/>
+          <a:p>
+            <a:pPr algn="ctr">
+              <a:lnSpc>
+                <a:spcPts val="1800"/>
+              </a:lnSpc>
+            </a:pPr>
+            <a:r>
+              <a:rPr sz="1425" b="1" i="0">
+                <a:solidFill>
+                  <a:srgbClr val="1B1A1A"/>
+                </a:solidFill>
+                <a:latin typeface="Cambria"/>
+              </a:rPr>
+              <a:t>Shannon Hess</a:t>
+            </a:r>
+          </a:p>
+        </p:txBody>
+      </p:sp>
+      <p:sp>
+        <p:nvSpPr>
+          <p:cNvPr id="43" name="Text: CLIENT ENGAGEMENT DIRECTOR"/>
+          <p:cNvSpPr txBox="1"/>
+          <p:nvPr/>
+        </p:nvSpPr>
+        <p:spPr>
+          <a:xfrm>
+            <a:off x="8092827" y="2971800"/>
+            <a:ext cx="1454497" cy="123825"/>
+          </a:xfrm>
+          <a:prstGeom prst="rect">
+            <a:avLst/>
+          </a:prstGeom>
+          <a:noFill/>
+        </p:spPr>
+        <p:txBody>
+          <a:bodyPr wrap="square" lIns="0" tIns="0" rIns="0" bIns="0" anchor="t">
+            <a:spAutoFit/>
+          </a:bodyPr>
+          <a:lstStyle/>
+          <a:p>
+            <a:pPr algn="ctr">
+              <a:lnSpc>
+                <a:spcPts val="975"/>
+              </a:lnSpc>
+            </a:pPr>
+            <a:r>
+              <a:rPr sz="638" b="1" i="0" spc="105">
+                <a:solidFill>
+                  <a:srgbClr val="8C6239"/>
+                </a:solidFill>
+                <a:latin typeface="Calibri"/>
+              </a:rPr>
+              <a:t>CLIENT ENGAGEMENT DIRECTOR</a:t>
+            </a:r>
+          </a:p>
+        </p:txBody>
+      </p:sp>
+      <p:sp>
+        <p:nvSpPr>
+          <p:cNvPr id="44" name="Rectangle 43"/>
+          <p:cNvSpPr/>
+          <p:nvPr/>
+        </p:nvSpPr>
+        <p:spPr>
+          <a:xfrm>
+            <a:off x="2628900" y="4019550"/>
+            <a:ext cx="2247900" cy="742950"/>
+          </a:xfrm>
+          <a:prstGeom prst="rect">
+            <a:avLst/>
+          </a:prstGeom>
+          <a:solidFill>
+            <a:srgbClr val="FFFFFF"/>
+          </a:solidFill>
+          <a:ln>
+            <a:noFill/>
+          </a:ln>
+          <a:effectLst/>
+        </p:spPr>
+        <p:txBody>
+          <a:bodyPr rtlCol="0" anchor="ctr"/>
+          <a:lstStyle/>
+          <a:p>
+            <a:pPr algn="ctr"/>
+            <a:endParaRPr/>
+          </a:p>
+        </p:txBody>
+      </p:sp>
+      <p:sp>
+        <p:nvSpPr>
+          <p:cNvPr id="45" name="Rectangle 44"/>
+          <p:cNvSpPr/>
+          <p:nvPr/>
+        </p:nvSpPr>
+        <p:spPr>
+          <a:xfrm>
+            <a:off x="2628900" y="4019550"/>
+            <a:ext cx="2247900" cy="9525"/>
+          </a:xfrm>
+          <a:prstGeom prst="rect">
+            <a:avLst/>
+          </a:prstGeom>
+          <a:solidFill>
+            <a:srgbClr val="E3DCD3"/>
+          </a:solidFill>
+          <a:ln>
+            <a:noFill/>
+          </a:ln>
+          <a:effectLst/>
+        </p:spPr>
+        <p:txBody>
+          <a:bodyPr rtlCol="0" anchor="ctr"/>
+          <a:lstStyle/>
+          <a:p>
+            <a:pPr algn="ctr"/>
+            <a:endParaRPr/>
+          </a:p>
+        </p:txBody>
+      </p:sp>
+      <p:sp>
+        <p:nvSpPr>
+          <p:cNvPr id="46" name="Rectangle 45"/>
+          <p:cNvSpPr/>
+          <p:nvPr/>
+        </p:nvSpPr>
+        <p:spPr>
+          <a:xfrm>
+            <a:off x="4867275" y="4019550"/>
+            <a:ext cx="9525" cy="742950"/>
+          </a:xfrm>
+          <a:prstGeom prst="rect">
+            <a:avLst/>
+          </a:prstGeom>
+          <a:solidFill>
+            <a:srgbClr val="E3DCD3"/>
+          </a:solidFill>
+          <a:ln>
+            <a:noFill/>
+          </a:ln>
+          <a:effectLst/>
+        </p:spPr>
+        <p:txBody>
+          <a:bodyPr rtlCol="0" anchor="ctr"/>
+          <a:lstStyle/>
+          <a:p>
+            <a:pPr algn="ctr"/>
+            <a:endParaRPr/>
+          </a:p>
+        </p:txBody>
+      </p:sp>
+      <p:sp>
+        <p:nvSpPr>
+          <p:cNvPr id="47" name="Rectangle 46"/>
+          <p:cNvSpPr/>
+          <p:nvPr/>
+        </p:nvSpPr>
+        <p:spPr>
+          <a:xfrm>
+            <a:off x="2628900" y="4752975"/>
+            <a:ext cx="2247900" cy="9525"/>
+          </a:xfrm>
+          <a:prstGeom prst="rect">
+            <a:avLst/>
+          </a:prstGeom>
+          <a:solidFill>
+            <a:srgbClr val="E3DCD3"/>
+          </a:solidFill>
+          <a:ln>
+            <a:noFill/>
+          </a:ln>
+          <a:effectLst/>
+        </p:spPr>
+        <p:txBody>
+          <a:bodyPr rtlCol="0" anchor="ctr"/>
+          <a:lstStyle/>
+          <a:p>
+            <a:pPr algn="ctr"/>
+            <a:endParaRPr/>
+          </a:p>
+        </p:txBody>
+      </p:sp>
+      <p:sp>
+        <p:nvSpPr>
+          <p:cNvPr id="48" name="Rectangle 47"/>
+          <p:cNvSpPr/>
+          <p:nvPr/>
+        </p:nvSpPr>
+        <p:spPr>
+          <a:xfrm>
+            <a:off x="2628900" y="4019550"/>
+            <a:ext cx="9525" cy="742950"/>
+          </a:xfrm>
+          <a:prstGeom prst="rect">
+            <a:avLst/>
+          </a:prstGeom>
+          <a:solidFill>
+            <a:srgbClr val="E3DCD3"/>
+          </a:solidFill>
+          <a:ln>
+            <a:noFill/>
+          </a:ln>
+          <a:effectLst/>
+        </p:spPr>
+        <p:txBody>
+          <a:bodyPr rtlCol="0" anchor="ctr"/>
+          <a:lstStyle/>
+          <a:p>
+            <a:pPr algn="ctr"/>
+            <a:endParaRPr/>
+          </a:p>
+        </p:txBody>
+      </p:sp>
+      <p:pic>
+        <p:nvPicPr>
+          <p:cNvPr id="49" name="Picture 48" descr="Sunny Garten"/>
+          <p:cNvPicPr>
+            <a:picLocks noChangeAspect="1"/>
+          </p:cNvPicPr>
+          <p:nvPr/>
+        </p:nvPicPr>
+        <p:blipFill>
+          <a:blip r:embed="rId9"/>
+          <a:srcRect/>
+          <a:stretch>
+            <a:fillRect/>
+          </a:stretch>
+        </p:blipFill>
+        <p:spPr>
+          <a:xfrm>
+            <a:off x="2752725" y="4133850"/>
+            <a:ext cx="514350" cy="514350"/>
+          </a:xfrm>
+          <a:prstGeom prst="ellipse">
+            <a:avLst/>
+          </a:prstGeom>
+        </p:spPr>
+      </p:pic>
+      <p:sp>
+        <p:nvSpPr>
+          <p:cNvPr id="50" name="Text: Sunny Garten"/>
+          <p:cNvSpPr txBox="1"/>
+          <p:nvPr/>
+        </p:nvSpPr>
+        <p:spPr>
+          <a:xfrm>
+            <a:off x="3381375" y="4095750"/>
+            <a:ext cx="1419225" cy="152400"/>
+          </a:xfrm>
+          <a:prstGeom prst="rect">
+            <a:avLst/>
+          </a:prstGeom>
+          <a:noFill/>
+        </p:spPr>
+        <p:txBody>
+          <a:bodyPr wrap="square" lIns="0" tIns="0" rIns="0" bIns="0" anchor="t">
+            <a:spAutoFit/>
+          </a:bodyPr>
+          <a:lstStyle/>
+          <a:p>
+            <a:pPr algn="l">
+              <a:lnSpc>
+                <a:spcPts val="1200"/>
+              </a:lnSpc>
+            </a:pPr>
+            <a:r>
+              <a:rPr sz="900" b="1" i="0" spc="15">
+                <a:solidFill>
+                  <a:srgbClr val="1B1A1A"/>
+                </a:solidFill>
+                <a:latin typeface="Calibri"/>
+              </a:rPr>
+              <a:t>Sunny Garten</a:t>
+            </a:r>
+          </a:p>
+        </p:txBody>
+      </p:sp>
+      <p:sp>
+        <p:nvSpPr>
+          <p:cNvPr id="51" name="Text: Senior Deal Associate"/>
+          <p:cNvSpPr txBox="1"/>
+          <p:nvPr/>
+        </p:nvSpPr>
+        <p:spPr>
+          <a:xfrm>
+            <a:off x="3381375" y="4248150"/>
+            <a:ext cx="1419225" cy="133350"/>
+          </a:xfrm>
+          <a:prstGeom prst="rect">
+            <a:avLst/>
+          </a:prstGeom>
+          <a:noFill/>
+        </p:spPr>
+        <p:txBody>
+          <a:bodyPr wrap="square" lIns="0" tIns="0" rIns="0" bIns="0" anchor="t">
+            <a:spAutoFit/>
+          </a:bodyPr>
+          <a:lstStyle/>
+          <a:p>
+            <a:pPr algn="l">
+              <a:lnSpc>
+                <a:spcPts val="1050"/>
+              </a:lnSpc>
+            </a:pPr>
+            <a:r>
+              <a:rPr sz="750" b="0" i="0" spc="15">
+                <a:solidFill>
+                  <a:srgbClr val="6F6A66"/>
+                </a:solidFill>
+                <a:latin typeface="Calibri"/>
+              </a:rPr>
+              <a:t>Senior Deal Associate</a:t>
+            </a:r>
+          </a:p>
+        </p:txBody>
+      </p:sp>
+      <p:sp>
+        <p:nvSpPr>
+          <p:cNvPr id="52" name="Rectangle 51"/>
+          <p:cNvSpPr/>
+          <p:nvPr/>
+        </p:nvSpPr>
+        <p:spPr>
+          <a:xfrm>
+            <a:off x="5010150" y="4019550"/>
+            <a:ext cx="2247900" cy="742950"/>
+          </a:xfrm>
+          <a:prstGeom prst="rect">
+            <a:avLst/>
+          </a:prstGeom>
+          <a:solidFill>
+            <a:srgbClr val="FFFFFF"/>
+          </a:solidFill>
+          <a:ln>
+            <a:noFill/>
+          </a:ln>
+          <a:effectLst/>
+        </p:spPr>
+        <p:txBody>
+          <a:bodyPr rtlCol="0" anchor="ctr"/>
+          <a:lstStyle/>
+          <a:p>
+            <a:pPr algn="ctr"/>
+            <a:endParaRPr/>
+          </a:p>
+        </p:txBody>
+      </p:sp>
+      <p:sp>
+        <p:nvSpPr>
+          <p:cNvPr id="53" name="Rectangle 52"/>
+          <p:cNvSpPr/>
+          <p:nvPr/>
+        </p:nvSpPr>
+        <p:spPr>
+          <a:xfrm>
+            <a:off x="5010150" y="4019550"/>
+            <a:ext cx="2247900" cy="9525"/>
+          </a:xfrm>
+          <a:prstGeom prst="rect">
+            <a:avLst/>
+          </a:prstGeom>
+          <a:solidFill>
+            <a:srgbClr val="E3DCD3"/>
+          </a:solidFill>
+          <a:ln>
+            <a:noFill/>
+          </a:ln>
+          <a:effectLst/>
+        </p:spPr>
+        <p:txBody>
+          <a:bodyPr rtlCol="0" anchor="ctr"/>
+          <a:lstStyle/>
+          <a:p>
+            <a:pPr algn="ctr"/>
+            <a:endParaRPr/>
+          </a:p>
+        </p:txBody>
+      </p:sp>
+      <p:sp>
+        <p:nvSpPr>
+          <p:cNvPr id="54" name="Rectangle 53"/>
+          <p:cNvSpPr/>
+          <p:nvPr/>
+        </p:nvSpPr>
+        <p:spPr>
+          <a:xfrm>
+            <a:off x="7248525" y="4019550"/>
+            <a:ext cx="9525" cy="742950"/>
+          </a:xfrm>
+          <a:prstGeom prst="rect">
+            <a:avLst/>
+          </a:prstGeom>
+          <a:solidFill>
+            <a:srgbClr val="E3DCD3"/>
+          </a:solidFill>
+          <a:ln>
+            <a:noFill/>
+          </a:ln>
+          <a:effectLst/>
+        </p:spPr>
+        <p:txBody>
+          <a:bodyPr rtlCol="0" anchor="ctr"/>
+          <a:lstStyle/>
+          <a:p>
+            <a:pPr algn="ctr"/>
+            <a:endParaRPr/>
+          </a:p>
+        </p:txBody>
+      </p:sp>
+      <p:sp>
+        <p:nvSpPr>
+          <p:cNvPr id="55" name="Rectangle 54"/>
+          <p:cNvSpPr/>
+          <p:nvPr/>
+        </p:nvSpPr>
+        <p:spPr>
+          <a:xfrm>
+            <a:off x="5010150" y="4752975"/>
+            <a:ext cx="2247900" cy="9525"/>
+          </a:xfrm>
+          <a:prstGeom prst="rect">
+            <a:avLst/>
+          </a:prstGeom>
+          <a:solidFill>
+            <a:srgbClr val="E3DCD3"/>
+          </a:solidFill>
+          <a:ln>
+            <a:noFill/>
+          </a:ln>
+          <a:effectLst/>
+        </p:spPr>
+        <p:txBody>
+          <a:bodyPr rtlCol="0" anchor="ctr"/>
+          <a:lstStyle/>
+          <a:p>
+            <a:pPr algn="ctr"/>
+            <a:endParaRPr/>
+          </a:p>
+        </p:txBody>
+      </p:sp>
+      <p:sp>
+        <p:nvSpPr>
+          <p:cNvPr id="56" name="Rectangle 55"/>
+          <p:cNvSpPr/>
+          <p:nvPr/>
+        </p:nvSpPr>
+        <p:spPr>
+          <a:xfrm>
+            <a:off x="5010150" y="4019550"/>
+            <a:ext cx="9525" cy="742950"/>
+          </a:xfrm>
+          <a:prstGeom prst="rect">
+            <a:avLst/>
+          </a:prstGeom>
+          <a:solidFill>
+            <a:srgbClr val="E3DCD3"/>
+          </a:solidFill>
+          <a:ln>
+            <a:noFill/>
+          </a:ln>
+          <a:effectLst/>
+        </p:spPr>
+        <p:txBody>
+          <a:bodyPr rtlCol="0" anchor="ctr"/>
+          <a:lstStyle/>
+          <a:p>
+            <a:pPr algn="ctr"/>
+            <a:endParaRPr/>
+          </a:p>
+        </p:txBody>
+      </p:sp>
+      <p:pic>
+        <p:nvPicPr>
+          <p:cNvPr id="57" name="Picture 56" descr="Michael Wynn"/>
+          <p:cNvPicPr>
+            <a:picLocks noChangeAspect="1"/>
+          </p:cNvPicPr>
+          <p:nvPr/>
+        </p:nvPicPr>
+        <p:blipFill>
+          <a:blip r:embed="rId10"/>
+          <a:srcRect/>
+          <a:stretch>
+            <a:fillRect/>
+          </a:stretch>
+        </p:blipFill>
+        <p:spPr>
+          <a:xfrm>
+            <a:off x="5133975" y="4133850"/>
+            <a:ext cx="514350" cy="514350"/>
+          </a:xfrm>
+          <a:prstGeom prst="ellipse">
+            <a:avLst/>
+          </a:prstGeom>
+        </p:spPr>
+      </p:pic>
+      <p:sp>
+        <p:nvSpPr>
+          <p:cNvPr id="58" name="Text: Michael Wynn"/>
+          <p:cNvSpPr txBox="1"/>
+          <p:nvPr/>
+        </p:nvSpPr>
+        <p:spPr>
+          <a:xfrm>
+            <a:off x="5762625" y="4095750"/>
+            <a:ext cx="1419225" cy="152400"/>
+          </a:xfrm>
+          <a:prstGeom prst="rect">
+            <a:avLst/>
+          </a:prstGeom>
+          <a:noFill/>
+        </p:spPr>
+        <p:txBody>
+          <a:bodyPr wrap="square" lIns="0" tIns="0" rIns="0" bIns="0" anchor="t">
+            <a:spAutoFit/>
+          </a:bodyPr>
+          <a:lstStyle/>
+          <a:p>
+            <a:pPr algn="l">
+              <a:lnSpc>
+                <a:spcPts val="1200"/>
+              </a:lnSpc>
+            </a:pPr>
+            <a:r>
+              <a:rPr sz="900" b="1" i="0" spc="15">
+                <a:solidFill>
+                  <a:srgbClr val="1B1A1A"/>
+                </a:solidFill>
+                <a:latin typeface="Calibri"/>
+              </a:rPr>
+              <a:t>Michael Wynn</a:t>
+            </a:r>
+          </a:p>
+        </p:txBody>
+      </p:sp>
+      <p:sp>
+        <p:nvSpPr>
+          <p:cNvPr id="59" name="Text: Senior Deal Associate"/>
+          <p:cNvSpPr txBox="1"/>
+          <p:nvPr/>
+        </p:nvSpPr>
+        <p:spPr>
+          <a:xfrm>
+            <a:off x="5762625" y="4248150"/>
+            <a:ext cx="1419225" cy="133350"/>
+          </a:xfrm>
+          <a:prstGeom prst="rect">
+            <a:avLst/>
+          </a:prstGeom>
+          <a:noFill/>
+        </p:spPr>
+        <p:txBody>
+          <a:bodyPr wrap="square" lIns="0" tIns="0" rIns="0" bIns="0" anchor="t">
+            <a:spAutoFit/>
+          </a:bodyPr>
+          <a:lstStyle/>
+          <a:p>
+            <a:pPr algn="l">
+              <a:lnSpc>
+                <a:spcPts val="1050"/>
+              </a:lnSpc>
+            </a:pPr>
+            <a:r>
+              <a:rPr sz="750" b="0" i="0" spc="15">
+                <a:solidFill>
+                  <a:srgbClr val="6F6A66"/>
+                </a:solidFill>
+                <a:latin typeface="Calibri"/>
+              </a:rPr>
+              <a:t>Senior Deal Associate</a:t>
+            </a:r>
+          </a:p>
+        </p:txBody>
+      </p:sp>
+      <p:sp>
+        <p:nvSpPr>
+          <p:cNvPr id="60" name="Rectangle 59"/>
+          <p:cNvSpPr/>
+          <p:nvPr/>
+        </p:nvSpPr>
+        <p:spPr>
+          <a:xfrm>
+            <a:off x="7391400" y="4019550"/>
+            <a:ext cx="2247900" cy="742950"/>
+          </a:xfrm>
+          <a:prstGeom prst="rect">
+            <a:avLst/>
+          </a:prstGeom>
+          <a:solidFill>
+            <a:srgbClr val="FFFFFF"/>
+          </a:solidFill>
+          <a:ln>
+            <a:noFill/>
+          </a:ln>
+          <a:effectLst/>
+        </p:spPr>
+        <p:txBody>
+          <a:bodyPr rtlCol="0" anchor="ctr"/>
+          <a:lstStyle/>
+          <a:p>
+            <a:pPr algn="ctr"/>
+            <a:endParaRPr/>
+          </a:p>
+        </p:txBody>
+      </p:sp>
+      <p:sp>
+        <p:nvSpPr>
+          <p:cNvPr id="61" name="Rectangle 60"/>
+          <p:cNvSpPr/>
+          <p:nvPr/>
+        </p:nvSpPr>
+        <p:spPr>
+          <a:xfrm>
+            <a:off x="7391400" y="4019550"/>
+            <a:ext cx="2247900" cy="9525"/>
+          </a:xfrm>
+          <a:prstGeom prst="rect">
+            <a:avLst/>
+          </a:prstGeom>
+          <a:solidFill>
+            <a:srgbClr val="E3DCD3"/>
+          </a:solidFill>
+          <a:ln>
+            <a:noFill/>
+          </a:ln>
+          <a:effectLst/>
+        </p:spPr>
+        <p:txBody>
+          <a:bodyPr rtlCol="0" anchor="ctr"/>
+          <a:lstStyle/>
+          <a:p>
+            <a:pPr algn="ctr"/>
+            <a:endParaRPr/>
+          </a:p>
+        </p:txBody>
+      </p:sp>
+      <p:sp>
+        <p:nvSpPr>
+          <p:cNvPr id="62" name="Rectangle 61"/>
+          <p:cNvSpPr/>
+          <p:nvPr/>
+        </p:nvSpPr>
+        <p:spPr>
+          <a:xfrm>
+            <a:off x="9629775" y="4019550"/>
+            <a:ext cx="9525" cy="742950"/>
+          </a:xfrm>
+          <a:prstGeom prst="rect">
+            <a:avLst/>
+          </a:prstGeom>
+          <a:solidFill>
+            <a:srgbClr val="E3DCD3"/>
+          </a:solidFill>
+          <a:ln>
+            <a:noFill/>
+          </a:ln>
+          <a:effectLst/>
+        </p:spPr>
+        <p:txBody>
+          <a:bodyPr rtlCol="0" anchor="ctr"/>
+          <a:lstStyle/>
+          <a:p>
+            <a:pPr algn="ctr"/>
+            <a:endParaRPr/>
+          </a:p>
+        </p:txBody>
+      </p:sp>
+      <p:sp>
+        <p:nvSpPr>
+          <p:cNvPr id="63" name="Rectangle 62"/>
+          <p:cNvSpPr/>
+          <p:nvPr/>
+        </p:nvSpPr>
+        <p:spPr>
+          <a:xfrm>
+            <a:off x="7391400" y="4752975"/>
+            <a:ext cx="2247900" cy="9525"/>
+          </a:xfrm>
+          <a:prstGeom prst="rect">
+            <a:avLst/>
+          </a:prstGeom>
+          <a:solidFill>
+            <a:srgbClr val="E3DCD3"/>
+          </a:solidFill>
+          <a:ln>
+            <a:noFill/>
+          </a:ln>
+          <a:effectLst/>
+        </p:spPr>
+        <p:txBody>
+          <a:bodyPr rtlCol="0" anchor="ctr"/>
+          <a:lstStyle/>
+          <a:p>
+            <a:pPr algn="ctr"/>
+            <a:endParaRPr/>
+          </a:p>
+        </p:txBody>
+      </p:sp>
+      <p:sp>
+        <p:nvSpPr>
+          <p:cNvPr id="64" name="Rectangle 63"/>
+          <p:cNvSpPr/>
+          <p:nvPr/>
+        </p:nvSpPr>
+        <p:spPr>
+          <a:xfrm>
+            <a:off x="7391400" y="4019550"/>
+            <a:ext cx="9525" cy="742950"/>
+          </a:xfrm>
+          <a:prstGeom prst="rect">
+            <a:avLst/>
+          </a:prstGeom>
+          <a:solidFill>
+            <a:srgbClr val="E3DCD3"/>
+          </a:solidFill>
+          <a:ln>
+            <a:noFill/>
+          </a:ln>
+          <a:effectLst/>
+        </p:spPr>
+        <p:txBody>
+          <a:bodyPr rtlCol="0" anchor="ctr"/>
+          <a:lstStyle/>
+          <a:p>
+            <a:pPr algn="ctr"/>
+            <a:endParaRPr/>
+          </a:p>
+        </p:txBody>
+      </p:sp>
+      <p:pic>
+        <p:nvPicPr>
+          <p:cNvPr id="65" name="Picture 64" descr="Jason Lisiak"/>
+          <p:cNvPicPr>
+            <a:picLocks noChangeAspect="1"/>
+          </p:cNvPicPr>
+          <p:nvPr/>
+        </p:nvPicPr>
+        <p:blipFill>
+          <a:blip r:embed="rId11"/>
+          <a:srcRect/>
+          <a:stretch>
+            <a:fillRect/>
+          </a:stretch>
+        </p:blipFill>
+        <p:spPr>
+          <a:xfrm>
+            <a:off x="7515225" y="4133850"/>
+            <a:ext cx="514350" cy="514350"/>
+          </a:xfrm>
+          <a:prstGeom prst="ellipse">
+            <a:avLst/>
+          </a:prstGeom>
+        </p:spPr>
+      </p:pic>
+      <p:sp>
+        <p:nvSpPr>
+          <p:cNvPr id="66" name="Text: Jason Lisiak"/>
+          <p:cNvSpPr txBox="1"/>
+          <p:nvPr/>
+        </p:nvSpPr>
+        <p:spPr>
+          <a:xfrm>
+            <a:off x="8143875" y="4095750"/>
+            <a:ext cx="1419225" cy="152400"/>
+          </a:xfrm>
+          <a:prstGeom prst="rect">
+            <a:avLst/>
+          </a:prstGeom>
+          <a:noFill/>
+        </p:spPr>
+        <p:txBody>
+          <a:bodyPr wrap="square" lIns="0" tIns="0" rIns="0" bIns="0" anchor="t">
+            <a:spAutoFit/>
+          </a:bodyPr>
+          <a:lstStyle/>
+          <a:p>
+            <a:pPr algn="l">
+              <a:lnSpc>
+                <a:spcPts val="1200"/>
+              </a:lnSpc>
+            </a:pPr>
+            <a:r>
+              <a:rPr sz="900" b="1" i="0" spc="15">
+                <a:solidFill>
+                  <a:srgbClr val="1B1A1A"/>
+                </a:solidFill>
+                <a:latin typeface="Calibri"/>
+              </a:rPr>
+              <a:t>Jason Lisiak</a:t>
+            </a:r>
+          </a:p>
+        </p:txBody>
+      </p:sp>
+      <p:sp>
+        <p:nvSpPr>
+          <p:cNvPr id="67" name="Text: Research Associate"/>
+          <p:cNvSpPr txBox="1"/>
+          <p:nvPr/>
+        </p:nvSpPr>
+        <p:spPr>
+          <a:xfrm>
+            <a:off x="8143875" y="4248150"/>
+            <a:ext cx="1419225" cy="133350"/>
+          </a:xfrm>
+          <a:prstGeom prst="rect">
+            <a:avLst/>
+          </a:prstGeom>
+          <a:noFill/>
+        </p:spPr>
+        <p:txBody>
+          <a:bodyPr wrap="square" lIns="0" tIns="0" rIns="0" bIns="0" anchor="t">
+            <a:spAutoFit/>
+          </a:bodyPr>
+          <a:lstStyle/>
+          <a:p>
+            <a:pPr algn="l">
+              <a:lnSpc>
+                <a:spcPts val="1050"/>
+              </a:lnSpc>
+            </a:pPr>
+            <a:r>
+              <a:rPr sz="750" b="0" i="0" spc="15">
+                <a:solidFill>
+                  <a:srgbClr val="6F6A66"/>
+                </a:solidFill>
+                <a:latin typeface="Calibri"/>
+              </a:rPr>
+              <a:t>Research Associate</a:t>
+            </a:r>
+          </a:p>
+        </p:txBody>
+      </p:sp>
+      <p:sp>
+        <p:nvSpPr>
+          <p:cNvPr id="68" name="Rectangle 67"/>
+          <p:cNvSpPr/>
+          <p:nvPr/>
+        </p:nvSpPr>
+        <p:spPr>
+          <a:xfrm>
+            <a:off x="2628900" y="4876800"/>
+            <a:ext cx="2247900" cy="742950"/>
+          </a:xfrm>
+          <a:prstGeom prst="rect">
+            <a:avLst/>
+          </a:prstGeom>
+          <a:solidFill>
+            <a:srgbClr val="FFFFFF"/>
+          </a:solidFill>
+          <a:ln>
+            <a:noFill/>
+          </a:ln>
+          <a:effectLst/>
+        </p:spPr>
+        <p:txBody>
+          <a:bodyPr rtlCol="0" anchor="ctr"/>
+          <a:lstStyle/>
+          <a:p>
+            <a:pPr algn="ctr"/>
+            <a:endParaRPr/>
+          </a:p>
+        </p:txBody>
+      </p:sp>
+      <p:sp>
+        <p:nvSpPr>
+          <p:cNvPr id="69" name="Rectangle 68"/>
+          <p:cNvSpPr/>
+          <p:nvPr/>
+        </p:nvSpPr>
+        <p:spPr>
+          <a:xfrm>
+            <a:off x="2628900" y="4876800"/>
+            <a:ext cx="2247900" cy="9525"/>
+          </a:xfrm>
+          <a:prstGeom prst="rect">
+            <a:avLst/>
+          </a:prstGeom>
+          <a:solidFill>
+            <a:srgbClr val="E3DCD3"/>
+          </a:solidFill>
+          <a:ln>
+            <a:noFill/>
+          </a:ln>
+          <a:effectLst/>
+        </p:spPr>
+        <p:txBody>
+          <a:bodyPr rtlCol="0" anchor="ctr"/>
+          <a:lstStyle/>
+          <a:p>
+            <a:pPr algn="ctr"/>
+            <a:endParaRPr/>
+          </a:p>
+        </p:txBody>
+      </p:sp>
+      <p:sp>
+        <p:nvSpPr>
+          <p:cNvPr id="70" name="Rectangle 69"/>
+          <p:cNvSpPr/>
+          <p:nvPr/>
+        </p:nvSpPr>
+        <p:spPr>
+          <a:xfrm>
+            <a:off x="4867275" y="4876800"/>
+            <a:ext cx="9525" cy="742950"/>
+          </a:xfrm>
+          <a:prstGeom prst="rect">
+            <a:avLst/>
+          </a:prstGeom>
+          <a:solidFill>
+            <a:srgbClr val="E3DCD3"/>
+          </a:solidFill>
+          <a:ln>
+            <a:noFill/>
+          </a:ln>
+          <a:effectLst/>
+        </p:spPr>
+        <p:txBody>
+          <a:bodyPr rtlCol="0" anchor="ctr"/>
+          <a:lstStyle/>
+          <a:p>
+            <a:pPr algn="ctr"/>
+            <a:endParaRPr/>
+          </a:p>
+        </p:txBody>
+      </p:sp>
+      <p:sp>
+        <p:nvSpPr>
+          <p:cNvPr id="71" name="Rectangle 70"/>
+          <p:cNvSpPr/>
+          <p:nvPr/>
+        </p:nvSpPr>
+        <p:spPr>
+          <a:xfrm>
+            <a:off x="2628900" y="5610225"/>
+            <a:ext cx="2247900" cy="9525"/>
+          </a:xfrm>
+          <a:prstGeom prst="rect">
+            <a:avLst/>
+          </a:prstGeom>
+          <a:solidFill>
+            <a:srgbClr val="E3DCD3"/>
+          </a:solidFill>
+          <a:ln>
+            <a:noFill/>
+          </a:ln>
+          <a:effectLst/>
+        </p:spPr>
+        <p:txBody>
+          <a:bodyPr rtlCol="0" anchor="ctr"/>
+          <a:lstStyle/>
+          <a:p>
+            <a:pPr algn="ctr"/>
+            <a:endParaRPr/>
+          </a:p>
+        </p:txBody>
+      </p:sp>
+      <p:sp>
+        <p:nvSpPr>
+          <p:cNvPr id="72" name="Rectangle 71"/>
+          <p:cNvSpPr/>
+          <p:nvPr/>
+        </p:nvSpPr>
+        <p:spPr>
+          <a:xfrm>
+            <a:off x="2628900" y="4876800"/>
+            <a:ext cx="9525" cy="742950"/>
+          </a:xfrm>
+          <a:prstGeom prst="rect">
+            <a:avLst/>
+          </a:prstGeom>
+          <a:solidFill>
+            <a:srgbClr val="E3DCD3"/>
+          </a:solidFill>
+          <a:ln>
+            <a:noFill/>
+          </a:ln>
+          <a:effectLst/>
+        </p:spPr>
+        <p:txBody>
+          <a:bodyPr rtlCol="0" anchor="ctr"/>
+          <a:lstStyle/>
+          <a:p>
+            <a:pPr algn="ctr"/>
+            <a:endParaRPr/>
+          </a:p>
+        </p:txBody>
+      </p:sp>
+      <p:pic>
+        <p:nvPicPr>
+          <p:cNvPr id="73" name="Picture 72" descr="Alexandra Barr"/>
+          <p:cNvPicPr>
+            <a:picLocks noChangeAspect="1"/>
+          </p:cNvPicPr>
+          <p:nvPr/>
+        </p:nvPicPr>
+        <p:blipFill>
+          <a:blip r:embed="rId12"/>
+          <a:srcRect/>
+          <a:stretch>
+            <a:fillRect/>
+          </a:stretch>
+        </p:blipFill>
+        <p:spPr>
+          <a:xfrm>
+            <a:off x="2752725" y="4991100"/>
+            <a:ext cx="514350" cy="514350"/>
+          </a:xfrm>
+          <a:prstGeom prst="ellipse">
+            <a:avLst/>
+          </a:prstGeom>
+        </p:spPr>
+      </p:pic>
+      <p:sp>
+        <p:nvSpPr>
+          <p:cNvPr id="74" name="Text: Alexandra Barr"/>
+          <p:cNvSpPr txBox="1"/>
+          <p:nvPr/>
+        </p:nvSpPr>
+        <p:spPr>
+          <a:xfrm>
+            <a:off x="3381375" y="4953000"/>
+            <a:ext cx="1419225" cy="152400"/>
+          </a:xfrm>
+          <a:prstGeom prst="rect">
+            <a:avLst/>
+          </a:prstGeom>
+          <a:noFill/>
+        </p:spPr>
+        <p:txBody>
+          <a:bodyPr wrap="square" lIns="0" tIns="0" rIns="0" bIns="0" anchor="t">
+            <a:spAutoFit/>
+          </a:bodyPr>
+          <a:lstStyle/>
+          <a:p>
+            <a:pPr algn="l">
+              <a:lnSpc>
+                <a:spcPts val="1200"/>
+              </a:lnSpc>
+            </a:pPr>
+            <a:r>
+              <a:rPr sz="900" b="1" i="0" spc="15">
+                <a:solidFill>
+                  <a:srgbClr val="1B1A1A"/>
+                </a:solidFill>
+                <a:latin typeface="Calibri"/>
+              </a:rPr>
+              <a:t>Alexandra Barr</a:t>
+            </a:r>
+          </a:p>
+        </p:txBody>
+      </p:sp>
+      <p:sp>
+        <p:nvSpPr>
+          <p:cNvPr id="75" name="Text: Transaction Support Associate"/>
+          <p:cNvSpPr txBox="1"/>
+          <p:nvPr/>
+        </p:nvSpPr>
+        <p:spPr>
+          <a:xfrm>
+            <a:off x="3381375" y="5105400"/>
+            <a:ext cx="1419225" cy="133350"/>
+          </a:xfrm>
+          <a:prstGeom prst="rect">
+            <a:avLst/>
+          </a:prstGeom>
+          <a:noFill/>
+        </p:spPr>
+        <p:txBody>
+          <a:bodyPr wrap="square" lIns="0" tIns="0" rIns="0" bIns="0" anchor="t">
+            <a:spAutoFit/>
+          </a:bodyPr>
+          <a:lstStyle/>
+          <a:p>
+            <a:pPr algn="l">
+              <a:lnSpc>
+                <a:spcPts val="1050"/>
+              </a:lnSpc>
+            </a:pPr>
+            <a:r>
+              <a:rPr sz="750" b="0" i="0" spc="15">
+                <a:solidFill>
+                  <a:srgbClr val="6F6A66"/>
+                </a:solidFill>
+                <a:latin typeface="Calibri"/>
+              </a:rPr>
+              <a:t>Transaction Support Associate</a:t>
+            </a:r>
+          </a:p>
+        </p:txBody>
+      </p:sp>
+      <p:sp>
+        <p:nvSpPr>
+          <p:cNvPr id="76" name="Rectangle 75"/>
+          <p:cNvSpPr/>
+          <p:nvPr/>
+        </p:nvSpPr>
+        <p:spPr>
+          <a:xfrm>
+            <a:off x="5010150" y="4876800"/>
+            <a:ext cx="2247900" cy="742950"/>
+          </a:xfrm>
+          <a:prstGeom prst="rect">
+            <a:avLst/>
+          </a:prstGeom>
+          <a:solidFill>
+            <a:srgbClr val="FFFFFF"/>
+          </a:solidFill>
+          <a:ln>
+            <a:noFill/>
+          </a:ln>
+          <a:effectLst/>
+        </p:spPr>
+        <p:txBody>
+          <a:bodyPr rtlCol="0" anchor="ctr"/>
+          <a:lstStyle/>
+          <a:p>
+            <a:pPr algn="ctr"/>
+            <a:endParaRPr/>
+          </a:p>
+        </p:txBody>
+      </p:sp>
+      <p:sp>
+        <p:nvSpPr>
+          <p:cNvPr id="77" name="Rectangle 76"/>
+          <p:cNvSpPr/>
+          <p:nvPr/>
+        </p:nvSpPr>
+        <p:spPr>
+          <a:xfrm>
+            <a:off x="5010150" y="4876800"/>
+            <a:ext cx="2247900" cy="9525"/>
+          </a:xfrm>
+          <a:prstGeom prst="rect">
+            <a:avLst/>
+          </a:prstGeom>
+          <a:solidFill>
+            <a:srgbClr val="E3DCD3"/>
+          </a:solidFill>
+          <a:ln>
+            <a:noFill/>
+          </a:ln>
+          <a:effectLst/>
+        </p:spPr>
+        <p:txBody>
+          <a:bodyPr rtlCol="0" anchor="ctr"/>
+          <a:lstStyle/>
+          <a:p>
+            <a:pPr algn="ctr"/>
+            <a:endParaRPr/>
+          </a:p>
+        </p:txBody>
+      </p:sp>
+      <p:sp>
+        <p:nvSpPr>
+          <p:cNvPr id="78" name="Rectangle 77"/>
+          <p:cNvSpPr/>
+          <p:nvPr/>
+        </p:nvSpPr>
+        <p:spPr>
+          <a:xfrm>
+            <a:off x="7248525" y="4876800"/>
+            <a:ext cx="9525" cy="742950"/>
+          </a:xfrm>
+          <a:prstGeom prst="rect">
+            <a:avLst/>
+          </a:prstGeom>
+          <a:solidFill>
+            <a:srgbClr val="E3DCD3"/>
+          </a:solidFill>
+          <a:ln>
+            <a:noFill/>
+          </a:ln>
+          <a:effectLst/>
+        </p:spPr>
+        <p:txBody>
+          <a:bodyPr rtlCol="0" anchor="ctr"/>
+          <a:lstStyle/>
+          <a:p>
+            <a:pPr algn="ctr"/>
+            <a:endParaRPr/>
+          </a:p>
+        </p:txBody>
+      </p:sp>
+      <p:sp>
+        <p:nvSpPr>
+          <p:cNvPr id="79" name="Rectangle 78"/>
+          <p:cNvSpPr/>
+          <p:nvPr/>
+        </p:nvSpPr>
+        <p:spPr>
+          <a:xfrm>
+            <a:off x="5010150" y="5610225"/>
+            <a:ext cx="2247900" cy="9525"/>
+          </a:xfrm>
+          <a:prstGeom prst="rect">
+            <a:avLst/>
+          </a:prstGeom>
+          <a:solidFill>
+            <a:srgbClr val="E3DCD3"/>
+          </a:solidFill>
+          <a:ln>
+            <a:noFill/>
+          </a:ln>
+          <a:effectLst/>
+        </p:spPr>
+        <p:txBody>
+          <a:bodyPr rtlCol="0" anchor="ctr"/>
+          <a:lstStyle/>
+          <a:p>
+            <a:pPr algn="ctr"/>
+            <a:endParaRPr/>
+          </a:p>
+        </p:txBody>
+      </p:sp>
+      <p:sp>
+        <p:nvSpPr>
+          <p:cNvPr id="80" name="Rectangle 79"/>
+          <p:cNvSpPr/>
+          <p:nvPr/>
+        </p:nvSpPr>
+        <p:spPr>
+          <a:xfrm>
+            <a:off x="5010150" y="4876800"/>
+            <a:ext cx="9525" cy="742950"/>
+          </a:xfrm>
+          <a:prstGeom prst="rect">
+            <a:avLst/>
+          </a:prstGeom>
+          <a:solidFill>
+            <a:srgbClr val="E3DCD3"/>
+          </a:solidFill>
+          <a:ln>
+            <a:noFill/>
+          </a:ln>
+          <a:effectLst/>
+        </p:spPr>
+        <p:txBody>
+          <a:bodyPr rtlCol="0" anchor="ctr"/>
+          <a:lstStyle/>
+          <a:p>
+            <a:pPr algn="ctr"/>
+            <a:endParaRPr/>
+          </a:p>
+        </p:txBody>
+      </p:sp>
+      <p:pic>
+        <p:nvPicPr>
+          <p:cNvPr id="81" name="Picture 80" descr="Josiah Warren"/>
+          <p:cNvPicPr>
+            <a:picLocks noChangeAspect="1"/>
+          </p:cNvPicPr>
+          <p:nvPr/>
+        </p:nvPicPr>
+        <p:blipFill>
+          <a:blip r:embed="rId13"/>
+          <a:srcRect/>
+          <a:stretch>
+            <a:fillRect/>
+          </a:stretch>
+        </p:blipFill>
+        <p:spPr>
+          <a:xfrm>
+            <a:off x="5133975" y="4991100"/>
+            <a:ext cx="514350" cy="514350"/>
+          </a:xfrm>
+          <a:prstGeom prst="ellipse">
+            <a:avLst/>
+          </a:prstGeom>
+        </p:spPr>
+      </p:pic>
+      <p:sp>
+        <p:nvSpPr>
+          <p:cNvPr id="82" name="Text: Josiah Warren"/>
+          <p:cNvSpPr txBox="1"/>
+          <p:nvPr/>
+        </p:nvSpPr>
+        <p:spPr>
+          <a:xfrm>
+            <a:off x="5762625" y="4953000"/>
+            <a:ext cx="1419225" cy="152400"/>
+          </a:xfrm>
+          <a:prstGeom prst="rect">
+            <a:avLst/>
+          </a:prstGeom>
+          <a:noFill/>
+        </p:spPr>
+        <p:txBody>
+          <a:bodyPr wrap="square" lIns="0" tIns="0" rIns="0" bIns="0" anchor="t">
+            <a:spAutoFit/>
+          </a:bodyPr>
+          <a:lstStyle/>
+          <a:p>
+            <a:pPr algn="l">
+              <a:lnSpc>
+                <a:spcPts val="1200"/>
+              </a:lnSpc>
+            </a:pPr>
+            <a:r>
+              <a:rPr sz="900" b="1" i="0" spc="15">
+                <a:solidFill>
+                  <a:srgbClr val="1B1A1A"/>
+                </a:solidFill>
+                <a:latin typeface="Calibri"/>
+              </a:rPr>
+              <a:t>Josiah Warren</a:t>
+            </a:r>
+          </a:p>
+        </p:txBody>
+      </p:sp>
+      <p:sp>
+        <p:nvSpPr>
+          <p:cNvPr id="83" name="Text: Transaction Support Associate"/>
+          <p:cNvSpPr txBox="1"/>
+          <p:nvPr/>
+        </p:nvSpPr>
+        <p:spPr>
+          <a:xfrm>
+            <a:off x="5762625" y="5105400"/>
+            <a:ext cx="1419225" cy="133350"/>
+          </a:xfrm>
+          <a:prstGeom prst="rect">
+            <a:avLst/>
+          </a:prstGeom>
+          <a:noFill/>
+        </p:spPr>
+        <p:txBody>
+          <a:bodyPr wrap="square" lIns="0" tIns="0" rIns="0" bIns="0" anchor="t">
+            <a:spAutoFit/>
+          </a:bodyPr>
+          <a:lstStyle/>
+          <a:p>
+            <a:pPr algn="l">
+              <a:lnSpc>
+                <a:spcPts val="1050"/>
+              </a:lnSpc>
+            </a:pPr>
+            <a:r>
+              <a:rPr sz="750" b="0" i="0" spc="15">
+                <a:solidFill>
+                  <a:srgbClr val="6F6A66"/>
+                </a:solidFill>
+                <a:latin typeface="Calibri"/>
+              </a:rPr>
+              <a:t>Transaction Support Associate</a:t>
+            </a:r>
+          </a:p>
+        </p:txBody>
+      </p:sp>
+      <p:sp>
+        <p:nvSpPr>
+          <p:cNvPr id="84" name="Rectangle 83"/>
+          <p:cNvSpPr/>
+          <p:nvPr/>
+        </p:nvSpPr>
+        <p:spPr>
+          <a:xfrm>
+            <a:off x="7391400" y="4876800"/>
+            <a:ext cx="2247900" cy="742950"/>
+          </a:xfrm>
+          <a:prstGeom prst="rect">
+            <a:avLst/>
+          </a:prstGeom>
+          <a:solidFill>
+            <a:srgbClr val="FFFFFF"/>
+          </a:solidFill>
+          <a:ln>
+            <a:noFill/>
+          </a:ln>
+          <a:effectLst/>
+        </p:spPr>
+        <p:txBody>
+          <a:bodyPr rtlCol="0" anchor="ctr"/>
+          <a:lstStyle/>
+          <a:p>
+            <a:pPr algn="ctr"/>
+            <a:endParaRPr/>
+          </a:p>
+        </p:txBody>
+      </p:sp>
+      <p:sp>
+        <p:nvSpPr>
+          <p:cNvPr id="85" name="Rectangle 84"/>
+          <p:cNvSpPr/>
+          <p:nvPr/>
+        </p:nvSpPr>
+        <p:spPr>
+          <a:xfrm>
+            <a:off x="7391400" y="4876800"/>
+            <a:ext cx="2247900" cy="9525"/>
+          </a:xfrm>
+          <a:prstGeom prst="rect">
+            <a:avLst/>
+          </a:prstGeom>
+          <a:solidFill>
+            <a:srgbClr val="E3DCD3"/>
+          </a:solidFill>
+          <a:ln>
+            <a:noFill/>
+          </a:ln>
+          <a:effectLst/>
+        </p:spPr>
+        <p:txBody>
+          <a:bodyPr rtlCol="0" anchor="ctr"/>
+          <a:lstStyle/>
+          <a:p>
+            <a:pPr algn="ctr"/>
+            <a:endParaRPr/>
+          </a:p>
+        </p:txBody>
+      </p:sp>
+      <p:sp>
+        <p:nvSpPr>
+          <p:cNvPr id="86" name="Rectangle 85"/>
+          <p:cNvSpPr/>
+          <p:nvPr/>
+        </p:nvSpPr>
+        <p:spPr>
+          <a:xfrm>
+            <a:off x="9629775" y="4876800"/>
+            <a:ext cx="9525" cy="742950"/>
+          </a:xfrm>
+          <a:prstGeom prst="rect">
+            <a:avLst/>
+          </a:prstGeom>
+          <a:solidFill>
+            <a:srgbClr val="E3DCD3"/>
+          </a:solidFill>
+          <a:ln>
+            <a:noFill/>
+          </a:ln>
+          <a:effectLst/>
+        </p:spPr>
+        <p:txBody>
+          <a:bodyPr rtlCol="0" anchor="ctr"/>
+          <a:lstStyle/>
+          <a:p>
+            <a:pPr algn="ctr"/>
+            <a:endParaRPr/>
+          </a:p>
+        </p:txBody>
+      </p:sp>
+      <p:sp>
+        <p:nvSpPr>
+          <p:cNvPr id="87" name="Rectangle 86"/>
+          <p:cNvSpPr/>
+          <p:nvPr/>
+        </p:nvSpPr>
+        <p:spPr>
+          <a:xfrm>
+            <a:off x="7391400" y="5610225"/>
+            <a:ext cx="2247900" cy="9525"/>
+          </a:xfrm>
+          <a:prstGeom prst="rect">
+            <a:avLst/>
+          </a:prstGeom>
+          <a:solidFill>
+            <a:srgbClr val="E3DCD3"/>
+          </a:solidFill>
+          <a:ln>
+            <a:noFill/>
+          </a:ln>
+          <a:effectLst/>
+        </p:spPr>
+        <p:txBody>
+          <a:bodyPr rtlCol="0" anchor="ctr"/>
+          <a:lstStyle/>
+          <a:p>
+            <a:pPr algn="ctr"/>
+            <a:endParaRPr/>
+          </a:p>
+        </p:txBody>
+      </p:sp>
+      <p:sp>
+        <p:nvSpPr>
+          <p:cNvPr id="88" name="Rectangle 87"/>
+          <p:cNvSpPr/>
+          <p:nvPr/>
+        </p:nvSpPr>
+        <p:spPr>
+          <a:xfrm>
+            <a:off x="7391400" y="4876800"/>
+            <a:ext cx="9525" cy="742950"/>
+          </a:xfrm>
+          <a:prstGeom prst="rect">
+            <a:avLst/>
+          </a:prstGeom>
+          <a:solidFill>
+            <a:srgbClr val="E3DCD3"/>
+          </a:solidFill>
+          <a:ln>
+            <a:noFill/>
+          </a:ln>
+          <a:effectLst/>
+        </p:spPr>
+        <p:txBody>
+          <a:bodyPr rtlCol="0" anchor="ctr"/>
+          <a:lstStyle/>
+          <a:p>
+            <a:pPr algn="ctr"/>
+            <a:endParaRPr/>
+          </a:p>
+        </p:txBody>
+      </p:sp>
+      <p:pic>
+        <p:nvPicPr>
+          <p:cNvPr id="89" name="Picture 88" descr="Luke Ernst"/>
+          <p:cNvPicPr>
+            <a:picLocks noChangeAspect="1"/>
+          </p:cNvPicPr>
+          <p:nvPr/>
+        </p:nvPicPr>
+        <p:blipFill>
+          <a:blip r:embed="rId14"/>
+          <a:srcRect/>
+          <a:stretch>
+            <a:fillRect/>
+          </a:stretch>
+        </p:blipFill>
+        <p:spPr>
+          <a:xfrm>
+            <a:off x="7515225" y="4991100"/>
+            <a:ext cx="514350" cy="514350"/>
+          </a:xfrm>
+          <a:prstGeom prst="ellipse">
+            <a:avLst/>
+          </a:prstGeom>
+        </p:spPr>
+      </p:pic>
+      <p:sp>
+        <p:nvSpPr>
+          <p:cNvPr id="90" name="Text: Luke Ernst"/>
+          <p:cNvSpPr txBox="1"/>
+          <p:nvPr/>
+        </p:nvSpPr>
+        <p:spPr>
+          <a:xfrm>
+            <a:off x="8143875" y="4953000"/>
+            <a:ext cx="1419225" cy="152400"/>
+          </a:xfrm>
+          <a:prstGeom prst="rect">
+            <a:avLst/>
+          </a:prstGeom>
+          <a:noFill/>
+        </p:spPr>
+        <p:txBody>
+          <a:bodyPr wrap="square" lIns="0" tIns="0" rIns="0" bIns="0" anchor="t">
+            <a:spAutoFit/>
+          </a:bodyPr>
+          <a:lstStyle/>
+          <a:p>
+            <a:pPr algn="l">
+              <a:lnSpc>
+                <a:spcPts val="1200"/>
+              </a:lnSpc>
+            </a:pPr>
+            <a:r>
+              <a:rPr sz="900" b="1" i="0" spc="15">
+                <a:solidFill>
+                  <a:srgbClr val="1B1A1A"/>
+                </a:solidFill>
+                <a:latin typeface="Calibri"/>
+              </a:rPr>
+              <a:t>Luke Ernst</a:t>
+            </a:r>
+          </a:p>
+        </p:txBody>
+      </p:sp>
+      <p:sp>
+        <p:nvSpPr>
+          <p:cNvPr id="91" name="Text: Deal Analyst"/>
+          <p:cNvSpPr txBox="1"/>
+          <p:nvPr/>
+        </p:nvSpPr>
+        <p:spPr>
+          <a:xfrm>
+            <a:off x="8143875" y="5105400"/>
+            <a:ext cx="1419225" cy="133350"/>
+          </a:xfrm>
+          <a:prstGeom prst="rect">
+            <a:avLst/>
+          </a:prstGeom>
+          <a:noFill/>
+        </p:spPr>
+        <p:txBody>
+          <a:bodyPr wrap="square" lIns="0" tIns="0" rIns="0" bIns="0" anchor="t">
+            <a:spAutoFit/>
+          </a:bodyPr>
+          <a:lstStyle/>
+          <a:p>
+            <a:pPr algn="l">
+              <a:lnSpc>
+                <a:spcPts val="1050"/>
+              </a:lnSpc>
+            </a:pPr>
+            <a:r>
+              <a:rPr sz="750" b="0" i="0" spc="15">
+                <a:solidFill>
+                  <a:srgbClr val="6F6A66"/>
+                </a:solidFill>
+                <a:latin typeface="Calibri"/>
+              </a:rPr>
+              <a:t>Deal Analyst</a:t>
+            </a:r>
+          </a:p>
+        </p:txBody>
+      </p:sp>
+      <p:sp>
+        <p:nvSpPr>
+          <p:cNvPr id="92" name="Rectangle 91"/>
+          <p:cNvSpPr/>
+          <p:nvPr/>
+        </p:nvSpPr>
+        <p:spPr>
+          <a:xfrm>
+            <a:off x="2628900" y="6143625"/>
+            <a:ext cx="7010400" cy="9525"/>
+          </a:xfrm>
+          <a:prstGeom prst="rect">
+            <a:avLst/>
+          </a:prstGeom>
+          <a:solidFill>
+            <a:srgbClr val="E3DCD3"/>
+          </a:solidFill>
+          <a:ln>
+            <a:noFill/>
+          </a:ln>
+          <a:effectLst/>
+        </p:spPr>
+        <p:txBody>
+          <a:bodyPr rtlCol="0" anchor="ctr"/>
+          <a:lstStyle/>
+          <a:p>
+            <a:pPr algn="ctr"/>
+            <a:endParaRPr/>
+          </a:p>
+        </p:txBody>
+      </p:sp>
+      <p:sp>
+        <p:nvSpPr>
+          <p:cNvPr id="93" name="Text: HEALTHCARE COVERAGE"/>
+          <p:cNvSpPr txBox="1"/>
+          <p:nvPr/>
+        </p:nvSpPr>
+        <p:spPr>
+          <a:xfrm>
+            <a:off x="2628900" y="6267450"/>
+            <a:ext cx="7024688" cy="123825"/>
+          </a:xfrm>
+          <a:prstGeom prst="rect">
+            <a:avLst/>
+          </a:prstGeom>
+          <a:noFill/>
+        </p:spPr>
+        <p:txBody>
+          <a:bodyPr wrap="square" lIns="0" tIns="0" rIns="0" bIns="0" anchor="t">
+            <a:spAutoFit/>
+          </a:bodyPr>
+          <a:lstStyle/>
+          <a:p>
+            <a:pPr algn="l">
+              <a:lnSpc>
+                <a:spcPts val="975"/>
+              </a:lnSpc>
+            </a:pPr>
+            <a:r>
+              <a:rPr sz="638" b="1" i="0" spc="150">
+                <a:solidFill>
+                  <a:srgbClr val="8C6239"/>
+                </a:solidFill>
+                <a:latin typeface="Calibri"/>
+              </a:rPr>
+              <a:t>INDUSTRIAL COVERAGE</a:t>
+            </a:r>
+          </a:p>
+        </p:txBody>
+      </p:sp>
+      <p:sp>
+        <p:nvSpPr>
+          <p:cNvPr id="102" name="Rectangle 101"/>
+          <p:cNvSpPr/>
+          <p:nvPr/>
+        </p:nvSpPr>
+        <p:spPr>
+          <a:xfrm>
+            <a:off x="419100" y="7029450"/>
+            <a:ext cx="9220200" cy="9525"/>
+          </a:xfrm>
+          <a:prstGeom prst="rect">
+            <a:avLst/>
+          </a:prstGeom>
+          <a:solidFill>
+            <a:srgbClr val="E3DCD3"/>
+          </a:solidFill>
+          <a:ln>
+            <a:noFill/>
+          </a:ln>
+          <a:effectLst/>
+        </p:spPr>
+        <p:txBody>
+          <a:bodyPr rtlCol="0" anchor="ctr"/>
+          <a:lstStyle/>
+          <a:p>
+            <a:pPr algn="ctr"/>
+            <a:endParaRPr/>
+          </a:p>
+        </p:txBody>
+      </p:sp>
+      <p:pic>
+        <p:nvPicPr>
+          <p:cNvPr id="103" name="Picture 102" descr="Benchmark International"/>
+          <p:cNvPicPr>
+            <a:picLocks noChangeAspect="1"/>
+          </p:cNvPicPr>
+          <p:nvPr/>
+        </p:nvPicPr>
+        <p:blipFill>
+          <a:blip r:embed="rId19"/>
+          <a:srcRect/>
+          <a:stretch>
+            <a:fillRect/>
+          </a:stretch>
+        </p:blipFill>
+        <p:spPr>
+          <a:xfrm>
+            <a:off x="419100" y="7143750"/>
+            <a:ext cx="914400" cy="171450"/>
+          </a:xfrm>
+          <a:prstGeom prst="rect">
+            <a:avLst/>
+          </a:prstGeom>
+        </p:spPr>
+      </p:pic>
+      <p:sp>
+        <p:nvSpPr>
+          <p:cNvPr id="104" name="Text: Team as listed on the Benchmark Ca"/>
+          <p:cNvSpPr txBox="1"/>
+          <p:nvPr/>
+        </p:nvSpPr>
+        <p:spPr>
+          <a:xfrm>
+            <a:off x="1543050" y="7105650"/>
+            <a:ext cx="7748588" cy="238125"/>
+          </a:xfrm>
+          <a:prstGeom prst="rect">
+            <a:avLst/>
+          </a:prstGeom>
+          <a:noFill/>
+        </p:spPr>
+        <p:txBody>
+          <a:bodyPr wrap="square" lIns="0" tIns="0" rIns="0" bIns="0" anchor="t">
+            <a:spAutoFit/>
+          </a:bodyPr>
+          <a:lstStyle/>
+          <a:p>
+            <a:pPr algn="l">
+              <a:lnSpc>
+                <a:spcPts val="938"/>
+              </a:lnSpc>
+            </a:pPr>
+            <a:r>
+              <a:rPr sz="675" b="0" i="0" spc="8">
+                <a:solidFill>
+                  <a:srgbClr val="6F6A66"/>
+                </a:solidFill>
+                <a:latin typeface="Calibri"/>
+              </a:rPr>
+              <a:t>Team as listed on the Middle Market site in October 2026.</a:t>
+            </a:r>
+          </a:p>
+        </p:txBody>
+      </p:sp>
+      <p:sp>
+        <p:nvSpPr>
+          <p:cNvPr id="105" name="Text: 20"/>
+          <p:cNvSpPr txBox="1"/>
+          <p:nvPr/>
+        </p:nvSpPr>
+        <p:spPr>
+          <a:xfrm>
+            <a:off x="9509373" y="7162800"/>
+            <a:ext cx="144214" cy="133350"/>
+          </a:xfrm>
+          <a:prstGeom prst="rect">
+            <a:avLst/>
+          </a:prstGeom>
+          <a:noFill/>
+        </p:spPr>
+        <p:txBody>
+          <a:bodyPr wrap="square" lIns="0" tIns="0" rIns="0" bIns="0" anchor="t">
+            <a:spAutoFit/>
+          </a:bodyPr>
+          <a:lstStyle/>
+          <a:p>
+            <a:pPr algn="l">
+              <a:lnSpc>
+                <a:spcPts val="1050"/>
+              </a:lnSpc>
+            </a:pPr>
+            <a:r>
+              <a:rPr sz="712" b="1" i="0" spc="150">
+                <a:solidFill>
+                  <a:srgbClr val="1B1A1A"/>
+                </a:solidFill>
+                <a:latin typeface="Calibri"/>
+              </a:rPr>
+              <a:t>16</a:t>
+            </a:r>
+          </a:p>
+        </p:txBody>
+      </p:sp>
+      <p:sp>
+        <p:nvSpPr>
+          <p:cNvPr id="106" name="Text: jhoutz@benchmarkintl.com"/>
+          <p:cNvSpPr txBox="1"/>
+          <p:nvPr/>
+        </p:nvSpPr>
+        <p:spPr>
+          <a:xfrm>
+            <a:off x="2835920" y="3162300"/>
+            <a:ext cx="1252686" cy="304800"/>
+          </a:xfrm>
+          <a:prstGeom prst="rect">
+            <a:avLst/>
+          </a:prstGeom>
+          <a:noFill/>
+        </p:spPr>
+        <p:txBody>
+          <a:bodyPr wrap="square" lIns="0" tIns="0" rIns="0" bIns="0" anchor="t">
+            <a:spAutoFit/>
+          </a:bodyPr>
+          <a:lstStyle/>
+          <a:p>
+            <a:pPr algn="ctr">
+              <a:lnSpc>
+                <a:spcPts val="1200"/>
+              </a:lnSpc>
+            </a:pPr>
+            <a:r>
+              <a:rPr sz="788" b="0" i="0" spc="15">
+                <a:solidFill>
+                  <a:srgbClr val="8C6239"/>
+                </a:solidFill>
+                <a:latin typeface="Calibri"/>
+                <a:hlinkClick r:id="rId5">
+                  <a:extLst>
+                    <a:ext uri="{A12FA001-AC4F-418D-AE19-62706E023703}">
+                      <ahyp:hlinkClr xmlns:ahyp="http://schemas.microsoft.com/office/drawing/2018/hyperlinkcolor" val="tx"/>
+                    </a:ext>
+                  </a:extLst>
+                </a:hlinkClick>
+              </a:rPr>
+              <a:t>813-771-6675</a:t>
+            </a:r>
+            <a:br/>
+            <a:r>
+              <a:rPr sz="788" b="0" i="0" spc="15">
+                <a:solidFill>
+                  <a:srgbClr val="8C6239"/>
+                </a:solidFill>
+                <a:latin typeface="Calibri"/>
+                <a:hlinkClick r:id="rId20">
+                  <a:extLst>
+                    <a:ext uri="{A12FA001-AC4F-418D-AE19-62706E023703}">
+                      <ahyp:hlinkClr xmlns:ahyp="http://schemas.microsoft.com/office/drawing/2018/hyperlinkcolor" val="tx"/>
+                    </a:ext>
+                  </a:extLst>
+                </a:hlinkClick>
+              </a:rPr>
+              <a:t>jhoutz@benchmarkintl.com</a:t>
+            </a:r>
+          </a:p>
+        </p:txBody>
+      </p:sp>
+      <p:sp>
+        <p:nvSpPr>
+          <p:cNvPr id="107" name="Text: azykov@benchmarkintl.com"/>
+          <p:cNvSpPr txBox="1"/>
+          <p:nvPr/>
+        </p:nvSpPr>
+        <p:spPr>
+          <a:xfrm>
+            <a:off x="6407869" y="3162300"/>
+            <a:ext cx="1252686" cy="304800"/>
+          </a:xfrm>
+          <a:prstGeom prst="rect">
+            <a:avLst/>
+          </a:prstGeom>
+          <a:noFill/>
+        </p:spPr>
+        <p:txBody>
+          <a:bodyPr wrap="square" lIns="0" tIns="0" rIns="0" bIns="0" anchor="t">
+            <a:spAutoFit/>
+          </a:bodyPr>
+          <a:lstStyle/>
+          <a:p>
+            <a:pPr algn="ctr">
+              <a:lnSpc>
+                <a:spcPts val="1200"/>
+              </a:lnSpc>
+            </a:pPr>
+            <a:r>
+              <a:rPr sz="788" b="0" i="0" spc="15">
+                <a:solidFill>
+                  <a:srgbClr val="8C6239"/>
+                </a:solidFill>
+                <a:latin typeface="Calibri"/>
+                <a:hlinkClick r:id="rId21">
+                  <a:extLst>
+                    <a:ext uri="{A12FA001-AC4F-418D-AE19-62706E023703}">
+                      <ahyp:hlinkClr xmlns:ahyp="http://schemas.microsoft.com/office/drawing/2018/hyperlinkcolor" val="tx"/>
+                    </a:ext>
+                  </a:extLst>
+                </a:hlinkClick>
+              </a:rPr>
+              <a:t>813-898-2372</a:t>
+            </a:r>
+            <a:br/>
+            <a:r>
+              <a:rPr sz="788" b="0" i="0" spc="15">
+                <a:solidFill>
+                  <a:srgbClr val="8C6239"/>
+                </a:solidFill>
+                <a:latin typeface="Calibri"/>
+                <a:hlinkClick r:id="rId22">
+                  <a:extLst>
+                    <a:ext uri="{A12FA001-AC4F-418D-AE19-62706E023703}">
+                      <ahyp:hlinkClr xmlns:ahyp="http://schemas.microsoft.com/office/drawing/2018/hyperlinkcolor" val="tx"/>
+                    </a:ext>
+                  </a:extLst>
+                </a:hlinkClick>
+              </a:rPr>
+              <a:t>azykov@benchmarkintl.com</a:t>
+            </a:r>
+          </a:p>
+        </p:txBody>
+      </p:sp>
+      <p:sp>
+        <p:nvSpPr>
+          <p:cNvPr id="108" name="Text: hess@benchmarkintl.com"/>
+          <p:cNvSpPr txBox="1"/>
+          <p:nvPr/>
+        </p:nvSpPr>
+        <p:spPr>
+          <a:xfrm>
+            <a:off x="8193733" y="3162300"/>
+            <a:ext cx="1252686" cy="304800"/>
+          </a:xfrm>
+          <a:prstGeom prst="rect">
+            <a:avLst/>
+          </a:prstGeom>
+          <a:noFill/>
+        </p:spPr>
+        <p:txBody>
+          <a:bodyPr wrap="square" lIns="0" tIns="0" rIns="0" bIns="0" anchor="t">
+            <a:spAutoFit/>
+          </a:bodyPr>
+          <a:lstStyle/>
+          <a:p>
+            <a:pPr algn="ctr">
+              <a:lnSpc>
+                <a:spcPts val="1200"/>
+              </a:lnSpc>
+            </a:pPr>
+            <a:r>
+              <a:rPr sz="788" b="0" i="0" spc="15">
+                <a:solidFill>
+                  <a:srgbClr val="8C6239"/>
+                </a:solidFill>
+                <a:latin typeface="Calibri"/>
+                <a:hlinkClick r:id="rId23">
+                  <a:extLst>
+                    <a:ext uri="{A12FA001-AC4F-418D-AE19-62706E023703}">
+                      <ahyp:hlinkClr xmlns:ahyp="http://schemas.microsoft.com/office/drawing/2018/hyperlinkcolor" val="tx"/>
+                    </a:ext>
+                  </a:extLst>
+                </a:hlinkClick>
+              </a:rPr>
+              <a:t>813-898-2397</a:t>
+            </a:r>
+            <a:br/>
+            <a:r>
+              <a:rPr sz="788" b="0" i="0" spc="15">
+                <a:solidFill>
+                  <a:srgbClr val="8C6239"/>
+                </a:solidFill>
+                <a:latin typeface="Calibri"/>
+                <a:hlinkClick r:id="rId24">
+                  <a:extLst>
+                    <a:ext uri="{A12FA001-AC4F-418D-AE19-62706E023703}">
+                      <ahyp:hlinkClr xmlns:ahyp="http://schemas.microsoft.com/office/drawing/2018/hyperlinkcolor" val="tx"/>
+                    </a:ext>
+                  </a:extLst>
+                </a:hlinkClick>
+              </a:rPr>
+              <a:t>hess@benchmarkintl.com</a:t>
+            </a:r>
+          </a:p>
+        </p:txBody>
+      </p:sp>
+      <p:sp>
+        <p:nvSpPr>
+          <p:cNvPr id="109" name="Text: garten@benchmarkintl.com"/>
+          <p:cNvSpPr txBox="1"/>
+          <p:nvPr/>
+        </p:nvSpPr>
+        <p:spPr>
+          <a:xfrm>
+            <a:off x="3381375" y="4394200"/>
+            <a:ext cx="1419225" cy="304800"/>
+          </a:xfrm>
+          <a:prstGeom prst="rect">
+            <a:avLst/>
+          </a:prstGeom>
+          <a:noFill/>
+        </p:spPr>
+        <p:txBody>
+          <a:bodyPr wrap="square" lIns="0" tIns="0" rIns="0" bIns="0" anchor="t">
+            <a:spAutoFit/>
+          </a:bodyPr>
+          <a:lstStyle/>
+          <a:p>
+            <a:pPr algn="l">
+              <a:lnSpc>
+                <a:spcPts val="850"/>
+              </a:lnSpc>
+            </a:pPr>
+            <a:r>
+              <a:rPr sz="675" b="0" i="0" spc="15">
+                <a:solidFill>
+                  <a:srgbClr val="8C6239"/>
+                </a:solidFill>
+                <a:latin typeface="Calibri"/>
+                <a:hlinkClick r:id="rId25">
+                  <a:extLst>
+                    <a:ext uri="{A12FA001-AC4F-418D-AE19-62706E023703}">
+                      <ahyp:hlinkClr xmlns:ahyp="http://schemas.microsoft.com/office/drawing/2018/hyperlinkcolor" val="tx"/>
+                    </a:ext>
+                  </a:extLst>
+                </a:hlinkClick>
+              </a:rPr>
+              <a:t>813-898-2357</a:t>
+            </a:r>
+            <a:br/>
+            <a:r>
+              <a:rPr sz="675" b="0" i="0" spc="15">
+                <a:solidFill>
+                  <a:srgbClr val="8C6239"/>
+                </a:solidFill>
+                <a:latin typeface="Calibri"/>
+                <a:hlinkClick r:id="rId26">
+                  <a:extLst>
+                    <a:ext uri="{A12FA001-AC4F-418D-AE19-62706E023703}">
+                      <ahyp:hlinkClr xmlns:ahyp="http://schemas.microsoft.com/office/drawing/2018/hyperlinkcolor" val="tx"/>
+                    </a:ext>
+                  </a:extLst>
+                </a:hlinkClick>
+              </a:rPr>
+              <a:t>garten@benchmarkintl.com</a:t>
+            </a:r>
+          </a:p>
+        </p:txBody>
+      </p:sp>
+      <p:sp>
+        <p:nvSpPr>
+          <p:cNvPr id="110" name="Text: mwynn@benchmarkintl.com"/>
+          <p:cNvSpPr txBox="1"/>
+          <p:nvPr/>
+        </p:nvSpPr>
+        <p:spPr>
+          <a:xfrm>
+            <a:off x="5762625" y="4394200"/>
+            <a:ext cx="1419225" cy="304800"/>
+          </a:xfrm>
+          <a:prstGeom prst="rect">
+            <a:avLst/>
+          </a:prstGeom>
+          <a:noFill/>
+        </p:spPr>
+        <p:txBody>
+          <a:bodyPr wrap="square" lIns="0" tIns="0" rIns="0" bIns="0" anchor="t">
+            <a:spAutoFit/>
+          </a:bodyPr>
+          <a:lstStyle/>
+          <a:p>
+            <a:pPr algn="l">
+              <a:lnSpc>
+                <a:spcPts val="850"/>
+              </a:lnSpc>
+            </a:pPr>
+            <a:r>
+              <a:rPr sz="675" b="0" i="0" spc="15">
+                <a:solidFill>
+                  <a:srgbClr val="8C6239"/>
+                </a:solidFill>
+                <a:latin typeface="Calibri"/>
+                <a:hlinkClick r:id="rId27">
+                  <a:extLst>
+                    <a:ext uri="{A12FA001-AC4F-418D-AE19-62706E023703}">
+                      <ahyp:hlinkClr xmlns:ahyp="http://schemas.microsoft.com/office/drawing/2018/hyperlinkcolor" val="tx"/>
+                    </a:ext>
+                  </a:extLst>
+                </a:hlinkClick>
+              </a:rPr>
+              <a:t>813-384-4972</a:t>
+            </a:r>
+            <a:br/>
+            <a:r>
+              <a:rPr sz="675" b="0" i="0" spc="15">
+                <a:solidFill>
+                  <a:srgbClr val="8C6239"/>
+                </a:solidFill>
+                <a:latin typeface="Calibri"/>
+                <a:hlinkClick r:id="rId28">
+                  <a:extLst>
+                    <a:ext uri="{A12FA001-AC4F-418D-AE19-62706E023703}">
+                      <ahyp:hlinkClr xmlns:ahyp="http://schemas.microsoft.com/office/drawing/2018/hyperlinkcolor" val="tx"/>
+                    </a:ext>
+                  </a:extLst>
+                </a:hlinkClick>
+              </a:rPr>
+              <a:t>mwynn@benchmarkintl.com</a:t>
+            </a:r>
+          </a:p>
+        </p:txBody>
+      </p:sp>
+      <p:sp>
+        <p:nvSpPr>
+          <p:cNvPr id="111" name="Text: jlisiak@benchmarkintl.com"/>
+          <p:cNvSpPr txBox="1"/>
+          <p:nvPr/>
+        </p:nvSpPr>
+        <p:spPr>
+          <a:xfrm>
+            <a:off x="8143875" y="4394200"/>
+            <a:ext cx="1419225" cy="304800"/>
+          </a:xfrm>
+          <a:prstGeom prst="rect">
+            <a:avLst/>
+          </a:prstGeom>
+          <a:noFill/>
+        </p:spPr>
+        <p:txBody>
+          <a:bodyPr wrap="square" lIns="0" tIns="0" rIns="0" bIns="0" anchor="t">
+            <a:spAutoFit/>
+          </a:bodyPr>
+          <a:lstStyle/>
+          <a:p>
+            <a:pPr algn="l">
+              <a:lnSpc>
+                <a:spcPts val="850"/>
+              </a:lnSpc>
+            </a:pPr>
+            <a:r>
+              <a:rPr sz="675" b="0" i="0" spc="15">
+                <a:solidFill>
+                  <a:srgbClr val="8C6239"/>
+                </a:solidFill>
+                <a:latin typeface="Calibri"/>
+                <a:hlinkClick r:id="rId29">
+                  <a:extLst>
+                    <a:ext uri="{A12FA001-AC4F-418D-AE19-62706E023703}">
+                      <ahyp:hlinkClr xmlns:ahyp="http://schemas.microsoft.com/office/drawing/2018/hyperlinkcolor" val="tx"/>
+                    </a:ext>
+                  </a:extLst>
+                </a:hlinkClick>
+              </a:rPr>
+              <a:t>jlisiak@benchmarkintl.com</a:t>
+            </a:r>
+          </a:p>
+        </p:txBody>
+      </p:sp>
+      <p:sp>
+        <p:nvSpPr>
+          <p:cNvPr id="112" name="Text: abarr@benchmarkintl.com"/>
+          <p:cNvSpPr txBox="1"/>
+          <p:nvPr/>
+        </p:nvSpPr>
+        <p:spPr>
+          <a:xfrm>
+            <a:off x="3381375" y="5251450"/>
+            <a:ext cx="1419225" cy="304800"/>
+          </a:xfrm>
+          <a:prstGeom prst="rect">
+            <a:avLst/>
+          </a:prstGeom>
+          <a:noFill/>
+        </p:spPr>
+        <p:txBody>
+          <a:bodyPr wrap="square" lIns="0" tIns="0" rIns="0" bIns="0" anchor="t">
+            <a:spAutoFit/>
+          </a:bodyPr>
+          <a:lstStyle/>
+          <a:p>
+            <a:pPr algn="l">
+              <a:lnSpc>
+                <a:spcPts val="850"/>
+              </a:lnSpc>
+            </a:pPr>
+            <a:r>
+              <a:rPr sz="675" b="0" i="0" spc="15">
+                <a:solidFill>
+                  <a:srgbClr val="8C6239"/>
+                </a:solidFill>
+                <a:latin typeface="Calibri"/>
+                <a:hlinkClick r:id="rId30">
+                  <a:extLst>
+                    <a:ext uri="{A12FA001-AC4F-418D-AE19-62706E023703}">
+                      <ahyp:hlinkClr xmlns:ahyp="http://schemas.microsoft.com/office/drawing/2018/hyperlinkcolor" val="tx"/>
+                    </a:ext>
+                  </a:extLst>
+                </a:hlinkClick>
+              </a:rPr>
+              <a:t>813-387-6046</a:t>
+            </a:r>
+            <a:br/>
+            <a:r>
+              <a:rPr sz="675" b="0" i="0" spc="15">
+                <a:solidFill>
+                  <a:srgbClr val="8C6239"/>
+                </a:solidFill>
+                <a:latin typeface="Calibri"/>
+                <a:hlinkClick r:id="rId31">
+                  <a:extLst>
+                    <a:ext uri="{A12FA001-AC4F-418D-AE19-62706E023703}">
+                      <ahyp:hlinkClr xmlns:ahyp="http://schemas.microsoft.com/office/drawing/2018/hyperlinkcolor" val="tx"/>
+                    </a:ext>
+                  </a:extLst>
+                </a:hlinkClick>
+              </a:rPr>
+              <a:t>abarr@benchmarkintl.com</a:t>
+            </a:r>
+          </a:p>
+        </p:txBody>
+      </p:sp>
+      <p:sp>
+        <p:nvSpPr>
+          <p:cNvPr id="113" name="Text: jwarren@benchmarkintl.com"/>
+          <p:cNvSpPr txBox="1"/>
+          <p:nvPr/>
+        </p:nvSpPr>
+        <p:spPr>
+          <a:xfrm>
+            <a:off x="5762625" y="5251450"/>
+            <a:ext cx="1419225" cy="304800"/>
+          </a:xfrm>
+          <a:prstGeom prst="rect">
+            <a:avLst/>
+          </a:prstGeom>
+          <a:noFill/>
+        </p:spPr>
+        <p:txBody>
+          <a:bodyPr wrap="square" lIns="0" tIns="0" rIns="0" bIns="0" anchor="t">
+            <a:spAutoFit/>
+          </a:bodyPr>
+          <a:lstStyle/>
+          <a:p>
+            <a:pPr algn="l">
+              <a:lnSpc>
+                <a:spcPts val="850"/>
+              </a:lnSpc>
+            </a:pPr>
+            <a:r>
+              <a:rPr sz="675" b="0" i="0" spc="15">
+                <a:solidFill>
+                  <a:srgbClr val="8C6239"/>
+                </a:solidFill>
+                <a:latin typeface="Calibri"/>
+                <a:hlinkClick r:id="rId32">
+                  <a:extLst>
+                    <a:ext uri="{A12FA001-AC4F-418D-AE19-62706E023703}">
+                      <ahyp:hlinkClr xmlns:ahyp="http://schemas.microsoft.com/office/drawing/2018/hyperlinkcolor" val="tx"/>
+                    </a:ext>
+                  </a:extLst>
+                </a:hlinkClick>
+              </a:rPr>
+              <a:t>813-898-2398</a:t>
+            </a:r>
+            <a:br/>
+            <a:r>
+              <a:rPr sz="675" b="0" i="0" spc="15">
+                <a:solidFill>
+                  <a:srgbClr val="8C6239"/>
+                </a:solidFill>
+                <a:latin typeface="Calibri"/>
+                <a:hlinkClick r:id="rId33">
+                  <a:extLst>
+                    <a:ext uri="{A12FA001-AC4F-418D-AE19-62706E023703}">
+                      <ahyp:hlinkClr xmlns:ahyp="http://schemas.microsoft.com/office/drawing/2018/hyperlinkcolor" val="tx"/>
+                    </a:ext>
+                  </a:extLst>
+                </a:hlinkClick>
+              </a:rPr>
+              <a:t>jwarren@benchmarkintl.com</a:t>
+            </a:r>
+          </a:p>
+        </p:txBody>
+      </p:sp>
+      <p:sp>
+        <p:nvSpPr>
+          <p:cNvPr id="114" name="Text: lernst@benchmarkintl.com"/>
+          <p:cNvSpPr txBox="1"/>
+          <p:nvPr/>
+        </p:nvSpPr>
+        <p:spPr>
+          <a:xfrm>
+            <a:off x="8143875" y="5251450"/>
+            <a:ext cx="1419225" cy="304800"/>
+          </a:xfrm>
+          <a:prstGeom prst="rect">
+            <a:avLst/>
+          </a:prstGeom>
+          <a:noFill/>
+        </p:spPr>
+        <p:txBody>
+          <a:bodyPr wrap="square" lIns="0" tIns="0" rIns="0" bIns="0" anchor="t">
+            <a:spAutoFit/>
+          </a:bodyPr>
+          <a:lstStyle/>
+          <a:p>
+            <a:pPr algn="l">
+              <a:lnSpc>
+                <a:spcPts val="850"/>
+              </a:lnSpc>
+            </a:pPr>
+            <a:r>
+              <a:rPr sz="675" b="0" i="0" spc="15">
+                <a:solidFill>
+                  <a:srgbClr val="8C6239"/>
+                </a:solidFill>
+                <a:latin typeface="Calibri"/>
+                <a:hlinkClick r:id="rId34">
+                  <a:extLst>
+                    <a:ext uri="{A12FA001-AC4F-418D-AE19-62706E023703}">
+                      <ahyp:hlinkClr xmlns:ahyp="http://schemas.microsoft.com/office/drawing/2018/hyperlinkcolor" val="tx"/>
+                    </a:ext>
+                  </a:extLst>
+                </a:hlinkClick>
+              </a:rPr>
+              <a:t>813-771-6318</a:t>
+            </a:r>
+            <a:br/>
+            <a:r>
+              <a:rPr sz="675" b="0" i="0" spc="15">
+                <a:solidFill>
+                  <a:srgbClr val="8C6239"/>
+                </a:solidFill>
+                <a:latin typeface="Calibri"/>
+                <a:hlinkClick r:id="rId35">
+                  <a:extLst>
+                    <a:ext uri="{A12FA001-AC4F-418D-AE19-62706E023703}">
+                      <ahyp:hlinkClr xmlns:ahyp="http://schemas.microsoft.com/office/drawing/2018/hyperlinkcolor" val="tx"/>
+                    </a:ext>
+                  </a:extLst>
+                </a:hlinkClick>
+              </a:rPr>
+              <a:t>lernst@benchmarkintl.com</a:t>
+            </a:r>
+          </a:p>
+        </p:txBody>
+      </p:sp>
+      <p:sp>
+        <p:nvSpPr>
+          <p:cNvPr id="115" name="Text: Provider Services"/>
+          <p:cNvSpPr txBox="1"/>
+          <p:nvPr/>
+        </p:nvSpPr>
+        <p:spPr>
+          <a:xfrm>
+            <a:off x="2628900" y="6496050"/>
+            <a:ext cx="2286000" cy="133350"/>
+          </a:xfrm>
+          <a:prstGeom prst="rect">
+            <a:avLst/>
+          </a:prstGeom>
+          <a:noFill/>
+        </p:spPr>
+        <p:txBody>
+          <a:bodyPr wrap="square" lIns="0" tIns="0" rIns="0" bIns="0" anchor="t">
+            <a:spAutoFit/>
+          </a:bodyPr>
+          <a:lstStyle/>
+          <a:p>
+            <a:pPr algn="l">
+              <a:lnSpc>
+                <a:spcPts val="1050"/>
+              </a:lnSpc>
+            </a:pPr>
+            <a:r>
+              <a:rPr sz="788" b="1" i="0" spc="15">
+                <a:solidFill>
+                  <a:srgbClr val="333231"/>
+                </a:solidFill>
+                <a:latin typeface="Calibri"/>
+              </a:rPr>
+              <a:t>Manufacturing &amp; Industrial Technology</a:t>
+            </a:r>
+          </a:p>
+        </p:txBody>
+      </p:sp>
+      <p:sp>
+        <p:nvSpPr>
+          <p:cNvPr id="116" name="Text: Provider Services"/>
+          <p:cNvSpPr txBox="1"/>
+          <p:nvPr/>
+        </p:nvSpPr>
+        <p:spPr>
+          <a:xfrm>
+            <a:off x="4965700" y="6496050"/>
+            <a:ext cx="2286000" cy="133350"/>
+          </a:xfrm>
+          <a:prstGeom prst="rect">
+            <a:avLst/>
+          </a:prstGeom>
+          <a:noFill/>
+        </p:spPr>
+        <p:txBody>
+          <a:bodyPr wrap="square" lIns="0" tIns="0" rIns="0" bIns="0" anchor="t">
+            <a:spAutoFit/>
+          </a:bodyPr>
+          <a:lstStyle/>
+          <a:p>
+            <a:pPr algn="l">
+              <a:lnSpc>
+                <a:spcPts val="1050"/>
+              </a:lnSpc>
+            </a:pPr>
+            <a:r>
+              <a:rPr sz="788" b="1" i="0" spc="15">
+                <a:solidFill>
+                  <a:srgbClr val="333231"/>
+                </a:solidFill>
+                <a:latin typeface="Calibri"/>
+              </a:rPr>
+              <a:t>Industrial Distribution &amp; Services</a:t>
+            </a:r>
+          </a:p>
+        </p:txBody>
+      </p:sp>
+      <p:sp>
+        <p:nvSpPr>
+          <p:cNvPr id="117" name="Text: Provider Services"/>
+          <p:cNvSpPr txBox="1"/>
+          <p:nvPr/>
+        </p:nvSpPr>
+        <p:spPr>
+          <a:xfrm>
+            <a:off x="7302500" y="6496050"/>
+            <a:ext cx="2286000" cy="133350"/>
+          </a:xfrm>
+          <a:prstGeom prst="rect">
+            <a:avLst/>
+          </a:prstGeom>
+          <a:noFill/>
+        </p:spPr>
+        <p:txBody>
+          <a:bodyPr wrap="square" lIns="0" tIns="0" rIns="0" bIns="0" anchor="t">
+            <a:spAutoFit/>
+          </a:bodyPr>
+          <a:lstStyle/>
+          <a:p>
+            <a:pPr algn="l">
+              <a:lnSpc>
+                <a:spcPts val="1050"/>
+              </a:lnSpc>
+            </a:pPr>
+            <a:r>
+              <a:rPr sz="788" b="1" i="0" spc="15">
+                <a:solidFill>
+                  <a:srgbClr val="333231"/>
+                </a:solidFill>
+                <a:latin typeface="Calibri"/>
+              </a:rPr>
+              <a:t>Building Products &amp; Construction Services</a:t>
+            </a:r>
+          </a:p>
+        </p:txBody>
+      </p:sp>
+      <p:sp>
+        <p:nvSpPr>
+          <p:cNvPr id="118" name="Text: Provider Services"/>
+          <p:cNvSpPr txBox="1"/>
+          <p:nvPr/>
+        </p:nvSpPr>
+        <p:spPr>
+          <a:xfrm>
+            <a:off x="2628900" y="6771640"/>
+            <a:ext cx="2286000" cy="133350"/>
+          </a:xfrm>
+          <a:prstGeom prst="rect">
+            <a:avLst/>
+          </a:prstGeom>
+          <a:noFill/>
+        </p:spPr>
+        <p:txBody>
+          <a:bodyPr wrap="square" lIns="0" tIns="0" rIns="0" bIns="0" anchor="t">
+            <a:spAutoFit/>
+          </a:bodyPr>
+          <a:lstStyle/>
+          <a:p>
+            <a:pPr algn="l">
+              <a:lnSpc>
+                <a:spcPts val="1050"/>
+              </a:lnSpc>
+            </a:pPr>
+            <a:r>
+              <a:rPr sz="788" b="1" i="0" spc="15">
+                <a:solidFill>
+                  <a:srgbClr val="333231"/>
+                </a:solidFill>
+                <a:latin typeface="Calibri"/>
+              </a:rPr>
+              <a:t>Energy, Power &amp; Environmental Services</a:t>
+            </a:r>
+          </a:p>
+        </p:txBody>
+      </p:sp>
+      <p:sp>
+        <p:nvSpPr>
+          <p:cNvPr id="119" name="Text: Provider Services"/>
+          <p:cNvSpPr txBox="1"/>
+          <p:nvPr/>
+        </p:nvSpPr>
+        <p:spPr>
+          <a:xfrm>
+            <a:off x="4965700" y="6771640"/>
+            <a:ext cx="2286000" cy="133350"/>
+          </a:xfrm>
+          <a:prstGeom prst="rect">
+            <a:avLst/>
+          </a:prstGeom>
+          <a:noFill/>
+        </p:spPr>
+        <p:txBody>
+          <a:bodyPr wrap="square" lIns="0" tIns="0" rIns="0" bIns="0" anchor="t">
+            <a:spAutoFit/>
+          </a:bodyPr>
+          <a:lstStyle/>
+          <a:p>
+            <a:pPr algn="l">
+              <a:lnSpc>
+                <a:spcPts val="1050"/>
+              </a:lnSpc>
+            </a:pPr>
+            <a:r>
+              <a:rPr sz="788" b="1" i="0" spc="15">
+                <a:solidFill>
+                  <a:srgbClr val="333231"/>
+                </a:solidFill>
+                <a:latin typeface="Calibri"/>
+              </a:rPr>
+              <a:t>Transportation &amp; Logistics</a:t>
+            </a:r>
           </a:p>
         </p:txBody>
       </p:sp>

</xml_diff>

<commit_message>
Sector reports: plainer wording and no leftover tool metadata
- Key insights rewritten with varied sentence shape in place of the uniform
  "X happened, so owners should Y" pattern; every figure is unchanged and
  comes from the brief. Industrial no longer ends on a vague clause,
  Healthcare drops a claim the brief does not make and restores the note
  that 13.6x is weighted toward larger platforms.
- "Key takeaway." becomes "Our read."; "landscape" and "dynamics" in our
  own headings and cover lines become plain words. Quoted company remarks
  are left verbatim.
- Decks: removed the "generated using python-pptx" description and its
  default author, image descriptions that held build-tool file paths,
  shape and theme names still reading Benchmark Capital Markets, and
  non-breaking spaces. Author is now Benchmark International.

Co-Authored-By: Claude Opus 5.5 <noreply@anthropic.com>
Claude-Session: https://claude.ai/code/session_01BhK2XsdqdQc3W1sm6otL2z
</commit_message>
<xml_diff>
--- a/mid-market-practice/_build/reports/industrial-q4-2026/brief.pptx
+++ b/mid-market-practice/_build/reports/industrial-q4-2026/brief.pptx
@@ -9711,7 +9711,7 @@
       </p:sp>
       <p:pic>
         <p:nvPicPr>
-          <p:cNvPr id="7" name="Image 0" descr="/tmp/claude-0/-home-claude-about/b7ea608c-3502-5da6-986c-4c57d144c940/scratchpad/brief/assets/logo-black.png"/>
+          <p:cNvPr id="7" name="Image 0"/>
           <p:cNvPicPr>
             <a:picLocks noChangeAspect="1"/>
           </p:cNvPicPr>
@@ -9936,7 +9936,7 @@
       </p:grpSpPr>
       <p:pic>
         <p:nvPicPr>
-          <p:cNvPr id="2" name="Image 0" descr="/tmp/claude-0/-home-claude-about/b7ea608c-3502-5da6-986c-4c57d144c940/scratchpad/brief/assets/knot.jpg"/>
+          <p:cNvPr id="2" name="Image 0"/>
           <p:cNvPicPr>
             <a:picLocks noChangeAspect="1"/>
           </p:cNvPicPr>
@@ -9962,7 +9962,7 @@
       </p:pic>
       <p:pic>
         <p:nvPicPr>
-          <p:cNvPr id="3" name="Image 1" descr="/tmp/claude-0/-home-claude-about/b7ea608c-3502-5da6-986c-4c57d144c940/scratchpad/brief/assets/logo-white.png"/>
+          <p:cNvPr id="3" name="Image 1"/>
           <p:cNvPicPr>
             <a:picLocks noChangeAspect="1"/>
           </p:cNvPicPr>
@@ -10449,7 +10449,7 @@
       </p:grpSpPr>
       <p:pic>
         <p:nvPicPr>
-          <p:cNvPr id="2" name="Image 0" descr="/tmp/claude-0/-home-claude-about/b7ea608c-3502-5da6-986c-4c57d144c940/scratchpad/brief/assets/hero.jpg"/>
+          <p:cNvPr id="2" name="Image 0"/>
           <p:cNvPicPr>
             <a:picLocks noChangeAspect="1"/>
           </p:cNvPicPr>
@@ -10557,7 +10557,7 @@
       </p:sp>
       <p:pic>
         <p:nvPicPr>
-          <p:cNvPr id="6" name="Image 1" descr="/tmp/claude-0/-home-claude-about/b7ea608c-3502-5da6-986c-4c57d144c940/scratchpad/brief/assets/logo-white.png"/>
+          <p:cNvPr id="6" name="Image 1"/>
           <p:cNvPicPr>
             <a:picLocks noChangeAspect="1"/>
           </p:cNvPicPr>
@@ -10757,7 +10757,7 @@
       </p:sp>
       <p:pic>
         <p:nvPicPr>
-          <p:cNvPr id="12" name="Image 2" descr="/tmp/claude-0/-home-claude-about/b7ea608c-3502-5da6-986c-4c57d144c940/scratchpad/brief/pptx/icons/factory_lg.png"/>
+          <p:cNvPr id="12" name="Image 2"/>
           <p:cNvPicPr>
             <a:picLocks noChangeAspect="1"/>
           </p:cNvPicPr>
@@ -10817,7 +10817,7 @@
       </p:sp>
       <p:pic>
         <p:nvPicPr>
-          <p:cNvPr id="14" name="Image 3" descr="/tmp/claude-0/-home-claude-about/b7ea608c-3502-5da6-986c-4c57d144c940/scratchpad/brief/pptx/icons/boxes_lg.png"/>
+          <p:cNvPr id="14" name="Image 3"/>
           <p:cNvPicPr>
             <a:picLocks noChangeAspect="1"/>
           </p:cNvPicPr>
@@ -10877,7 +10877,7 @@
       </p:sp>
       <p:pic>
         <p:nvPicPr>
-          <p:cNvPr id="16" name="Image 4" descr="/tmp/claude-0/-home-claude-about/b7ea608c-3502-5da6-986c-4c57d144c940/scratchpad/brief/pptx/icons/building_lg.png"/>
+          <p:cNvPr id="16" name="Image 4"/>
           <p:cNvPicPr>
             <a:picLocks noChangeAspect="1"/>
           </p:cNvPicPr>
@@ -10937,7 +10937,7 @@
       </p:sp>
       <p:pic>
         <p:nvPicPr>
-          <p:cNvPr id="18" name="Image 5" descr="/tmp/claude-0/-home-claude-about/b7ea608c-3502-5da6-986c-4c57d144c940/scratchpad/brief/pptx/icons/bolt_lg.png"/>
+          <p:cNvPr id="18" name="Image 5"/>
           <p:cNvPicPr>
             <a:picLocks noChangeAspect="1"/>
           </p:cNvPicPr>
@@ -10997,7 +10997,7 @@
       </p:sp>
       <p:pic>
         <p:nvPicPr>
-          <p:cNvPr id="20" name="Image 6" descr="/tmp/claude-0/-home-claude-about/b7ea608c-3502-5da6-986c-4c57d144c940/scratchpad/brief/pptx/icons/truck_lg.png"/>
+          <p:cNvPr id="20" name="Image 6"/>
           <p:cNvPicPr>
             <a:picLocks noChangeAspect="1"/>
           </p:cNvPicPr>
@@ -11836,7 +11836,7 @@
       </p:sp>
       <p:pic>
         <p:nvPicPr>
-          <p:cNvPr id="7" name="Image 0" descr="/tmp/claude-0/-home-claude-about/b7ea608c-3502-5da6-986c-4c57d144c940/scratchpad/brief/pptx/icons/factory_dg.png"/>
+          <p:cNvPr id="7" name="Image 0"/>
           <p:cNvPicPr>
             <a:picLocks noChangeAspect="1"/>
           </p:cNvPicPr>
@@ -12469,7 +12469,7 @@
       </p:sp>
       <p:pic>
         <p:nvPicPr>
-          <p:cNvPr id="16" name="Image 1" descr="/tmp/claude-0/-home-claude-about/b7ea608c-3502-5da6-986c-4c57d144c940/scratchpad/brief/pptx/icons/boxes_dg.png"/>
+          <p:cNvPr id="16" name="Image 1"/>
           <p:cNvPicPr>
             <a:picLocks noChangeAspect="1"/>
           </p:cNvPicPr>
@@ -13102,7 +13102,7 @@
       </p:sp>
       <p:pic>
         <p:nvPicPr>
-          <p:cNvPr id="25" name="Image 2" descr="/tmp/claude-0/-home-claude-about/b7ea608c-3502-5da6-986c-4c57d144c940/scratchpad/brief/pptx/icons/building_dg.png"/>
+          <p:cNvPr id="25" name="Image 2"/>
           <p:cNvPicPr>
             <a:picLocks noChangeAspect="1"/>
           </p:cNvPicPr>
@@ -13735,7 +13735,7 @@
       </p:sp>
       <p:pic>
         <p:nvPicPr>
-          <p:cNvPr id="34" name="Image 3" descr="/tmp/claude-0/-home-claude-about/b7ea608c-3502-5da6-986c-4c57d144c940/scratchpad/brief/pptx/icons/bolt_dg.png"/>
+          <p:cNvPr id="34" name="Image 3"/>
           <p:cNvPicPr>
             <a:picLocks noChangeAspect="1"/>
           </p:cNvPicPr>
@@ -14368,7 +14368,7 @@
       </p:sp>
       <p:pic>
         <p:nvPicPr>
-          <p:cNvPr id="43" name="Image 4" descr="/tmp/claude-0/-home-claude-about/b7ea608c-3502-5da6-986c-4c57d144c940/scratchpad/brief/pptx/icons/truck_dg.png"/>
+          <p:cNvPr id="43" name="Image 4"/>
           <p:cNvPicPr>
             <a:picLocks noChangeAspect="1"/>
           </p:cNvPicPr>
@@ -20011,7 +20011,7 @@
       </p:grpSpPr>
       <p:pic>
         <p:nvPicPr>
-          <p:cNvPr id="2" name="Image 0" descr="/tmp/claude-0/-home-claude-about/b7ea608c-3502-5da6-986c-4c57d144c940/scratchpad/brief/assets/meeting.jpg"/>
+          <p:cNvPr id="2" name="Image 0"/>
           <p:cNvPicPr>
             <a:picLocks noChangeAspect="1"/>
           </p:cNvPicPr>
@@ -21009,7 +21009,7 @@
       </p:sp>
       <p:pic>
         <p:nvPicPr>
-          <p:cNvPr id="10" name="Image 0" descr="/tmp/claude-0/-home-claude-about/b7ea608c-3502-5da6-986c-4c57d144c940/scratchpad/brief/assets/jared-hardin.jpg"/>
+          <p:cNvPr id="10" name="Image 0"/>
           <p:cNvPicPr>
             <a:picLocks noChangeAspect="1"/>
           </p:cNvPicPr>
@@ -21230,7 +21230,7 @@
       </p:sp>
       <p:pic>
         <p:nvPicPr>
-          <p:cNvPr id="16" name="Image 1" descr="/tmp/claude-0/-home-claude-about/b7ea608c-3502-5da6-986c-4c57d144c940/scratchpad/brief/assets/jordan-houtz.jpg"/>
+          <p:cNvPr id="16" name="Image 1"/>
           <p:cNvPicPr>
             <a:picLocks noChangeAspect="1"/>
           </p:cNvPicPr>
@@ -21381,7 +21381,7 @@
       </p:sp>
       <p:pic>
         <p:nvPicPr>
-          <p:cNvPr id="22" name="Image 2" descr="/tmp/claude-0/-home-claude-about/b7ea608c-3502-5da6-986c-4c57d144c940/scratchpad/brief/assets/alex-zykov.jpg"/>
+          <p:cNvPr id="22" name="Image 2"/>
           <p:cNvPicPr>
             <a:picLocks noChangeAspect="1"/>
           </p:cNvPicPr>
@@ -21532,7 +21532,7 @@
       </p:sp>
       <p:pic>
         <p:nvPicPr>
-          <p:cNvPr id="28" name="Image 3" descr="/tmp/claude-0/-home-claude-about/b7ea608c-3502-5da6-986c-4c57d144c940/scratchpad/brief/assets/shannon-hess.jpg"/>
+          <p:cNvPr id="28" name="Image 3"/>
           <p:cNvPicPr>
             <a:picLocks noChangeAspect="1"/>
           </p:cNvPicPr>
@@ -22176,7 +22176,7 @@
       </p:sp>
       <p:pic>
         <p:nvPicPr>
-          <p:cNvPr id="47" name="Image 4" descr="/tmp/claude-0/-home-claude-about/b7ea608c-3502-5da6-986c-4c57d144c940/scratchpad/brief/assets/logo-white.png"/>
+          <p:cNvPr id="47" name="Image 4"/>
           <p:cNvPicPr>
             <a:picLocks noChangeAspect="1"/>
           </p:cNvPicPr>
@@ -22527,7 +22527,7 @@
       </p:sp>
       <p:pic>
         <p:nvPicPr>
-          <p:cNvPr id="57" name="Image 5" descr="/tmp/claude-0/-home-claude-about/b7ea608c-3502-5da6-986c-4c57d144c940/scratchpad/brief/pptx/icons/factory_lg.png"/>
+          <p:cNvPr id="57" name="Image 5"/>
           <p:cNvPicPr>
             <a:picLocks noChangeAspect="1"/>
           </p:cNvPicPr>
@@ -22587,7 +22587,7 @@
       </p:sp>
       <p:pic>
         <p:nvPicPr>
-          <p:cNvPr id="59" name="Image 6" descr="/tmp/claude-0/-home-claude-about/b7ea608c-3502-5da6-986c-4c57d144c940/scratchpad/brief/pptx/icons/boxes_lg.png"/>
+          <p:cNvPr id="59" name="Image 6"/>
           <p:cNvPicPr>
             <a:picLocks noChangeAspect="1"/>
           </p:cNvPicPr>
@@ -22647,7 +22647,7 @@
       </p:sp>
       <p:pic>
         <p:nvPicPr>
-          <p:cNvPr id="61" name="Image 7" descr="/tmp/claude-0/-home-claude-about/b7ea608c-3502-5da6-986c-4c57d144c940/scratchpad/brief/pptx/icons/building_lg.png"/>
+          <p:cNvPr id="61" name="Image 7"/>
           <p:cNvPicPr>
             <a:picLocks noChangeAspect="1"/>
           </p:cNvPicPr>
@@ -22707,7 +22707,7 @@
       </p:sp>
       <p:pic>
         <p:nvPicPr>
-          <p:cNvPr id="63" name="Image 8" descr="/tmp/claude-0/-home-claude-about/b7ea608c-3502-5da6-986c-4c57d144c940/scratchpad/brief/pptx/icons/bolt_lg.png"/>
+          <p:cNvPr id="63" name="Image 8"/>
           <p:cNvPicPr>
             <a:picLocks noChangeAspect="1"/>
           </p:cNvPicPr>
@@ -22767,7 +22767,7 @@
       </p:sp>
       <p:pic>
         <p:nvPicPr>
-          <p:cNvPr id="65" name="Image 9" descr="/tmp/claude-0/-home-claude-about/b7ea608c-3502-5da6-986c-4c57d144c940/scratchpad/brief/pptx/icons/truck_lg.png"/>
+          <p:cNvPr id="65" name="Image 9"/>
           <p:cNvPicPr>
             <a:picLocks noChangeAspect="1"/>
           </p:cNvPicPr>
@@ -23459,7 +23459,7 @@
       </p:sp>
       <p:sp>
         <p:nvSpPr>
-          <p:cNvPr id="6" name="Text: The BCM team leads each engagement"/>
+          <p:cNvPr id="6" name="TextBox"/>
           <p:cNvSpPr txBox="1"/>
           <p:nvPr/>
         </p:nvSpPr>
@@ -23587,7 +23587,7 @@
       </p:pic>
       <p:sp>
         <p:nvSpPr>
-          <p:cNvPr id="10" name="Text: Benchmark Capital Markets"/>
+          <p:cNvPr id="10" name="TextBox"/>
           <p:cNvSpPr txBox="1"/>
           <p:nvPr/>
         </p:nvSpPr>
@@ -23657,7 +23657,7 @@
       </p:sp>
       <p:sp>
         <p:nvSpPr>
-          <p:cNvPr id="12" name="Text: Benchmark Capital Markets (BCM) re"/>
+          <p:cNvPr id="12" name="TextBox"/>
           <p:cNvSpPr txBox="1"/>
           <p:nvPr/>
         </p:nvSpPr>
@@ -30419,7 +30419,7 @@
       </p:grpSpPr>
       <p:pic>
         <p:nvPicPr>
-          <p:cNvPr id="2" name="Image 0" descr="/tmp/claude-0/-home-claude-about/b7ea608c-3502-5da6-986c-4c57d144c940/scratchpad/brief/assets/robots.jpg"/>
+          <p:cNvPr id="2" name="Image 0"/>
           <p:cNvPicPr>
             <a:picLocks noChangeAspect="1"/>
           </p:cNvPicPr>
@@ -30698,7 +30698,7 @@
                 </a:solidFill>
                 <a:latin typeface="+mn-lt"/>
               </a:rPr>
-              <a:t>Power and data center work commands top value</a:t>
+              <a:t>Power and data center work earns the premium</a:t>
             </a:r>
           </a:p>
           <a:p>
@@ -30714,7 +30714,7 @@
                 </a:solidFill>
                 <a:latin typeface="+mn-lt"/>
               </a:rPr>
-              <a:t>Quanta Services ended June with a $53.4 billion backlog, up from $35.8 billion, and buyers will ask how much of a company's backlog is tied to funded power and data center work.</a:t>
+              <a:t>Quanta Services ended June with $53.4 billion of backlog, up from $35.8 billion. A buyer will ask how much of yours is tied to funded power and data center work.</a:t>
             </a:r>
           </a:p>
           <a:p>
@@ -30739,7 +30739,7 @@
                 </a:solidFill>
                 <a:latin typeface="+mn-lt"/>
               </a:rPr>
-              <a:t>Your likely buyer is an operating platform</a:t>
+              <a:t>The likely buyer is an operating platform</a:t>
             </a:r>
           </a:p>
           <a:p>
@@ -30755,7 +30755,7 @@
                 </a:solidFill>
                 <a:latin typeface="+mn-lt"/>
               </a:rPr>
-              <a:t>Add-on acquisitions made up about three-quarters of buyouts in the second quarter, and Pye-Barker Fire &amp; Safety completed 22 acquisitions in the first half, so owners should expect a sponsor that knows their trade.</a:t>
+              <a:t>Add-ons made up about three-quarters of buyouts in the second quarter, and Pye-Barker Fire &amp; Safety completed 22 acquisitions in the first half. Expect a sponsor that already knows the trade.</a:t>
             </a:r>
           </a:p>
           <a:p>
@@ -30780,7 +30780,7 @@
                 </a:solidFill>
                 <a:latin typeface="+mn-lt"/>
               </a:rPr>
-              <a:t>Report service revenue separately from projects</a:t>
+              <a:t>Report service revenue on its own line</a:t>
             </a:r>
           </a:p>
           <a:p>
@@ -30796,7 +30796,7 @@
                 </a:solidFill>
                 <a:latin typeface="+mn-lt"/>
               </a:rPr>
-              <a:t>APi Group is working toward 60% of revenue from inspection and service, and buyers pay more for service, repair and aftermarket revenue that an owner reports separately with its renewal history.</a:t>
+              <a:t>APi Group is working toward 60% of revenue from inspection and service. Buyers pay more for service, repair and aftermarket revenue when it is reported apart from projects, with its renewal history.</a:t>
             </a:r>
           </a:p>
           <a:p>
@@ -30821,7 +30821,7 @@
                 </a:solidFill>
                 <a:latin typeface="+mn-lt"/>
               </a:rPr>
-              <a:t>Higher financing costs make buyers more selective</a:t>
+              <a:t>Financing costs more and buyers are choosier</a:t>
             </a:r>
           </a:p>
           <a:p>
@@ -30837,7 +30837,7 @@
                 </a:solidFill>
                 <a:latin typeface="+mn-lt"/>
               </a:rPr>
-              <a:t>The Federal Reserve raised its target range to 3.75% to 4.00% on September 16, and GF Data's average multiple eased to 7.0 times trailing adjusted EBITDA from 7.3 times, so preparation matters more.</a:t>
+              <a:t>The Federal Reserve raised its target range to 3.75% to 4.00% on September 16. GF Data's average multiple eased to 7.0 times trailing adjusted EBITDA, from 7.3 times.</a:t>
             </a:r>
           </a:p>
         </p:txBody>
@@ -31016,7 +31016,7 @@
       </p:sp>
       <p:pic>
         <p:nvPicPr>
-          <p:cNvPr id="6" name="Image 0" descr="/tmp/claude-0/-home-claude-about/b7ea608c-3502-5da6-986c-4c57d144c940/scratchpad/brief/assets/technicians.jpg"/>
+          <p:cNvPr id="6" name="Image 0"/>
           <p:cNvPicPr>
             <a:picLocks noChangeAspect="1"/>
           </p:cNvPicPr>
@@ -31208,7 +31208,7 @@
       </p:sp>
       <p:pic>
         <p:nvPicPr>
-          <p:cNvPr id="12" name="Image 1" descr="/tmp/claude-0/-home-claude-about/b7ea608c-3502-5da6-986c-4c57d144c940/scratchpad/brief/pptx/icons/factory_lg.png"/>
+          <p:cNvPr id="12" name="Image 1"/>
           <p:cNvPicPr>
             <a:picLocks noChangeAspect="1"/>
           </p:cNvPicPr>
@@ -31539,7 +31539,7 @@
       </p:sp>
       <p:pic>
         <p:nvPicPr>
-          <p:cNvPr id="20" name="Image 2" descr="/tmp/claude-0/-home-claude-about/b7ea608c-3502-5da6-986c-4c57d144c940/scratchpad/brief/pptx/icons/layers_lg.png"/>
+          <p:cNvPr id="20" name="Image 2"/>
           <p:cNvPicPr>
             <a:picLocks noChangeAspect="1"/>
           </p:cNvPicPr>
@@ -31847,7 +31847,7 @@
       </p:sp>
       <p:pic>
         <p:nvPicPr>
-          <p:cNvPr id="28" name="Image 3" descr="/tmp/claude-0/-home-claude-about/b7ea608c-3502-5da6-986c-4c57d144c940/scratchpad/brief/pptx/icons/bolt_lg.png"/>
+          <p:cNvPr id="28" name="Image 3"/>
           <p:cNvPicPr>
             <a:picLocks noChangeAspect="1"/>
           </p:cNvPicPr>
@@ -32144,7 +32144,7 @@
       </p:sp>
       <p:pic>
         <p:nvPicPr>
-          <p:cNvPr id="36" name="Image 4" descr="/tmp/claude-0/-home-claude-about/b7ea608c-3502-5da6-986c-4c57d144c940/scratchpad/brief/pptx/icons/wrench_lg.png"/>
+          <p:cNvPr id="36" name="Image 4"/>
           <p:cNvPicPr>
             <a:picLocks noChangeAspect="1"/>
           </p:cNvPicPr>
@@ -32452,7 +32452,7 @@
       </p:sp>
       <p:pic>
         <p:nvPicPr>
-          <p:cNvPr id="44" name="Image 5" descr="/tmp/claude-0/-home-claude-about/b7ea608c-3502-5da6-986c-4c57d144c940/scratchpad/brief/pptx/icons/percent_lg.png"/>
+          <p:cNvPr id="44" name="Image 5"/>
           <p:cNvPicPr>
             <a:picLocks noChangeAspect="1"/>
           </p:cNvPicPr>
@@ -33380,7 +33380,7 @@
       </p:sp>
       <p:pic>
         <p:nvPicPr>
-          <p:cNvPr id="13" name="Image 0" descr="/tmp/claude-0/-home-claude-about/b7ea608c-3502-5da6-986c-4c57d144c940/scratchpad/brief/pptx/icons/factory_lg.png"/>
+          <p:cNvPr id="13" name="Image 0"/>
           <p:cNvPicPr>
             <a:picLocks noChangeAspect="1"/>
           </p:cNvPicPr>
@@ -33559,7 +33559,7 @@
       </p:sp>
       <p:pic>
         <p:nvPicPr>
-          <p:cNvPr id="18" name="Image 1" descr="/tmp/claude-0/-home-claude-about/b7ea608c-3502-5da6-986c-4c57d144c940/scratchpad/brief/pptx/icons/boxes_lg.png"/>
+          <p:cNvPr id="18" name="Image 1"/>
           <p:cNvPicPr>
             <a:picLocks noChangeAspect="1"/>
           </p:cNvPicPr>
@@ -33738,7 +33738,7 @@
       </p:sp>
       <p:pic>
         <p:nvPicPr>
-          <p:cNvPr id="23" name="Image 2" descr="/tmp/claude-0/-home-claude-about/b7ea608c-3502-5da6-986c-4c57d144c940/scratchpad/brief/pptx/icons/building_lg.png"/>
+          <p:cNvPr id="23" name="Image 2"/>
           <p:cNvPicPr>
             <a:picLocks noChangeAspect="1"/>
           </p:cNvPicPr>
@@ -33940,7 +33940,7 @@
       </p:sp>
       <p:pic>
         <p:nvPicPr>
-          <p:cNvPr id="28" name="Image 3" descr="/tmp/claude-0/-home-claude-about/b7ea608c-3502-5da6-986c-4c57d144c940/scratchpad/brief/pptx/icons/bolt_lg.png"/>
+          <p:cNvPr id="28" name="Image 3"/>
           <p:cNvPicPr>
             <a:picLocks noChangeAspect="1"/>
           </p:cNvPicPr>
@@ -34142,7 +34142,7 @@
       </p:sp>
       <p:pic>
         <p:nvPicPr>
-          <p:cNvPr id="33" name="Image 4" descr="/tmp/claude-0/-home-claude-about/b7ea608c-3502-5da6-986c-4c57d144c940/scratchpad/brief/pptx/icons/truck_lg.png"/>
+          <p:cNvPr id="33" name="Image 4"/>
           <p:cNvPicPr>
             <a:picLocks noChangeAspect="1"/>
           </p:cNvPicPr>
@@ -34314,7 +34314,7 @@
       </p:sp>
       <p:pic>
         <p:nvPicPr>
-          <p:cNvPr id="37" name="Image 5" descr="/tmp/claude-0/-home-claude-about/b7ea608c-3502-5da6-986c-4c57d144c940/scratchpad/brief/assets/plant.jpg"/>
+          <p:cNvPr id="37" name="Image 5"/>
           <p:cNvPicPr>
             <a:picLocks noChangeAspect="1"/>
           </p:cNvPicPr>
@@ -35111,7 +35111,7 @@
       </p:sp>
       <p:pic>
         <p:nvPicPr>
-          <p:cNvPr id="6" name="Image 0" descr="/tmp/claude-0/-home-claude-about/b7ea608c-3502-5da6-986c-4c57d144c940/scratchpad/brief/assets/signing.jpg"/>
+          <p:cNvPr id="6" name="Image 0"/>
           <p:cNvPicPr>
             <a:picLocks noChangeAspect="1"/>
           </p:cNvPicPr>
@@ -36538,7 +36538,7 @@
       </p:sp>
       <p:pic>
         <p:nvPicPr>
-          <p:cNvPr id="44" name="Image 1" descr="/tmp/claude-0/-home-claude-about/b7ea608c-3502-5da6-986c-4c57d144c940/scratchpad/brief/assets/jared-hardin.jpg"/>
+          <p:cNvPr id="44" name="Image 1"/>
           <p:cNvPicPr>
             <a:picLocks noChangeAspect="1"/>
           </p:cNvPicPr>
@@ -36759,7 +36759,7 @@
       </p:sp>
       <p:pic>
         <p:nvPicPr>
-          <p:cNvPr id="50" name="Image 2" descr="/tmp/claude-0/-home-claude-about/b7ea608c-3502-5da6-986c-4c57d144c940/scratchpad/brief/assets/jordan-houtz.jpg"/>
+          <p:cNvPr id="50" name="Image 2"/>
           <p:cNvPicPr>
             <a:picLocks noChangeAspect="1"/>
           </p:cNvPicPr>
@@ -37014,7 +37014,7 @@
       </p:grpSpPr>
       <p:pic>
         <p:nvPicPr>
-          <p:cNvPr id="2" name="Image 0" descr="/tmp/claude-0/-home-claude-about/b7ea608c-3502-5da6-986c-4c57d144c940/scratchpad/brief/assets/lathe.jpg"/>
+          <p:cNvPr id="2" name="Image 0"/>
           <p:cNvPicPr>
             <a:picLocks noChangeAspect="1"/>
           </p:cNvPicPr>
@@ -46147,9 +46147,9 @@
 </file>
 
 <file path=ppt/theme/theme1.xml><?xml version="1.0" encoding="utf-8"?>
-<a:theme xmlns:a="http://schemas.openxmlformats.org/drawingml/2006/main" name="Benchmark Capital Markets">
+<a:theme xmlns:a="http://schemas.openxmlformats.org/drawingml/2006/main" name="Benchmark International">
   <a:themeElements>
-    <a:clrScheme name="Benchmark Capital Markets">
+    <a:clrScheme name="Benchmark International">
       <a:dk1>
         <a:srgbClr val="1B1A1A"/>
       </a:dk1>
@@ -46187,7 +46187,7 @@
         <a:srgbClr val="5E4126"/>
       </a:folHlink>
     </a:clrScheme>
-    <a:fontScheme name="Benchmark Capital Markets">
+    <a:fontScheme name="Benchmark International">
       <a:majorFont>
         <a:latin typeface="Cambria"/>
         <a:ea typeface=""/>

</xml_diff>

<commit_message>
Describe services as majority and control transactions and strategic partnerships
Replace recapitalization, partial sale and growth capital language across the site, the industry report decks and the generated reports.
</commit_message>
<xml_diff>
--- a/mid-market-practice/_build/reports/industrial-q4-2026/brief.pptx
+++ b/mid-market-practice/_build/reports/industrial-q4-2026/brief.pptx
@@ -20225,7 +20225,7 @@
                   <a:srgbClr val="E8E2DA"/>
                 </a:solidFill>
               </a:rPr>
-              <a:t>Benchmark International's Middle Market team represents owners of privately held companies with $50 million to $500 million of total enterprise value in sales, recapitalizations and growth partnerships. The first step is a confidential conversation about your goals, your company and your options, with no pressure and no commitment.</a:t>
+              <a:t>Benchmark International's Middle Market team represents owners of privately held companies with $50 million to $500 million of total enterprise value in majority and control transactions and strategic partnerships. The first step is a confidential conversation about your goals, your company and your options, with no pressure and no commitment.</a:t>
             </a:r>
             <a:endParaRPr lang="en-US" sz="1013" dirty="0"/>
           </a:p>
@@ -20947,7 +20947,7 @@
                   <a:srgbClr val="333231"/>
                 </a:solidFill>
               </a:rPr>
-              <a:t>Owners considering a sale, a recapitalization or a growth partnership in any of the five industrial sectors, and the accountants, attorneys and wealth advisors who work with them, are welcome to call or write. Every engagement is led by the Middle Market team and backed by Benchmark International’s global network of strategic acquirers, private equity groups, family offices and independent sponsors.</a:t>
+              <a:t>Owners considering a sale, a majority or control transaction or a strategic partnership in any of the five industrial sectors, and the accountants, attorneys and wealth advisors who work with them, are welcome to call or write. Every engagement is led by the Middle Market team and backed by Benchmark International’s global network of strategic acquirers, private equity groups, family offices and independent sponsors.</a:t>
             </a:r>
             <a:endParaRPr lang="en-US" sz="938" dirty="0"/>
           </a:p>
@@ -22047,7 +22047,7 @@
                   <a:srgbClr val="6F6A66"/>
                 </a:solidFill>
               </a:rPr>
-              <a:t>Understand the paths available, from a partial recapitalization to a full sale, and what each could mean for you.</a:t>
+              <a:t>Understand the paths available, from a full sale to a strategic partnership, and what each could mean for you.</a:t>
             </a:r>
             <a:endParaRPr lang="en-US" sz="765" dirty="0"/>
           </a:p>
@@ -23549,7 +23549,7 @@
                 </a:solidFill>
                 <a:latin typeface="Calibri"/>
               </a:rPr>
-              <a:t>Benchmark International's Middle Market team represents owners of privately held companies with $50 million to $500 million of total enterprise value in sales, recapitalizations and growth partnerships.</a:t>
+              <a:t>Benchmark International's Middle Market team represents owners of privately held companies with $50 million to $500 million of total enterprise value in majority and control transactions and strategic partnerships.</a:t>
             </a:r>
           </a:p>
         </p:txBody>

</xml_diff>

<commit_message>
Smooth service wording and fix awkward grammar across the site and reports
</commit_message>
<xml_diff>
--- a/mid-market-practice/_build/reports/industrial-q4-2026/brief.pptx
+++ b/mid-market-practice/_build/reports/industrial-q4-2026/brief.pptx
@@ -20225,7 +20225,7 @@
                   <a:srgbClr val="E8E2DA"/>
                 </a:solidFill>
               </a:rPr>
-              <a:t>Benchmark International's Middle Market team represents owners of privately held companies with $50 million to $500 million of total enterprise value in majority and control transactions and strategic partnerships. The first step is a confidential conversation about your goals, your company and your options, with no pressure and no commitment.</a:t>
+              <a:t>Benchmark International's Middle Market team represents owners of privately held companies with $50 million to $500 million of total enterprise value, from majority and control transactions to strategic partnerships. The first step is a confidential conversation about your goals, your company and your options, with no pressure and no commitment.</a:t>
             </a:r>
             <a:endParaRPr lang="en-US" sz="1013" dirty="0"/>
           </a:p>
@@ -20947,7 +20947,7 @@
                   <a:srgbClr val="333231"/>
                 </a:solidFill>
               </a:rPr>
-              <a:t>Owners considering a sale, a majority or control transaction or a strategic partnership in any of the five industrial sectors, and the accountants, attorneys and wealth advisors who work with them, are welcome to call or write. Every engagement is led by the Middle Market team and backed by Benchmark International’s global network of strategic acquirers, private equity groups, family offices and independent sponsors.</a:t>
+              <a:t>We welcome calls from owners considering a sale or strategic partnership in any of our five industries, and from the accountants, attorneys and wealth advisors who work with them. Every engagement is led by the Middle Market team and backed by Benchmark International’s global network of strategic acquirers, private equity groups, family offices and independent sponsors.</a:t>
             </a:r>
             <a:endParaRPr lang="en-US" sz="938" dirty="0"/>
           </a:p>
@@ -23549,7 +23549,7 @@
                 </a:solidFill>
                 <a:latin typeface="Calibri"/>
               </a:rPr>
-              <a:t>Benchmark International's Middle Market team represents owners of privately held companies with $50 million to $500 million of total enterprise value in majority and control transactions and strategic partnerships.</a:t>
+              <a:t>Benchmark International's Middle Market team represents owners of privately held companies with $50 million to $500 million of total enterprise value, from majority and control transactions to strategic partnerships.</a:t>
             </a:r>
           </a:p>
         </p:txBody>

</xml_diff>

<commit_message>
Punchlist: new hero, industries moved up, Jordan's title, Insights and Industries labels, footnote, FAQ updates
</commit_message>
<xml_diff>
--- a/mid-market-practice/_build/reports/industrial-q4-2026/brief.pptx
+++ b/mid-market-practice/_build/reports/industrial-q4-2026/brief.pptx
@@ -21298,16 +21298,16 @@
         <p:spPr>
           <a:xfrm>
             <a:off x="4591050" y="3419475"/>
-            <a:ext cx="1790700" cy="123825"/>
-          </a:xfrm>
-          <a:prstGeom prst="rect">
-            <a:avLst/>
-          </a:prstGeom>
-          <a:noFill/>
-          <a:ln/>
-        </p:spPr>
-        <p:txBody>
-          <a:bodyPr wrap="square" lIns="0" tIns="0" rIns="0" bIns="0" rtlCol="0" anchor="t"/>
+            <a:ext cx="1790700" cy="233210"/>
+          </a:xfrm>
+          <a:prstGeom prst="rect">
+            <a:avLst/>
+          </a:prstGeom>
+          <a:noFill/>
+          <a:ln/>
+        </p:spPr>
+        <p:txBody>
+          <a:bodyPr wrap="none" lIns="0" tIns="0" rIns="0" bIns="0" rtlCol="0" anchor="t"/>
           <a:lstStyle/>
           <a:p>
             <a:pPr marL="0" indent="0">
@@ -21320,6 +21320,21 @@
                 </a:solidFill>
               </a:rPr>
               <a:t>MANAGING DIRECTOR</a:t>
+            </a:r>
+            <a:br>
+              <a:rPr lang="en-US" sz="638" b="1" kern="0" spc="150" dirty="0">
+                <a:solidFill>
+                  <a:srgbClr val="8C6239"/>
+                </a:solidFill>
+              </a:rPr>
+            </a:br>
+            <a:r>
+              <a:rPr lang="en-US" sz="638" b="1" kern="0" spc="150" dirty="0">
+                <a:solidFill>
+                  <a:srgbClr val="8C6239"/>
+                </a:solidFill>
+              </a:rPr>
+              <a:t>HEAD OF MIDDLE MARKET</a:t>
             </a:r>
             <a:endParaRPr lang="en-US" sz="638" dirty="0"/>
           </a:p>
@@ -23089,7 +23104,7 @@
         </p:nvSpPr>
         <p:spPr>
           <a:xfrm>
-            <a:off x="4591050" y="3581400"/>
+            <a:off x="4591050" y="3690785"/>
             <a:ext cx="1790700" cy="381000"/>
           </a:xfrm>
           <a:prstGeom prst="rect">
@@ -24120,16 +24135,16 @@
         </p:nvSpPr>
         <p:spPr>
           <a:xfrm>
-            <a:off x="2963912" y="2971800"/>
-            <a:ext cx="996702" cy="123825"/>
-          </a:xfrm>
-          <a:prstGeom prst="rect">
-            <a:avLst/>
-          </a:prstGeom>
-          <a:noFill/>
-        </p:spPr>
-        <p:txBody>
-          <a:bodyPr wrap="square" lIns="0" tIns="0" rIns="0" bIns="0" anchor="t">
+            <a:off x="2637263" y="2971800"/>
+            <a:ext cx="1650000" cy="233210"/>
+          </a:xfrm>
+          <a:prstGeom prst="rect">
+            <a:avLst/>
+          </a:prstGeom>
+          <a:noFill/>
+        </p:spPr>
+        <p:txBody>
+          <a:bodyPr wrap="none" lIns="0" tIns="0" rIns="0" bIns="0" anchor="t">
             <a:spAutoFit/>
           </a:bodyPr>
           <a:lstStyle/>
@@ -24147,6 +24162,23 @@
                 <a:latin typeface="Calibri"/>
               </a:rPr>
               <a:t>MANAGING DIRECTOR</a:t>
+            </a:r>
+            <a:br>
+              <a:rPr sz="638" b="1" i="0" spc="105">
+                <a:solidFill>
+                  <a:srgbClr val="8C6239"/>
+                </a:solidFill>
+                <a:latin typeface="Calibri"/>
+              </a:rPr>
+            </a:br>
+            <a:r>
+              <a:rPr sz="638" b="1" i="0" spc="105">
+                <a:solidFill>
+                  <a:srgbClr val="8C6239"/>
+                </a:solidFill>
+                <a:latin typeface="Calibri"/>
+              </a:rPr>
+              <a:t>HEAD OF MIDDLE MARKET</a:t>
             </a:r>
           </a:p>
         </p:txBody>
@@ -26469,7 +26501,7 @@
         </p:nvSpPr>
         <p:spPr>
           <a:xfrm>
-            <a:off x="2835920" y="3162300"/>
+            <a:off x="2835920" y="3271685"/>
             <a:ext cx="1252686" cy="304800"/>
           </a:xfrm>
           <a:prstGeom prst="rect">
@@ -36200,16 +36232,16 @@
         <p:spPr>
           <a:xfrm>
             <a:off x="8020050" y="5905500"/>
-            <a:ext cx="1524000" cy="123825"/>
-          </a:xfrm>
-          <a:prstGeom prst="rect">
-            <a:avLst/>
-          </a:prstGeom>
-          <a:noFill/>
-          <a:ln/>
-        </p:spPr>
-        <p:txBody>
-          <a:bodyPr wrap="square" lIns="0" tIns="0" rIns="0" bIns="0" rtlCol="0" anchor="t"/>
+            <a:ext cx="1650000" cy="226695"/>
+          </a:xfrm>
+          <a:prstGeom prst="rect">
+            <a:avLst/>
+          </a:prstGeom>
+          <a:noFill/>
+          <a:ln/>
+        </p:spPr>
+        <p:txBody>
+          <a:bodyPr wrap="none" lIns="0" tIns="0" rIns="0" bIns="0" rtlCol="0" anchor="t"/>
           <a:lstStyle/>
           <a:p>
             <a:pPr marL="0" indent="0">
@@ -36222,6 +36254,21 @@
                 </a:solidFill>
               </a:rPr>
               <a:t>MANAGING DIRECTOR</a:t>
+            </a:r>
+            <a:br>
+              <a:rPr lang="en-US" sz="600" b="1" kern="0" spc="120" dirty="0">
+                <a:solidFill>
+                  <a:srgbClr val="8C6239"/>
+                </a:solidFill>
+              </a:rPr>
+            </a:br>
+            <a:r>
+              <a:rPr lang="en-US" sz="600" b="1" kern="0" spc="120" dirty="0">
+                <a:solidFill>
+                  <a:srgbClr val="8C6239"/>
+                </a:solidFill>
+              </a:rPr>
+              <a:t>HEAD OF MIDDLE MARKET</a:t>
             </a:r>
             <a:endParaRPr lang="en-US" sz="600" dirty="0"/>
           </a:p>
@@ -36235,7 +36282,7 @@
         </p:nvSpPr>
         <p:spPr>
           <a:xfrm>
-            <a:off x="8020050" y="6038850"/>
+            <a:off x="8020050" y="6141720"/>
             <a:ext cx="1524000" cy="304800"/>
           </a:xfrm>
           <a:prstGeom prst="rect">

</xml_diff>

<commit_message>
Apply Jordan's rewrites to the industry and About pages; remove strategic partnerships language; add FINRA and services FAQ answers
</commit_message>
<xml_diff>
--- a/mid-market-practice/_build/reports/industrial-q4-2026/brief.pptx
+++ b/mid-market-practice/_build/reports/industrial-q4-2026/brief.pptx
@@ -20225,7 +20225,7 @@
                   <a:srgbClr val="E8E2DA"/>
                 </a:solidFill>
               </a:rPr>
-              <a:t>Benchmark International's Middle Market team represents owners of privately held companies with $50 million to $500 million of total enterprise value, from majority and control transactions to strategic partnerships. The first step is a confidential conversation about your goals, your company and your options, with no pressure and no commitment.</a:t>
+              <a:t>Benchmark International's Middle Market team represents owners of privately held companies with $50 million to $500 million of total enterprise value on strategic sales, mergers, and qualifying change-of-control transactions. The first step is a confidential conversation about your goals, your company and your options, with no pressure and no commitment.</a:t>
             </a:r>
             <a:endParaRPr lang="en-US" sz="1013" dirty="0"/>
           </a:p>
@@ -20947,7 +20947,7 @@
                   <a:srgbClr val="333231"/>
                 </a:solidFill>
               </a:rPr>
-              <a:t>We welcome calls from owners considering a sale or strategic partnership in any of our five industries, and from the accountants, attorneys and wealth advisors who work with them. Every engagement is led by the Middle Market team and backed by Benchmark International’s global network of strategic acquirers, private equity groups, family offices and independent sponsors.</a:t>
+              <a:t>We welcome calls from owners considering a strategic sale, merger or change-of-control transaction in any of our five industries, and from the accountants, attorneys and wealth advisors who work with them. Every engagement is led by the Middle Market team and backed by Benchmark International’s global network of strategic acquirers, private equity groups, family offices and independent sponsors.</a:t>
             </a:r>
             <a:endParaRPr lang="en-US" sz="938" dirty="0"/>
           </a:p>
@@ -22062,7 +22062,7 @@
                   <a:srgbClr val="6F6A66"/>
                 </a:solidFill>
               </a:rPr>
-              <a:t>Understand the paths available, from a full sale to a strategic partnership, and what each could mean for you.</a:t>
+              <a:t>Understand the paths available, from a strategic sale to a merger or change-of-control transaction, and what each could mean for you.</a:t>
             </a:r>
             <a:endParaRPr lang="en-US" sz="765" dirty="0"/>
           </a:p>
@@ -23564,7 +23564,7 @@
                 </a:solidFill>
                 <a:latin typeface="Calibri"/>
               </a:rPr>
-              <a:t>Benchmark International's Middle Market team represents owners of privately held companies with $50 million to $500 million of total enterprise value, from majority and control transactions to strategic partnerships.</a:t>
+              <a:t>Benchmark International's Middle Market team represents owners of privately held companies with $50 million to $500 million of total enterprise value on strategic sales, mergers, and qualifying change-of-control transactions.</a:t>
             </a:r>
           </a:p>
         </p:txBody>

</xml_diff>

<commit_message>
Rename Industrial to Industrials and Tech-Enabled to Technology-Enabled; use the About FINRA answer on the Home page
</commit_message>
<xml_diff>
--- a/mid-market-practice/_build/reports/industrial-q4-2026/brief.pptx
+++ b/mid-market-practice/_build/reports/industrial-q4-2026/brief.pptx
@@ -9606,7 +9606,7 @@
                   <a:srgbClr val="8C6239"/>
                 </a:solidFill>
               </a:rPr>
-              <a:t>INDUSTRIAL  |  QUARTERLY INDUSTRY REPORT</a:t>
+              <a:t>INDUSTRIALS  |  QUARTERLY INDUSTRY REPORT</a:t>
             </a:r>
             <a:endParaRPr lang="en-US" sz="675" dirty="0"/>
           </a:p>
@@ -10050,7 +10050,7 @@
                   <a:srgbClr val="D3AE84"/>
                 </a:solidFill>
               </a:rPr>
-              <a:t>INDUSTRIAL  |  QUARTERLY INDUSTRY REPORT  |  Q4 2026</a:t>
+              <a:t>INDUSTRIALS  |  QUARTERLY INDUSTRY REPORT  |  Q4 2026</a:t>
             </a:r>
             <a:endParaRPr lang="en-US" sz="675" dirty="0"/>
           </a:p>
@@ -10682,7 +10682,7 @@
                 </a:solidFill>
                 <a:latin typeface="+mj-lt" pitchFamily="34" charset="0"/>
               </a:rPr>
-              <a:t>INDUSTRIAL</a:t>
+              <a:t>INDUSTRIALS</a:t>
             </a:r>
             <a:endParaRPr lang="en-US" sz="6150" dirty="0"/>
           </a:p>
@@ -22534,7 +22534,7 @@
                   <a:srgbClr val="8C6239"/>
                 </a:solidFill>
               </a:rPr>
-              <a:t>INDUSTRIAL COVERAGE</a:t>
+              <a:t>INDUSTRIALS COVERAGE</a:t>
             </a:r>
             <a:endParaRPr lang="en-US" sz="675" dirty="0"/>
           </a:p>
@@ -23249,7 +23249,7 @@
                 </a:solidFill>
                 <a:latin typeface="Calibri"/>
               </a:rPr>
-              <a:t>INDUSTRIAL | QUARTERLY INDUSTRY REPORT</a:t>
+              <a:t>INDUSTRIALS | QUARTERLY INDUSTRY REPORT</a:t>
             </a:r>
           </a:p>
         </p:txBody>
@@ -26354,7 +26354,7 @@
                 </a:solidFill>
                 <a:latin typeface="Calibri"/>
               </a:rPr>
-              <a:t>INDUSTRIAL COVERAGE</a:t>
+              <a:t>INDUSTRIALS COVERAGE</a:t>
             </a:r>
           </a:p>
         </p:txBody>
@@ -29240,7 +29240,7 @@
                   </a:extLst>
                 </a:hlinkClick>
               </a:rPr>
-              <a:t>Middle Market: Industrial Q4 2026 M&amp;A Industry Report</a:t>
+              <a:t>Middle Market: Industrials Q4 2026 M&amp;A Industry Report</a:t>
             </a:r>
             <a:r>
               <a:rPr lang="en-US" sz="720" dirty="0">

</xml_diff>

<commit_message>
Serial commas across the site and reports; Jason Lisiak, CFA and new bio; link email and phone in FAQ answers
</commit_message>
<xml_diff>
--- a/mid-market-practice/_build/reports/industrial-q4-2026/brief.pptx
+++ b/mid-market-practice/_build/reports/industrial-q4-2026/brief.pptx
@@ -10749,7 +10749,7 @@
                 </a:solidFill>
                 <a:latin typeface="+mj-lt" pitchFamily="34" charset="0"/>
               </a:rPr>
-              <a:t>Order books are full, the deal market has become more selective and buyers are paying the most for power, data center, aerospace and service revenue.</a:t>
+              <a:t>Order books are full, the deal market has become more selective, and buyers are paying the most for power, data center, aerospace, and service revenue.</a:t>
             </a:r>
             <a:endParaRPr lang="en-US" sz="1500" dirty="0"/>
           </a:p>
@@ -11320,7 +11320,7 @@
                   <a:srgbClr val="D9D2C8"/>
                 </a:solidFill>
               </a:rPr>
-              <a:t>Market insights, the power demand buildout and a featured engagement</a:t>
+              <a:t>Market insights, the power demand buildout, and a featured engagement</a:t>
             </a:r>
             <a:endParaRPr lang="en-US" sz="825" dirty="0"/>
           </a:p>
@@ -11711,7 +11711,7 @@
                   <a:srgbClr val="6F6A66"/>
                 </a:solidFill>
               </a:rPr>
-              <a:t>Manufacturing, distribution and transportation companies trade above every year-end multiple of the past five years.</a:t>
+              <a:t>Manufacturing, distribution, and transportation companies trade above every year-end multiple of the past five years.</a:t>
             </a:r>
             <a:endParaRPr lang="en-US" sz="938" dirty="0"/>
           </a:p>
@@ -11751,7 +11751,7 @@
                   <a:srgbClr val="6F6A66"/>
                 </a:solidFill>
               </a:rPr>
-              <a:t>Median enterprise value to trailing EBITDA for 38 listed companies at each company’s fiscal year-end from 2021 to 2025 and today; the five-year high, low and median under each chart use the year-end values. Source: </a:t>
+              <a:t>Median enterprise value to trailing EBITDA for 38 listed companies at each company’s fiscal year-end from 2021 to 2025 and today; the five-year high, low, and median under each chart use the year-end values. Source: </a:t>
             </a:r>
             <a:r>
               <a:rPr lang="en-US" sz="675" u="sng" dirty="0">
@@ -15406,7 +15406,7 @@
                   <a:srgbClr val="E8E2DA"/>
                 </a:solidFill>
               </a:rPr>
-              <a:t>Survey medians for manufacturing, wholesale and construction companies with $1 million to $25 million of EBITDA (</a:t>
+              <a:t>Survey medians for manufacturing, wholesale, and construction companies with $1 million to $25 million of EBITDA (</a:t>
             </a:r>
             <a:r>
               <a:rPr lang="en-US" sz="720" u="sng" dirty="0">
@@ -16854,7 +16854,7 @@
                   <a:srgbClr val="6F6A66"/>
                 </a:solidFill>
               </a:rPr>
-              <a:t>Shares rose at 7 of 7 manufacturing, 8 of 8 distribution, 4 of 8 building, 3 of 8 energy and 7 of 7 transport companies</a:t>
+              <a:t>Shares rose at 7 of 7 manufacturing, 8 of 8 distribution, 4 of 8 building, 3 of 8 energy, and 7 of 7 transport companies</a:t>
             </a:r>
             <a:endParaRPr lang="en-US" sz="720" dirty="0"/>
           </a:p>
@@ -17165,7 +17165,7 @@
                   <a:srgbClr val="6F6A66"/>
                 </a:solidFill>
               </a:rPr>
-              <a:t>Capital goods orders are 14% above a year ago, diesel is up 68% and the 10-year Treasury yield averaged 4.99% in September.</a:t>
+              <a:t>Capital goods orders are 14% above a year ago, diesel is up 68%, and the 10-year Treasury yield averaged 4.99% in September.</a:t>
             </a:r>
             <a:endParaRPr lang="en-US" sz="938" dirty="0"/>
           </a:p>
@@ -20225,7 +20225,7 @@
                   <a:srgbClr val="E8E2DA"/>
                 </a:solidFill>
               </a:rPr>
-              <a:t>Benchmark International's Middle Market team represents owners of privately held companies with $50 million to $500 million of total enterprise value on strategic sales, mergers, and qualifying change-of-control transactions. The first step is a confidential conversation about your goals, your company and your options, with no pressure and no commitment.</a:t>
+              <a:t>Benchmark International's Middle Market team represents owners of privately held companies with $50 million to $500 million of total enterprise value on strategic sales, mergers, and qualifying change-of-control transactions. The first step is a confidential conversation about your goals, your company, and your options, with no pressure and no commitment.</a:t>
             </a:r>
             <a:endParaRPr lang="en-US" sz="1013" dirty="0"/>
           </a:p>
@@ -20947,7 +20947,7 @@
                   <a:srgbClr val="333231"/>
                 </a:solidFill>
               </a:rPr>
-              <a:t>We welcome calls from owners considering a strategic sale, merger or change-of-control transaction in any of our five industries, and from the accountants, attorneys and wealth advisors who work with them. Every engagement is led by the Middle Market team and backed by Benchmark International’s global network of strategic acquirers, private equity groups, family offices and independent sponsors.</a:t>
+              <a:t>We welcome calls from owners considering a strategic sale, merger, or change-of-control transaction in any of our five industries, and from the accountants, attorneys, and wealth advisors who work with them. Every engagement is led by the Middle Market team and backed by Benchmark International’s global network of strategic acquirers, private equity groups, family offices, and independent sponsors.</a:t>
             </a:r>
             <a:endParaRPr lang="en-US" sz="938" dirty="0"/>
           </a:p>
@@ -22395,7 +22395,7 @@
                   <a:srgbClr val="E8E2DA"/>
                 </a:solidFill>
               </a:rPr>
-              <a:t>Global offices across the Americas, Europe and Africa</a:t>
+              <a:t>Global offices across the Americas, Europe, and Africa</a:t>
             </a:r>
             <a:endParaRPr lang="en-US" sz="705" dirty="0"/>
           </a:p>
@@ -25471,7 +25471,7 @@
                 </a:solidFill>
                 <a:latin typeface="Calibri"/>
               </a:rPr>
-              <a:t>Jason Lisiak</a:t>
+              <a:t>Jason Lisiak, CFA</a:t>
             </a:r>
           </a:p>
         </p:txBody>
@@ -26952,7 +26952,7 @@
                   <a:srgbClr val="333231"/>
                 </a:solidFill>
               </a:rPr>
-              <a:t>Benchmark International and its affiliates may have had, may currently have, or may in the future have business relationships with companies named in this material, with potential parties to a transaction and their related persons, or with their competitors, customers or suppliers. When Benchmark International is engaged to provide advisory services in a transaction, it acts only for its client in connection with that transaction.</a:t>
+              <a:t>Benchmark International and its affiliates may have had, may currently have, or may in the future have business relationships with companies named in this material, with potential parties to a transaction and their related persons, or with their competitors, customers, or suppliers. When Benchmark International is engaged to provide advisory services in a transaction, it acts only for its client in connection with that transaction.</a:t>
             </a:r>
             <a:endParaRPr lang="en-US" sz="855" dirty="0"/>
           </a:p>
@@ -27014,7 +27014,7 @@
                   <a:srgbClr val="333231"/>
                 </a:solidFill>
               </a:rPr>
-              <a:t>This material does not contain all the information needed to assess any transaction. You must conduct your own investigations and analyses. Benchmark International does not provide valuations, appraisals or fairness opinions, and does not provide accounting, tax, investment, regulatory or legal advice to anyone. This material is for discussion and informational purposes only and is not a recommendation, offer or solicitation for the purchase or sale of any security or an invitation or inducement to engage in any transaction or investment activity. Benchmark International obtained the information in this material from public filings, company announcements, published reports and other third-party sources, together with its own transaction experience. Benchmark International has not independently verified such information, the information is current only as of the date stated, and no obligation is undertaken to provide updated or additional information. Transaction values, multiples and other figures are as publicly reported, and the price of any private company depends on that business. No representation or warranty, expressed or implied, is made in relation to the fairness, accuracy, correctness or completeness of the information, opinions or conclusions expressed herein. All forward-looking statements herein involve assumptions and elements of subjective judgment and analysis and are not facts. Past transactions are not indicative of future results, and nothing in this material guarantees future results or performance.</a:t>
+              <a:t>This material does not contain all the information needed to assess any transaction. You must conduct your own investigations and analyses. Benchmark International does not provide valuations, appraisals, or fairness opinions, and does not provide accounting, tax, investment, regulatory, or legal advice to anyone. This material is for discussion and informational purposes only and is not a recommendation, offer, or solicitation for the purchase or sale of any security or an invitation or inducement to engage in any transaction or investment activity. Benchmark International obtained the information in this material from public filings, company announcements, published reports, and other third-party sources, together with its own transaction experience. Benchmark International has not independently verified such information, the information is current only as of the date stated, and no obligation is undertaken to provide updated or additional information. Transaction values, multiples, and other figures are as publicly reported, and the price of any private company depends on that business. No representation or warranty, expressed or implied, is made in relation to the fairness, accuracy, correctness, or completeness of the information, opinions, or conclusions expressed herein. All forward-looking statements herein involve assumptions and elements of subjective judgment and analysis and are not facts. Past transactions are not indicative of future results, and nothing in this material guarantees future results or performance.</a:t>
             </a:r>
             <a:endParaRPr lang="en-US" sz="855" dirty="0"/>
           </a:p>
@@ -27034,7 +27034,7 @@
                   <a:srgbClr val="333231"/>
                 </a:solidFill>
               </a:rPr>
-              <a:t>Company names, logos and trademarks referenced in this material are the property of their respective owners and are used for identification only. Their use does not imply any affiliation with or endorsement by those owners.</a:t>
+              <a:t>Company names, logos, and trademarks referenced in this material are the property of their respective owners and are used for identification only. Their use does not imply any affiliation with or endorsement by those owners.</a:t>
             </a:r>
             <a:endParaRPr lang="en-US" sz="855" dirty="0"/>
           </a:p>
@@ -29746,7 +29746,7 @@
                   <a:srgbClr val="333231"/>
                 </a:solidFill>
               </a:rPr>
-              <a:t>Listed-company figures are from StockAnalysis and use reported results. Economic series are from FRED. Benchmark International figures are from the firm’s transaction records as of October 1, 2026. Subscription and registration sources that would add depth, including GF Data, PitchBook and S&amp;P Capital IQ, are listed in a separate one-page companion.</a:t>
+              <a:t>Listed-company figures are from StockAnalysis and use reported results. Economic series are from FRED. Benchmark International figures are from the firm’s transaction records as of October 1, 2026. Subscription and registration sources that would add depth, including GF Data, PitchBook, and S&amp;P Capital IQ, are listed in a separate one-page companion.</a:t>
             </a:r>
             <a:endParaRPr lang="en-US" sz="720" dirty="0"/>
           </a:p>
@@ -30201,7 +30201,7 @@
                 </a:solidFill>
                 <a:latin typeface="+mn-lt"/>
               </a:rPr>
-              <a:t>APi Group is working toward 60% of revenue from inspection and service. Buyers pay more for service, repair and aftermarket revenue when it is reported apart from projects, with its renewal history.</a:t>
+              <a:t>APi Group is working toward 60% of revenue from inspection and service. Buyers pay more for service, repair, and aftermarket revenue when it is reported apart from projects, with its renewal history.</a:t>
             </a:r>
           </a:p>
           <a:p>
@@ -30346,7 +30346,7 @@
                   <a:srgbClr val="6F6A66"/>
                 </a:solidFill>
               </a:rPr>
-              <a:t>Demand is broad, buyers are organized around platforms and financing became more expensive in September.</a:t>
+              <a:t>Demand is broad, buyers are organized around platforms, and financing became more expensive in September.</a:t>
             </a:r>
             <a:endParaRPr lang="en-US" sz="938" dirty="0"/>
           </a:p>
@@ -30539,7 +30539,7 @@
                 </a:solidFill>
                 <a:latin typeface="+mj-lt" pitchFamily="34" charset="0"/>
               </a:rPr>
-              <a:t>Strategic acquirers and private equity platforms are still buying machining, distribution, contracting, environmental and logistics capacity that already exists.</a:t>
+              <a:t>Strategic acquirers and private equity platforms are still buying machining, distribution, contracting, environmental, and logistics capacity that already exists.</a:t>
             </a:r>
             <a:endParaRPr lang="en-US" sz="1238" dirty="0"/>
           </a:p>
@@ -30578,7 +30578,7 @@
                   <a:srgbClr val="E8E2DA"/>
                 </a:solidFill>
               </a:rPr>
-              <a:t>They are paying the most for companies tied to power, data centers, aerospace and service work that codes and regulations require.</a:t>
+              <a:t>They are paying the most for companies tied to power, data centers, aerospace, and service work that codes and regulations require.</a:t>
             </a:r>
             <a:endParaRPr lang="en-US" sz="825" dirty="0"/>
           </a:p>
@@ -31686,7 +31686,7 @@
                   <a:srgbClr val="333231"/>
                 </a:solidFill>
               </a:rPr>
-              <a:t>). Buyers pay more for service, repair, inspection and aftermarket parts revenue when an owner reports it separately from project and product sales, with the renewal history behind it.</a:t>
+              <a:t>). Buyers pay more for service, repair, inspection, and aftermarket parts revenue when an owner reports it separately from project and product sales, with the renewal history behind it.</a:t>
             </a:r>
             <a:endParaRPr lang="en-US" sz="810" dirty="0"/>
           </a:p>
@@ -33078,7 +33078,7 @@
                   <a:srgbClr val="333231"/>
                 </a:solidFill>
               </a:rPr>
-              <a:t>), and contractors with power, utility and data center customers have kept growing in a year when refiners deferred turnaround work to 2027.</a:t>
+              <a:t>), and contractors with power, utility, and data center customers have kept growing in a year when refiners deferred turnaround work to 2027.</a:t>
             </a:r>
             <a:endParaRPr lang="en-US" sz="795" dirty="0"/>
           </a:p>
@@ -34814,7 +34814,7 @@
                   <a:srgbClr val="E8E2DA"/>
                 </a:solidFill>
               </a:rPr>
-              <a:t>Cross-border freight, customs brokerage and warehousing</a:t>
+              <a:t>Cross-border freight, customs brokerage, and warehousing</a:t>
             </a:r>
             <a:endParaRPr lang="en-US" sz="788" dirty="0"/>
           </a:p>
@@ -34971,7 +34971,7 @@
                   <a:srgbClr val="333231"/>
                 </a:solidFill>
               </a:rPr>
-              <a:t>Founded in 1983 in Laredo, Texas, The Carmi Companies is a single-source logistics group that coordinates land, air and ocean freight and provides customs brokerage, warehousing and transloading.</a:t>
+              <a:t>Founded in 1983 in Laredo, Texas, The Carmi Companies is a single-source logistics group that coordinates land, air, and ocean freight and provides customs brokerage, warehousing, and transloading.</a:t>
             </a:r>
             <a:endParaRPr lang="en-US" sz="885" dirty="0"/>
           </a:p>
@@ -37882,7 +37882,7 @@
                             <a:srgbClr val="333231"/>
                           </a:solidFill>
                         </a:rPr>
-                        <a:t>Precinmac acquired Advance Mfg. Co. of Westfield, Massachusetts, family-owned since 1961, which supplies machined components, fabrications and Nadcap coating for defense and aerospace customers (</a:t>
+                        <a:t>Precinmac acquired Advance Mfg. Co. of Westfield, Massachusetts, family-owned since 1961, which supplies machined components, fabrications, and Nadcap coating for defense and aerospace customers (</a:t>
                       </a:r>
                       <a:r>
                         <a:rPr lang="en-US" sz="810" u="sng" dirty="0">
@@ -38696,7 +38696,7 @@
                             <a:srgbClr val="333231"/>
                           </a:solidFill>
                         </a:rPr>
-                        <a:t>Limbach acquired 1901 Inc., a mechanical, electrical and plumbing contractor in Madison, Wisconsin, that it expects to contribute about $140 million of revenue, for $63 million plus an earn-out of up to $6 million (</a:t>
+                        <a:t>Limbach acquired 1901 Inc., a mechanical, electrical, and plumbing contractor in Madison, Wisconsin, that it expects to contribute about $140 million of revenue, for $63 million plus an earn-out of up to $6 million (</a:t>
                       </a:r>
                       <a:r>
                         <a:rPr lang="en-US" sz="810" u="sng" dirty="0">
@@ -38954,7 +38954,7 @@
                   <a:srgbClr val="6F6A66"/>
                 </a:solidFill>
               </a:rPr>
-              <a:t>Buyers in power, environmental services and logistics paid for technicians, permits, equipment supply and border capability they did not already have.</a:t>
+              <a:t>Buyers in power, environmental services, and logistics paid for technicians, permits, equipment supply, and border capability they did not already have.</a:t>
             </a:r>
             <a:endParaRPr lang="en-US" sz="938" dirty="0"/>
           </a:p>
@@ -39368,7 +39368,7 @@
                             <a:srgbClr val="333231"/>
                           </a:solidFill>
                         </a:rPr>
-                        <a:t>Bay Crane acquired Clark Rigging &amp; Rental, a crane rental, rigging and heavy-haul company in upstate New York that had been family-owned since 1954 (</a:t>
+                        <a:t>Bay Crane acquired Clark Rigging &amp; Rental, a crane rental, rigging, and heavy-haul company in upstate New York that had been family-owned since 1954 (</a:t>
                       </a:r>
                       <a:r>
                         <a:rPr lang="en-US" sz="810" u="sng" dirty="0">
@@ -39437,7 +39437,7 @@
                             <a:srgbClr val="333231"/>
                           </a:solidFill>
                         </a:rPr>
-                        <a:t>Crane, rigging and pump rental each have an active acquirer buying family-owned regional operators.</a:t>
+                        <a:t>Crane, rigging, and pump rental each have an active acquirer buying family-owned regional operators.</a:t>
                       </a:r>
                       <a:endParaRPr lang="en-US" sz="1200" dirty="0"/>
                     </a:p>
@@ -39627,7 +39627,7 @@
                             <a:srgbClr val="333231"/>
                           </a:solidFill>
                         </a:rPr>
-                        <a:t>Clean Harbors agreed to buy EnviroServe, a remediation, industrial cleaning and emergency response company with 40 locations, from One Rock Capital Partners for $470 million (</a:t>
+                        <a:t>Clean Harbors agreed to buy EnviroServe, a remediation, industrial cleaning, and emergency response company with 40 locations, from One Rock Capital Partners for $470 million (</a:t>
                       </a:r>
                       <a:r>
                         <a:rPr lang="en-US" sz="810" u="sng" dirty="0">
@@ -39923,7 +39923,7 @@
                             <a:srgbClr val="333231"/>
                           </a:solidFill>
                         </a:rPr>
-                        <a:t>Mission Critical Group acquired CORE Transformers, a founder-led supplier of new, made-to-order and remanufactured power transformers (</a:t>
+                        <a:t>Mission Critical Group acquired CORE Transformers, a founder-led supplier of new, made-to-order, and remanufactured power transformers (</a:t>
                       </a:r>
                       <a:r>
                         <a:rPr lang="en-US" sz="810" u="sng" dirty="0">
@@ -40182,7 +40182,7 @@
                             <a:srgbClr val="333231"/>
                           </a:solidFill>
                         </a:rPr>
-                        <a:t>C.H. Robinson agreed on October 5 to acquire RXO, a truck brokerage, managed transportation and last-mile provider, at an implied value of $5.8 billion, a 29% premium to RXO’s last closing price (</a:t>
+                        <a:t>C.H. Robinson agreed on October 5 to acquire RXO, a truck brokerage, managed transportation, and last-mile provider, at an implied value of $5.8 billion, a 29% premium to RXO’s last closing price (</a:t>
                       </a:r>
                       <a:r>
                         <a:rPr lang="en-US" sz="810" u="sng" dirty="0">
@@ -42651,7 +42651,7 @@
                   <a:srgbClr val="333231"/>
                 </a:solidFill>
               </a:rPr>
-              <a:t>Sales, repair and maintenance of industrial vacuum pumps</a:t>
+              <a:t>Sales, repair, and maintenance of industrial vacuum pumps</a:t>
             </a:r>
             <a:endParaRPr lang="en-US" sz="690" dirty="0"/>
           </a:p>
@@ -42933,7 +42933,7 @@
                   <a:srgbClr val="333231"/>
                 </a:solidFill>
               </a:rPr>
-              <a:t>Industrial maintenance, capital projects and turnarounds</a:t>
+              <a:t>Industrial maintenance, capital projects, and turnarounds</a:t>
             </a:r>
             <a:endParaRPr lang="en-US" sz="690" dirty="0"/>
           </a:p>

</xml_diff>